<commit_message>
Synchronize presentation and figures with canonical benchmarks, remove portal disclaimer, and apply reviewer refinements
</commit_message>
<xml_diff>
--- a/LUNA-CORR_SIH2026_Presentation.pptx
+++ b/LUNA-CORR_SIH2026_Presentation.pptx
@@ -3696,7 +3696,7 @@
         </p:nvSpPr>
         <p:spPr>
           <a:xfrm>
-            <a:off x="274320" y="5897880"/>
+            <a:off x="274320" y="6080760"/>
             <a:ext cx="3383280" cy="320040"/>
           </a:xfrm>
           <a:prstGeom prst="rect">
@@ -3725,42 +3725,7 @@
       </p:sp>
       <p:sp>
         <p:nvSpPr>
-          <p:cNvPr id="19" name="TextBox 18"/>
-          <p:cNvSpPr txBox="1"/>
-          <p:nvPr/>
-        </p:nvSpPr>
-        <p:spPr>
-          <a:xfrm>
-            <a:off x="274320" y="6263640"/>
-            <a:ext cx="3383280" cy="182880"/>
-          </a:xfrm>
-          <a:prstGeom prst="rect">
-            <a:avLst/>
-          </a:prstGeom>
-          <a:noFill/>
-        </p:spPr>
-        <p:txBody>
-          <a:bodyPr wrap="square">
-            <a:spAutoFit/>
-          </a:bodyPr>
-          <a:lstStyle/>
-          <a:p>
-            <a:pPr algn="l"/>
-            <a:r>
-              <a:rPr sz="700" b="0" i="1">
-                <a:solidFill>
-                  <a:srgbClr val="6B7E88"/>
-                </a:solidFill>
-                <a:latin typeface="Calibri"/>
-              </a:rPr>
-              <a:t>Contact through official SIH 2026 portal only.</a:t>
-            </a:r>
-          </a:p>
-        </p:txBody>
-      </p:sp>
-      <p:sp>
-        <p:nvSpPr>
-          <p:cNvPr id="20" name="Rectangle 19"/>
+          <p:cNvPr id="19" name="Rectangle 18"/>
           <p:cNvSpPr/>
           <p:nvPr/>
         </p:nvSpPr>
@@ -3803,7 +3768,7 @@
       </p:sp>
       <p:sp>
         <p:nvSpPr>
-          <p:cNvPr id="21" name="TextBox 20"/>
+          <p:cNvPr id="20" name="TextBox 19"/>
           <p:cNvSpPr txBox="1"/>
           <p:nvPr/>
         </p:nvSpPr>
@@ -3838,7 +3803,7 @@
       </p:sp>
       <p:sp>
         <p:nvSpPr>
-          <p:cNvPr id="22" name="TextBox 21"/>
+          <p:cNvPr id="21" name="TextBox 20"/>
           <p:cNvSpPr txBox="1"/>
           <p:nvPr/>
         </p:nvSpPr>
@@ -3873,7 +3838,7 @@
       </p:sp>
       <p:pic>
         <p:nvPicPr>
-          <p:cNvPr id="23" name="Picture 22" descr="fig1_title_hero.png"/>
+          <p:cNvPr id="22" name="Picture 21" descr="fig1_title_hero.png"/>
           <p:cNvPicPr>
             <a:picLocks noChangeAspect="1"/>
           </p:cNvPicPr>
@@ -3897,7 +3862,7 @@
       </p:pic>
       <p:sp>
         <p:nvSpPr>
-          <p:cNvPr id="24" name="Rectangle 23"/>
+          <p:cNvPr id="23" name="Rectangle 22"/>
           <p:cNvSpPr/>
           <p:nvPr/>
         </p:nvSpPr>
@@ -3942,7 +3907,7 @@
       </p:sp>
       <p:sp>
         <p:nvSpPr>
-          <p:cNvPr id="25" name="TextBox 24"/>
+          <p:cNvPr id="24" name="TextBox 23"/>
           <p:cNvSpPr txBox="1"/>
           <p:nvPr/>
         </p:nvSpPr>
@@ -3977,7 +3942,7 @@
       </p:sp>
       <p:sp>
         <p:nvSpPr>
-          <p:cNvPr id="26" name="TextBox 25"/>
+          <p:cNvPr id="25" name="TextBox 24"/>
           <p:cNvSpPr txBox="1"/>
           <p:nvPr/>
         </p:nvSpPr>
@@ -4005,15 +3970,15 @@
                 </a:solidFill>
                 <a:latin typeface="Calibri"/>
               </a:rPr>
-              <a:t>• OHRC Cross-Orbit: 822 inliers (99.2% ratio)  ·  Held-out RMSE: 0.68 px (TPS Warping Accepted)
-• TMC-2 Stereo: Held-out RMSE reduced 1.52 px → 0.84 px (44.7% error reduction, N=150 fixed set)</a:t>
-            </a:r>
-          </a:p>
-        </p:txBody>
-      </p:sp>
-      <p:sp>
-        <p:nvSpPr>
-          <p:cNvPr id="27" name="Rectangle 26"/>
+              <a:t>• OHRC Cross-Orbit: 822 inliers (99.2% ratio)  ·  Held-out RMSE: 0.779 px (TPS Warping Accepted)
+• TMC-2 Stereo: Held-out RMSE reduced 1.52 px → 0.84 px (44.7% error reduction vs Stage-3 baseline, N=150 fixed set)</a:t>
+            </a:r>
+          </a:p>
+        </p:txBody>
+      </p:sp>
+      <p:sp>
+        <p:nvSpPr>
+          <p:cNvPr id="26" name="Rectangle 25"/>
           <p:cNvSpPr/>
           <p:nvPr/>
         </p:nvSpPr>
@@ -4058,7 +4023,7 @@
       </p:sp>
       <p:sp>
         <p:nvSpPr>
-          <p:cNvPr id="28" name="Rectangle 27"/>
+          <p:cNvPr id="27" name="Rectangle 26"/>
           <p:cNvSpPr/>
           <p:nvPr/>
         </p:nvSpPr>
@@ -4101,7 +4066,7 @@
       </p:sp>
       <p:sp>
         <p:nvSpPr>
-          <p:cNvPr id="29" name="TextBox 28"/>
+          <p:cNvPr id="28" name="TextBox 27"/>
           <p:cNvSpPr txBox="1"/>
           <p:nvPr/>
         </p:nvSpPr>
@@ -4136,7 +4101,7 @@
       </p:sp>
       <p:sp>
         <p:nvSpPr>
-          <p:cNvPr id="30" name="TextBox 29"/>
+          <p:cNvPr id="29" name="TextBox 28"/>
           <p:cNvSpPr txBox="1"/>
           <p:nvPr/>
         </p:nvSpPr>
@@ -4164,14 +4129,14 @@
                 </a:solidFill>
                 <a:latin typeface="Calibri"/>
               </a:rPr>
-              <a:t>Sun azimuth/elevation changes invert slope brightness and cast moving shadows. Direct optical cross-correlation collapses.</a:t>
-            </a:r>
-          </a:p>
-        </p:txBody>
-      </p:sp>
-      <p:sp>
-        <p:nvSpPr>
-          <p:cNvPr id="31" name="Rectangle 30"/>
+              <a:t>Sun azimuth/elevation changes invert slope brightness and cast moving shadows. Direct feature matching collapses.</a:t>
+            </a:r>
+          </a:p>
+        </p:txBody>
+      </p:sp>
+      <p:sp>
+        <p:nvSpPr>
+          <p:cNvPr id="30" name="Rectangle 29"/>
           <p:cNvSpPr/>
           <p:nvPr/>
         </p:nvSpPr>
@@ -4216,7 +4181,7 @@
       </p:sp>
       <p:sp>
         <p:nvSpPr>
-          <p:cNvPr id="32" name="Rectangle 31"/>
+          <p:cNvPr id="31" name="Rectangle 30"/>
           <p:cNvSpPr/>
           <p:nvPr/>
         </p:nvSpPr>
@@ -4259,7 +4224,7 @@
       </p:sp>
       <p:sp>
         <p:nvSpPr>
-          <p:cNvPr id="33" name="TextBox 32"/>
+          <p:cNvPr id="32" name="TextBox 31"/>
           <p:cNvSpPr txBox="1"/>
           <p:nvPr/>
         </p:nvSpPr>
@@ -4294,7 +4259,7 @@
       </p:sp>
       <p:sp>
         <p:nvSpPr>
-          <p:cNvPr id="34" name="TextBox 33"/>
+          <p:cNvPr id="33" name="TextBox 32"/>
           <p:cNvSpPr txBox="1"/>
           <p:nvPr/>
         </p:nvSpPr>
@@ -4322,14 +4287,14 @@
                 </a:solidFill>
                 <a:latin typeface="Calibri"/>
               </a:rPr>
-              <a:t>3D crater topography creates localized relief parallax that violates planar homography. Requires adaptive elastic deformation.</a:t>
-            </a:r>
-          </a:p>
-        </p:txBody>
-      </p:sp>
-      <p:sp>
-        <p:nvSpPr>
-          <p:cNvPr id="35" name="Rectangle 34"/>
+              <a:t>3D crater topography creates localized relief parallax that violates planar homography. Residual relief may require adaptive local deformation.</a:t>
+            </a:r>
+          </a:p>
+        </p:txBody>
+      </p:sp>
+      <p:sp>
+        <p:nvSpPr>
+          <p:cNvPr id="34" name="Rectangle 33"/>
           <p:cNvSpPr/>
           <p:nvPr/>
         </p:nvSpPr>
@@ -4374,7 +4339,7 @@
       </p:sp>
       <p:sp>
         <p:nvSpPr>
-          <p:cNvPr id="36" name="Rectangle 35"/>
+          <p:cNvPr id="35" name="Rectangle 34"/>
           <p:cNvSpPr/>
           <p:nvPr/>
         </p:nvSpPr>
@@ -4417,7 +4382,7 @@
       </p:sp>
       <p:sp>
         <p:nvSpPr>
-          <p:cNvPr id="37" name="TextBox 36"/>
+          <p:cNvPr id="36" name="TextBox 35"/>
           <p:cNvSpPr txBox="1"/>
           <p:nvPr/>
         </p:nvSpPr>
@@ -4452,7 +4417,7 @@
       </p:sp>
       <p:sp>
         <p:nvSpPr>
-          <p:cNvPr id="38" name="TextBox 37"/>
+          <p:cNvPr id="37" name="TextBox 36"/>
           <p:cNvSpPr txBox="1"/>
           <p:nvPr/>
         </p:nvSpPr>
@@ -4487,7 +4452,7 @@
       </p:sp>
       <p:sp>
         <p:nvSpPr>
-          <p:cNvPr id="39" name="Rectangle 38"/>
+          <p:cNvPr id="38" name="Rectangle 37"/>
           <p:cNvSpPr/>
           <p:nvPr/>
         </p:nvSpPr>
@@ -4530,7 +4495,7 @@
       </p:sp>
       <p:sp>
         <p:nvSpPr>
-          <p:cNvPr id="40" name="TextBox 39"/>
+          <p:cNvPr id="39" name="TextBox 38"/>
           <p:cNvSpPr txBox="1"/>
           <p:nvPr/>
         </p:nvSpPr>
@@ -4565,7 +4530,7 @@
       </p:sp>
       <p:sp>
         <p:nvSpPr>
-          <p:cNvPr id="41" name="TextBox 40"/>
+          <p:cNvPr id="40" name="TextBox 39"/>
           <p:cNvSpPr txBox="1"/>
           <p:nvPr/>
         </p:nvSpPr>
@@ -4600,7 +4565,7 @@
       </p:sp>
       <p:sp>
         <p:nvSpPr>
-          <p:cNvPr id="42" name="Rectangle 41"/>
+          <p:cNvPr id="41" name="Rectangle 40"/>
           <p:cNvSpPr/>
           <p:nvPr/>
         </p:nvSpPr>
@@ -4645,7 +4610,7 @@
       </p:sp>
       <p:sp>
         <p:nvSpPr>
-          <p:cNvPr id="43" name="TextBox 42"/>
+          <p:cNvPr id="42" name="TextBox 41"/>
           <p:cNvSpPr txBox="1"/>
           <p:nvPr/>
         </p:nvSpPr>
@@ -4680,7 +4645,7 @@
       </p:sp>
       <p:sp>
         <p:nvSpPr>
-          <p:cNvPr id="44" name="Rectangle 43"/>
+          <p:cNvPr id="43" name="Rectangle 42"/>
           <p:cNvSpPr/>
           <p:nvPr/>
         </p:nvSpPr>
@@ -4723,7 +4688,7 @@
       </p:sp>
       <p:sp>
         <p:nvSpPr>
-          <p:cNvPr id="45" name="TextBox 44"/>
+          <p:cNvPr id="44" name="TextBox 43"/>
           <p:cNvSpPr txBox="1"/>
           <p:nvPr/>
         </p:nvSpPr>
@@ -5115,7 +5080,7 @@
                 </a:solidFill>
                 <a:latin typeface="Calibri"/>
               </a:rPr>
-              <a:t>TAKEAWAY:  Same surface. Same geometry. Different sun. Appearance changes completely — direct matching fails without physics conditioning.</a:t>
+              <a:t>TAKEAWAY:  Same surface. Same geometry. Different sun. Appearance changes dramatically — direct feature matching collapses without physics conditioning.</a:t>
             </a:r>
           </a:p>
         </p:txBody>
@@ -5563,7 +5528,7 @@
                 </a:solidFill>
                 <a:latin typeface="Calibri"/>
               </a:rPr>
-              <a:t>▸  MAGSAC++ &amp; Spatial Quotas: Rejects shadow outliers and promotes uniform spatial coverage.</a:t>
+              <a:t>▸  MAGSAC++ &amp; Spatial Quotas: Rejects geometrically inconsistent matches; promotes uniform coverage.</a:t>
             </a:r>
           </a:p>
         </p:txBody>
@@ -5633,7 +5598,7 @@
                 </a:solidFill>
                 <a:latin typeface="Calibri"/>
               </a:rPr>
-              <a:t>▸  Fail-Safe Abstention: Reason-coded rejection prevents corrupting downstream map products.</a:t>
+              <a:t>▸  Fail-Safe Abstention: Reason-coded rejection prevents acceptance of low-confidence registrations.</a:t>
             </a:r>
           </a:p>
         </p:txBody>
@@ -7447,7 +7412,7 @@
                 </a:solidFill>
                 <a:latin typeface="Calibri"/>
               </a:rPr>
-              <a:t>S_relief &gt; 0.20 triggers adaptive TPS warp</a:t>
+              <a:t>Relief-coherent residual + P95 threshold → TPS</a:t>
             </a:r>
           </a:p>
         </p:txBody>
@@ -7705,7 +7670,7 @@
         <p:spPr>
           <a:xfrm>
             <a:off x="457200" y="2889504"/>
-            <a:ext cx="6126480" cy="2286000"/>
+            <a:ext cx="6126480" cy="2423160"/>
           </a:xfrm>
           <a:prstGeom prst="rect">
             <a:avLst/>
@@ -7715,6 +7680,121 @@
       <p:sp>
         <p:nvSpPr>
           <p:cNvPr id="47" name="Rectangle 46"/>
+          <p:cNvSpPr/>
+          <p:nvPr/>
+        </p:nvSpPr>
+        <p:spPr>
+          <a:xfrm>
+            <a:off x="457200" y="5358384"/>
+            <a:ext cx="6126480" cy="457200"/>
+          </a:xfrm>
+          <a:prstGeom prst="rect">
+            <a:avLst/>
+          </a:prstGeom>
+          <a:solidFill>
+            <a:srgbClr val="EAF6F0"/>
+          </a:solidFill>
+          <a:ln w="7620">
+            <a:solidFill>
+              <a:srgbClr val="2E9E6E"/>
+            </a:solidFill>
+          </a:ln>
+        </p:spPr>
+        <p:style>
+          <a:lnRef idx="1">
+            <a:schemeClr val="accent1"/>
+          </a:lnRef>
+          <a:fillRef idx="3">
+            <a:schemeClr val="accent1"/>
+          </a:fillRef>
+          <a:effectRef idx="2">
+            <a:schemeClr val="accent1"/>
+          </a:effectRef>
+          <a:fontRef idx="minor">
+            <a:schemeClr val="lt1"/>
+          </a:fontRef>
+        </p:style>
+        <p:txBody>
+          <a:bodyPr rtlCol="0" anchor="ctr"/>
+          <a:lstStyle/>
+          <a:p>
+            <a:pPr algn="ctr"/>
+          </a:p>
+        </p:txBody>
+      </p:sp>
+      <p:sp>
+        <p:nvSpPr>
+          <p:cNvPr id="48" name="TextBox 47"/>
+          <p:cNvSpPr txBox="1"/>
+          <p:nvPr/>
+        </p:nvSpPr>
+        <p:spPr>
+          <a:xfrm>
+            <a:off x="548640" y="5394960"/>
+            <a:ext cx="5943600" cy="182880"/>
+          </a:xfrm>
+          <a:prstGeom prst="rect">
+            <a:avLst/>
+          </a:prstGeom>
+          <a:noFill/>
+        </p:spPr>
+        <p:txBody>
+          <a:bodyPr wrap="square">
+            <a:spAutoFit/>
+          </a:bodyPr>
+          <a:lstStyle/>
+          <a:p>
+            <a:pPr algn="l"/>
+            <a:r>
+              <a:rPr sz="850" b="1" i="0">
+                <a:solidFill>
+                  <a:srgbClr val="2E9E6E"/>
+                </a:solidFill>
+                <a:latin typeface="Calibri"/>
+              </a:rPr>
+              <a:t>TMC-2 STEREO — 710 INLIERS — ACCEPTED</a:t>
+            </a:r>
+          </a:p>
+        </p:txBody>
+      </p:sp>
+      <p:sp>
+        <p:nvSpPr>
+          <p:cNvPr id="49" name="TextBox 48"/>
+          <p:cNvSpPr txBox="1"/>
+          <p:nvPr/>
+        </p:nvSpPr>
+        <p:spPr>
+          <a:xfrm>
+            <a:off x="548640" y="5577840"/>
+            <a:ext cx="5943600" cy="201168"/>
+          </a:xfrm>
+          <a:prstGeom prst="rect">
+            <a:avLst/>
+          </a:prstGeom>
+          <a:noFill/>
+        </p:spPr>
+        <p:txBody>
+          <a:bodyPr wrap="square">
+            <a:spAutoFit/>
+          </a:bodyPr>
+          <a:lstStyle/>
+          <a:p>
+            <a:pPr algn="l"/>
+            <a:r>
+              <a:rPr sz="800" b="0" i="0">
+                <a:solidFill>
+                  <a:srgbClr val="1A2B35"/>
+                </a:solidFill>
+                <a:latin typeface="Calibri"/>
+              </a:rPr>
+              <a:t>Held-out RMSE: 1.52 → 0.84 px (44.7% error reduction vs Stage-3 baseline) · Continuous crater rims across seams</a:t>
+            </a:r>
+          </a:p>
+        </p:txBody>
+      </p:sp>
+      <p:sp>
+        <p:nvSpPr>
+          <p:cNvPr id="50" name="Rectangle 49"/>
           <p:cNvSpPr/>
           <p:nvPr/>
         </p:nvSpPr>
@@ -7757,7 +7837,7 @@
       </p:sp>
       <p:sp>
         <p:nvSpPr>
-          <p:cNvPr id="48" name="TextBox 47"/>
+          <p:cNvPr id="51" name="TextBox 50"/>
           <p:cNvSpPr txBox="1"/>
           <p:nvPr/>
         </p:nvSpPr>
@@ -7792,7 +7872,7 @@
       </p:sp>
       <p:sp>
         <p:nvSpPr>
-          <p:cNvPr id="49" name="Rectangle 48"/>
+          <p:cNvPr id="52" name="Rectangle 51"/>
           <p:cNvSpPr/>
           <p:nvPr/>
         </p:nvSpPr>
@@ -7837,7 +7917,7 @@
       </p:sp>
       <p:sp>
         <p:nvSpPr>
-          <p:cNvPr id="50" name="TextBox 49"/>
+          <p:cNvPr id="53" name="TextBox 52"/>
           <p:cNvSpPr txBox="1"/>
           <p:nvPr/>
         </p:nvSpPr>
@@ -7872,7 +7952,7 @@
       </p:sp>
       <p:sp>
         <p:nvSpPr>
-          <p:cNvPr id="51" name="TextBox 50"/>
+          <p:cNvPr id="54" name="TextBox 53"/>
           <p:cNvSpPr txBox="1"/>
           <p:nvPr/>
         </p:nvSpPr>
@@ -7907,7 +7987,7 @@
       </p:sp>
       <p:sp>
         <p:nvSpPr>
-          <p:cNvPr id="52" name="Rectangle 51"/>
+          <p:cNvPr id="55" name="Rectangle 54"/>
           <p:cNvSpPr/>
           <p:nvPr/>
         </p:nvSpPr>
@@ -7952,7 +8032,7 @@
       </p:sp>
       <p:sp>
         <p:nvSpPr>
-          <p:cNvPr id="53" name="TextBox 52"/>
+          <p:cNvPr id="56" name="TextBox 55"/>
           <p:cNvSpPr txBox="1"/>
           <p:nvPr/>
         </p:nvSpPr>
@@ -7987,7 +8067,7 @@
       </p:sp>
       <p:sp>
         <p:nvSpPr>
-          <p:cNvPr id="54" name="TextBox 53"/>
+          <p:cNvPr id="57" name="TextBox 56"/>
           <p:cNvSpPr txBox="1"/>
           <p:nvPr/>
         </p:nvSpPr>
@@ -8022,7 +8102,7 @@
       </p:sp>
       <p:sp>
         <p:nvSpPr>
-          <p:cNvPr id="55" name="Rectangle 54"/>
+          <p:cNvPr id="58" name="Rectangle 57"/>
           <p:cNvSpPr/>
           <p:nvPr/>
         </p:nvSpPr>
@@ -8067,7 +8147,7 @@
       </p:sp>
       <p:sp>
         <p:nvSpPr>
-          <p:cNvPr id="56" name="TextBox 55"/>
+          <p:cNvPr id="59" name="TextBox 58"/>
           <p:cNvSpPr txBox="1"/>
           <p:nvPr/>
         </p:nvSpPr>
@@ -8102,7 +8182,7 @@
       </p:sp>
       <p:sp>
         <p:nvSpPr>
-          <p:cNvPr id="57" name="TextBox 56"/>
+          <p:cNvPr id="60" name="TextBox 59"/>
           <p:cNvSpPr txBox="1"/>
           <p:nvPr/>
         </p:nvSpPr>
@@ -8137,7 +8217,7 @@
       </p:sp>
       <p:sp>
         <p:nvSpPr>
-          <p:cNvPr id="58" name="Rectangle 57"/>
+          <p:cNvPr id="61" name="Rectangle 60"/>
           <p:cNvSpPr/>
           <p:nvPr/>
         </p:nvSpPr>
@@ -8182,7 +8262,7 @@
       </p:sp>
       <p:sp>
         <p:nvSpPr>
-          <p:cNvPr id="59" name="TextBox 58"/>
+          <p:cNvPr id="62" name="TextBox 61"/>
           <p:cNvSpPr txBox="1"/>
           <p:nvPr/>
         </p:nvSpPr>
@@ -8217,7 +8297,7 @@
       </p:sp>
       <p:sp>
         <p:nvSpPr>
-          <p:cNvPr id="60" name="TextBox 59"/>
+          <p:cNvPr id="63" name="TextBox 62"/>
           <p:cNvSpPr txBox="1"/>
           <p:nvPr/>
         </p:nvSpPr>
@@ -8252,7 +8332,7 @@
       </p:sp>
       <p:sp>
         <p:nvSpPr>
-          <p:cNvPr id="61" name="Rectangle 60"/>
+          <p:cNvPr id="64" name="Rectangle 63"/>
           <p:cNvSpPr/>
           <p:nvPr/>
         </p:nvSpPr>
@@ -8295,7 +8375,7 @@
       </p:sp>
       <p:sp>
         <p:nvSpPr>
-          <p:cNvPr id="62" name="TextBox 61"/>
+          <p:cNvPr id="65" name="TextBox 64"/>
           <p:cNvSpPr txBox="1"/>
           <p:nvPr/>
         </p:nvSpPr>
@@ -8330,14 +8410,14 @@
       </p:sp>
       <p:sp>
         <p:nvSpPr>
-          <p:cNvPr id="63" name="Rectangle 62"/>
+          <p:cNvPr id="66" name="Rectangle 65"/>
           <p:cNvSpPr/>
           <p:nvPr/>
         </p:nvSpPr>
         <p:spPr>
           <a:xfrm>
             <a:off x="6766560" y="4517136"/>
-            <a:ext cx="4965192" cy="292608"/>
+            <a:ext cx="4965192" cy="640080"/>
           </a:xfrm>
           <a:prstGeom prst="rect">
             <a:avLst/>
@@ -8375,49 +8455,49 @@
       </p:sp>
       <p:sp>
         <p:nvSpPr>
-          <p:cNvPr id="64" name="TextBox 63"/>
+          <p:cNvPr id="67" name="TextBox 66"/>
           <p:cNvSpPr txBox="1"/>
           <p:nvPr/>
         </p:nvSpPr>
         <p:spPr>
           <a:xfrm>
             <a:off x="6858000" y="4553712"/>
-            <a:ext cx="1463040" cy="201168"/>
-          </a:xfrm>
-          <a:prstGeom prst="rect">
-            <a:avLst/>
-          </a:prstGeom>
-          <a:noFill/>
-        </p:spPr>
-        <p:txBody>
-          <a:bodyPr wrap="square">
-            <a:spAutoFit/>
-          </a:bodyPr>
-          <a:lstStyle/>
-          <a:p>
-            <a:pPr algn="l"/>
-            <a:r>
-              <a:rPr sz="750" b="1" i="0">
+            <a:ext cx="4782312" cy="164592"/>
+          </a:xfrm>
+          <a:prstGeom prst="rect">
+            <a:avLst/>
+          </a:prstGeom>
+          <a:noFill/>
+        </p:spPr>
+        <p:txBody>
+          <a:bodyPr wrap="square">
+            <a:spAutoFit/>
+          </a:bodyPr>
+          <a:lstStyle/>
+          <a:p>
+            <a:pPr algn="l"/>
+            <a:r>
+              <a:rPr sz="800" b="1" i="0">
                 <a:solidFill>
                   <a:srgbClr val="147D77"/>
                 </a:solidFill>
                 <a:latin typeface="Calibri"/>
               </a:rPr>
-              <a:t>result.json</a:t>
-            </a:r>
-          </a:p>
-        </p:txBody>
-      </p:sp>
-      <p:sp>
-        <p:nvSpPr>
-          <p:cNvPr id="65" name="TextBox 64"/>
-          <p:cNvSpPr txBox="1"/>
-          <p:nvPr/>
-        </p:nvSpPr>
-        <p:spPr>
-          <a:xfrm>
-            <a:off x="8366760" y="4553712"/>
-            <a:ext cx="3291840" cy="201168"/>
+              <a:t>CORE OUTPUTS:</a:t>
+            </a:r>
+          </a:p>
+        </p:txBody>
+      </p:sp>
+      <p:sp>
+        <p:nvSpPr>
+          <p:cNvPr id="68" name="TextBox 67"/>
+          <p:cNvSpPr txBox="1"/>
+          <p:nvPr/>
+        </p:nvSpPr>
+        <p:spPr>
+          <a:xfrm>
+            <a:off x="6858000" y="4736592"/>
+            <a:ext cx="4782312" cy="402336"/>
           </a:xfrm>
           <a:prstGeom prst="rect">
             <a:avLst/>
@@ -8438,21 +8518,23 @@
                 </a:solidFill>
                 <a:latin typeface="Calibri"/>
               </a:rPr>
-              <a:t>Transformation matrix, inlier count, coverage score, held-out RMSE, reason codes.</a:t>
-            </a:r>
-          </a:p>
-        </p:txBody>
-      </p:sp>
-      <p:sp>
-        <p:nvSpPr>
-          <p:cNvPr id="66" name="Rectangle 65"/>
+              <a:t>• Registered raster aligned to reference coordinate grid (registered_image.tif)
+• Tie-points CSV + result.json (transform, inlier count, coverage, held-out RMSE, reason codes)
+• Operator QC diagnostic checkerboard overlay (checkerboard_overlay.png)</a:t>
+            </a:r>
+          </a:p>
+        </p:txBody>
+      </p:sp>
+      <p:sp>
+        <p:nvSpPr>
+          <p:cNvPr id="69" name="Rectangle 68"/>
           <p:cNvSpPr/>
           <p:nvPr/>
         </p:nvSpPr>
         <p:spPr>
           <a:xfrm>
-            <a:off x="6766560" y="4846320"/>
-            <a:ext cx="4965192" cy="292608"/>
+            <a:off x="6766560" y="5230368"/>
+            <a:ext cx="4965192" cy="585216"/>
           </a:xfrm>
           <a:prstGeom prst="rect">
             <a:avLst/>
@@ -8490,49 +8572,49 @@
       </p:sp>
       <p:sp>
         <p:nvSpPr>
-          <p:cNvPr id="67" name="TextBox 66"/>
-          <p:cNvSpPr txBox="1"/>
-          <p:nvPr/>
-        </p:nvSpPr>
-        <p:spPr>
-          <a:xfrm>
-            <a:off x="6858000" y="4882896"/>
-            <a:ext cx="1463040" cy="201168"/>
-          </a:xfrm>
-          <a:prstGeom prst="rect">
-            <a:avLst/>
-          </a:prstGeom>
-          <a:noFill/>
-        </p:spPr>
-        <p:txBody>
-          <a:bodyPr wrap="square">
-            <a:spAutoFit/>
-          </a:bodyPr>
-          <a:lstStyle/>
-          <a:p>
-            <a:pPr algn="l"/>
-            <a:r>
-              <a:rPr sz="750" b="1" i="0">
+          <p:cNvPr id="70" name="TextBox 69"/>
+          <p:cNvSpPr txBox="1"/>
+          <p:nvPr/>
+        </p:nvSpPr>
+        <p:spPr>
+          <a:xfrm>
+            <a:off x="6858000" y="5266944"/>
+            <a:ext cx="4782312" cy="164592"/>
+          </a:xfrm>
+          <a:prstGeom prst="rect">
+            <a:avLst/>
+          </a:prstGeom>
+          <a:noFill/>
+        </p:spPr>
+        <p:txBody>
+          <a:bodyPr wrap="square">
+            <a:spAutoFit/>
+          </a:bodyPr>
+          <a:lstStyle/>
+          <a:p>
+            <a:pPr algn="l"/>
+            <a:r>
+              <a:rPr sz="800" b="1" i="0">
                 <a:solidFill>
                   <a:srgbClr val="147D77"/>
                 </a:solidFill>
                 <a:latin typeface="Calibri"/>
               </a:rPr>
-              <a:t>registered_image.tif</a:t>
-            </a:r>
-          </a:p>
-        </p:txBody>
-      </p:sp>
-      <p:sp>
-        <p:nvSpPr>
-          <p:cNvPr id="68" name="TextBox 67"/>
-          <p:cNvSpPr txBox="1"/>
-          <p:nvPr/>
-        </p:nvSpPr>
-        <p:spPr>
-          <a:xfrm>
-            <a:off x="8366760" y="4882896"/>
-            <a:ext cx="3291840" cy="201168"/>
+              <a:t>SOFTWARE DELIVERABLES:</a:t>
+            </a:r>
+          </a:p>
+        </p:txBody>
+      </p:sp>
+      <p:sp>
+        <p:nvSpPr>
+          <p:cNvPr id="71" name="TextBox 70"/>
+          <p:cNvSpPr txBox="1"/>
+          <p:nvPr/>
+        </p:nvSpPr>
+        <p:spPr>
+          <a:xfrm>
+            <a:off x="6858000" y="5449824"/>
+            <a:ext cx="4782312" cy="329184"/>
           </a:xfrm>
           <a:prstGeom prst="rect">
             <a:avLst/>
@@ -8553,122 +8635,8 @@
                 </a:solidFill>
                 <a:latin typeface="Calibri"/>
               </a:rPr>
-              <a:t>Georeferenced registered raster co-aligned with reference.</a:t>
-            </a:r>
-          </a:p>
-        </p:txBody>
-      </p:sp>
-      <p:sp>
-        <p:nvSpPr>
-          <p:cNvPr id="69" name="Rectangle 68"/>
-          <p:cNvSpPr/>
-          <p:nvPr/>
-        </p:nvSpPr>
-        <p:spPr>
-          <a:xfrm>
-            <a:off x="6766560" y="5175504"/>
-            <a:ext cx="4965192" cy="292608"/>
-          </a:xfrm>
-          <a:prstGeom prst="rect">
-            <a:avLst/>
-          </a:prstGeom>
-          <a:solidFill>
-            <a:srgbClr val="F4F6F8"/>
-          </a:solidFill>
-          <a:ln w="3810">
-            <a:solidFill>
-              <a:srgbClr val="D0D8DD"/>
-            </a:solidFill>
-          </a:ln>
-        </p:spPr>
-        <p:style>
-          <a:lnRef idx="1">
-            <a:schemeClr val="accent1"/>
-          </a:lnRef>
-          <a:fillRef idx="3">
-            <a:schemeClr val="accent1"/>
-          </a:fillRef>
-          <a:effectRef idx="2">
-            <a:schemeClr val="accent1"/>
-          </a:effectRef>
-          <a:fontRef idx="minor">
-            <a:schemeClr val="lt1"/>
-          </a:fontRef>
-        </p:style>
-        <p:txBody>
-          <a:bodyPr rtlCol="0" anchor="ctr"/>
-          <a:lstStyle/>
-          <a:p>
-            <a:pPr algn="ctr"/>
-          </a:p>
-        </p:txBody>
-      </p:sp>
-      <p:sp>
-        <p:nvSpPr>
-          <p:cNvPr id="70" name="TextBox 69"/>
-          <p:cNvSpPr txBox="1"/>
-          <p:nvPr/>
-        </p:nvSpPr>
-        <p:spPr>
-          <a:xfrm>
-            <a:off x="6858000" y="5212080"/>
-            <a:ext cx="1463040" cy="201168"/>
-          </a:xfrm>
-          <a:prstGeom prst="rect">
-            <a:avLst/>
-          </a:prstGeom>
-          <a:noFill/>
-        </p:spPr>
-        <p:txBody>
-          <a:bodyPr wrap="square">
-            <a:spAutoFit/>
-          </a:bodyPr>
-          <a:lstStyle/>
-          <a:p>
-            <a:pPr algn="l"/>
-            <a:r>
-              <a:rPr sz="750" b="1" i="0">
-                <a:solidFill>
-                  <a:srgbClr val="147D77"/>
-                </a:solidFill>
-                <a:latin typeface="Calibri"/>
-              </a:rPr>
-              <a:t>diagnostic_overlay</a:t>
-            </a:r>
-          </a:p>
-        </p:txBody>
-      </p:sp>
-      <p:sp>
-        <p:nvSpPr>
-          <p:cNvPr id="71" name="TextBox 70"/>
-          <p:cNvSpPr txBox="1"/>
-          <p:nvPr/>
-        </p:nvSpPr>
-        <p:spPr>
-          <a:xfrm>
-            <a:off x="8366760" y="5212080"/>
-            <a:ext cx="3291840" cy="201168"/>
-          </a:xfrm>
-          <a:prstGeom prst="rect">
-            <a:avLst/>
-          </a:prstGeom>
-          <a:noFill/>
-        </p:spPr>
-        <p:txBody>
-          <a:bodyPr wrap="square">
-            <a:spAutoFit/>
-          </a:bodyPr>
-          <a:lstStyle/>
-          <a:p>
-            <a:pPr algn="l"/>
-            <a:r>
-              <a:rPr sz="750" b="0" i="0">
-                <a:solidFill>
-                  <a:srgbClr val="1A2B35"/>
-                </a:solidFill>
-                <a:latin typeface="Calibri"/>
-              </a:rPr>
-              <a:t>High-resolution checkerboard verification image for operators.</a:t>
+              <a:t>• Runnable Python pipeline package (lunacorr/) with modular CLI
+• Container / environment specification (Docker / pip) + automated test suite</a:t>
             </a:r>
           </a:p>
         </p:txBody>
@@ -8676,121 +8644,6 @@
       <p:sp>
         <p:nvSpPr>
           <p:cNvPr id="72" name="Rectangle 71"/>
-          <p:cNvSpPr/>
-          <p:nvPr/>
-        </p:nvSpPr>
-        <p:spPr>
-          <a:xfrm>
-            <a:off x="6766560" y="5504688"/>
-            <a:ext cx="4965192" cy="292608"/>
-          </a:xfrm>
-          <a:prstGeom prst="rect">
-            <a:avLst/>
-          </a:prstGeom>
-          <a:solidFill>
-            <a:srgbClr val="F4F6F8"/>
-          </a:solidFill>
-          <a:ln w="3810">
-            <a:solidFill>
-              <a:srgbClr val="D0D8DD"/>
-            </a:solidFill>
-          </a:ln>
-        </p:spPr>
-        <p:style>
-          <a:lnRef idx="1">
-            <a:schemeClr val="accent1"/>
-          </a:lnRef>
-          <a:fillRef idx="3">
-            <a:schemeClr val="accent1"/>
-          </a:fillRef>
-          <a:effectRef idx="2">
-            <a:schemeClr val="accent1"/>
-          </a:effectRef>
-          <a:fontRef idx="minor">
-            <a:schemeClr val="lt1"/>
-          </a:fontRef>
-        </p:style>
-        <p:txBody>
-          <a:bodyPr rtlCol="0" anchor="ctr"/>
-          <a:lstStyle/>
-          <a:p>
-            <a:pPr algn="ctr"/>
-          </a:p>
-        </p:txBody>
-      </p:sp>
-      <p:sp>
-        <p:nvSpPr>
-          <p:cNvPr id="73" name="TextBox 72"/>
-          <p:cNvSpPr txBox="1"/>
-          <p:nvPr/>
-        </p:nvSpPr>
-        <p:spPr>
-          <a:xfrm>
-            <a:off x="6858000" y="5541264"/>
-            <a:ext cx="1463040" cy="201168"/>
-          </a:xfrm>
-          <a:prstGeom prst="rect">
-            <a:avLst/>
-          </a:prstGeom>
-          <a:noFill/>
-        </p:spPr>
-        <p:txBody>
-          <a:bodyPr wrap="square">
-            <a:spAutoFit/>
-          </a:bodyPr>
-          <a:lstStyle/>
-          <a:p>
-            <a:pPr algn="l"/>
-            <a:r>
-              <a:rPr sz="750" b="1" i="0">
-                <a:solidFill>
-                  <a:srgbClr val="147D77"/>
-                </a:solidFill>
-                <a:latin typeface="Calibri"/>
-              </a:rPr>
-              <a:t>runnable_code</a:t>
-            </a:r>
-          </a:p>
-        </p:txBody>
-      </p:sp>
-      <p:sp>
-        <p:nvSpPr>
-          <p:cNvPr id="74" name="TextBox 73"/>
-          <p:cNvSpPr txBox="1"/>
-          <p:nvPr/>
-        </p:nvSpPr>
-        <p:spPr>
-          <a:xfrm>
-            <a:off x="8366760" y="5541264"/>
-            <a:ext cx="3291840" cy="201168"/>
-          </a:xfrm>
-          <a:prstGeom prst="rect">
-            <a:avLst/>
-          </a:prstGeom>
-          <a:noFill/>
-        </p:spPr>
-        <p:txBody>
-          <a:bodyPr wrap="square">
-            <a:spAutoFit/>
-          </a:bodyPr>
-          <a:lstStyle/>
-          <a:p>
-            <a:pPr algn="l"/>
-            <a:r>
-              <a:rPr sz="750" b="0" i="0">
-                <a:solidFill>
-                  <a:srgbClr val="1A2B35"/>
-                </a:solidFill>
-                <a:latin typeface="Calibri"/>
-              </a:rPr>
-              <a:t>Python pipeline package (lunacorr/) and container environment.</a:t>
-            </a:r>
-          </a:p>
-        </p:txBody>
-      </p:sp>
-      <p:sp>
-        <p:nvSpPr>
-          <p:cNvPr id="75" name="Rectangle 74"/>
           <p:cNvSpPr/>
           <p:nvPr/>
         </p:nvSpPr>
@@ -8835,7 +8688,7 @@
       </p:sp>
       <p:sp>
         <p:nvSpPr>
-          <p:cNvPr id="76" name="TextBox 75"/>
+          <p:cNvPr id="73" name="TextBox 72"/>
           <p:cNvSpPr txBox="1"/>
           <p:nvPr/>
         </p:nvSpPr>
@@ -8870,7 +8723,7 @@
       </p:sp>
       <p:sp>
         <p:nvSpPr>
-          <p:cNvPr id="77" name="Rectangle 76"/>
+          <p:cNvPr id="74" name="Rectangle 73"/>
           <p:cNvSpPr/>
           <p:nvPr/>
         </p:nvSpPr>
@@ -8913,7 +8766,7 @@
       </p:sp>
       <p:sp>
         <p:nvSpPr>
-          <p:cNvPr id="78" name="TextBox 77"/>
+          <p:cNvPr id="75" name="TextBox 74"/>
           <p:cNvSpPr txBox="1"/>
           <p:nvPr/>
         </p:nvSpPr>
@@ -9420,7 +9273,7 @@
                 </a:solidFill>
                 <a:latin typeface="Calibri"/>
               </a:rPr>
-              <a:t>• Held-out RMSE reduced: 1.52 px → 0.84 px (44.7% error reduction vs affine fit)
+              <a:t>• Held-out RMSE reduced: 1.52 px → 0.84 px (44.7% held-out RMSE reduction vs Stage-3 rigid/projective baseline)
 • 95% Bootstrap Confidence Interval: [0.71, 0.97] px (B = 1000, seed frozen)
 • Evaluated on N=150 fixed held-out set, strictly withheld from transform fitting.</a:t>
             </a:r>
@@ -9502,7 +9355,7 @@
                 </a:solidFill>
                 <a:latin typeface="Calibri"/>
               </a:rPr>
-              <a:t>RESULT 3 — DISJOINT SCENE NEGATIVE CONTROL (FAIL-SAFE ABSTENTION):</a:t>
+              <a:t>RESULT 2 — DISJOINT SCENE NEGATIVE CONTROL (FAIL-SAFE ABSTENTION):</a:t>
             </a:r>
           </a:p>
         </p:txBody>
@@ -9537,7 +9390,7 @@
                 </a:solidFill>
                 <a:latin typeface="Calibri"/>
               </a:rPr>
-              <a:t>1/1 disjoint scene pair rejected (5 candidate inliers retained, 0 accepted; system fails safely rather than hallucinating false correspondences).</a:t>
+              <a:t>1/1 disjoint scene pair rejected; 5 candidate inliers retained but no registration accepted (system fails safely).</a:t>
             </a:r>
           </a:p>
         </p:txBody>
@@ -10400,7 +10253,7 @@
                 </a:solidFill>
                 <a:latin typeface="Calibri"/>
               </a:rPr>
-              <a:t>0.18 px median on LOLA</a:t>
+              <a:t>0.18 px median error</a:t>
             </a:r>
           </a:p>
         </p:txBody>
@@ -10955,7 +10808,7 @@
                 </a:solidFill>
                 <a:latin typeface="Calibri"/>
               </a:rPr>
-              <a:t>×204 inlier gain at 60°</a:t>
+              <a:t>1,679–2,859 inliers</a:t>
             </a:r>
           </a:p>
         </p:txBody>
@@ -11368,7 +11221,7 @@
                 </a:solidFill>
                 <a:latin typeface="Calibri"/>
               </a:rPr>
-              <a:t>PROVEN ON REAL MISSION DATA</a:t>
+              <a:t>DEMONSTRATED ON REAL-DATA BENCHMARKS</a:t>
             </a:r>
           </a:p>
         </p:txBody>
@@ -11518,7 +11371,7 @@
                 </a:solidFill>
                 <a:latin typeface="Calibri"/>
               </a:rPr>
-              <a:t>VERIFIED BY DESIGN</a:t>
+              <a:t>METHODOLOGICAL CONTROLS</a:t>
             </a:r>
           </a:p>
         </p:txBody>
@@ -11553,7 +11406,7 @@
                 </a:solidFill>
                 <a:latin typeface="Calibri"/>
               </a:rPr>
-              <a:t>No test-set leakage, frozen evaluation seeds, N≥20 inlier gating rule</a:t>
+              <a:t>No test-set access during model selection, frozen protocol, minimum-N rule</a:t>
             </a:r>
           </a:p>
         </p:txBody>
@@ -11703,7 +11556,7 @@
                 </a:solidFill>
                 <a:latin typeface="Calibri"/>
               </a:rPr>
-              <a:t>0.18 px median error on synthetic GT; re-illumination gain curves</a:t>
+              <a:t>Subpixel refinement: 0.18 px median; re-illumination gain curves</a:t>
             </a:r>
           </a:p>
         </p:txBody>
@@ -12523,7 +12376,7 @@
                 </a:solidFill>
                 <a:latin typeface="Calibri"/>
               </a:rPr>
-              <a:t>VALIDATION BOUNDARY: DEMONSTRATED vs PENDING</a:t>
+              <a:t>VALIDATION BOUNDARY: EVIDENCE STATUS</a:t>
             </a:r>
           </a:p>
         </p:txBody>
@@ -12537,7 +12390,7 @@
         <p:spPr>
           <a:xfrm>
             <a:off x="8458200" y="960120"/>
-            <a:ext cx="3520440" cy="1417320"/>
+            <a:ext cx="3520440" cy="1005840"/>
           </a:xfrm>
           <a:prstGeom prst="rect">
             <a:avLst/>
@@ -12581,7 +12434,7 @@
         </p:nvSpPr>
         <p:spPr>
           <a:xfrm>
-            <a:off x="8549640" y="996696"/>
+            <a:off x="8549640" y="987552"/>
             <a:ext cx="3337560" cy="164592"/>
           </a:xfrm>
           <a:prstGeom prst="rect">
@@ -12597,13 +12450,13 @@
           <a:p>
             <a:pPr algn="l"/>
             <a:r>
-              <a:rPr sz="800" b="1" i="0">
+              <a:rPr sz="780" b="1" i="0">
                 <a:solidFill>
                   <a:srgbClr val="2E9E6E"/>
                 </a:solidFill>
                 <a:latin typeface="Calibri"/>
               </a:rPr>
-              <a:t>DEMONSTRATED ON MISSION DATA:</a:t>
+              <a:t>DEMONSTRATED ON REAL MISSION DATA:</a:t>
             </a:r>
           </a:p>
         </p:txBody>
@@ -12616,8 +12469,8 @@
         </p:nvSpPr>
         <p:spPr>
           <a:xfrm>
-            <a:off x="8549640" y="1170432"/>
-            <a:ext cx="3337560" cy="1143000"/>
+            <a:off x="8549640" y="1152144"/>
+            <a:ext cx="3337560" cy="768096"/>
           </a:xfrm>
           <a:prstGeom prst="rect">
             <a:avLst/>
@@ -12638,10 +12491,9 @@
                 </a:solidFill>
                 <a:latin typeface="Calibri"/>
               </a:rPr>
-              <a:t>✓ Same-sensor repeat: OHRC cross-orbit (822 inliers, held-out RMSE 0.68 px)
-✓ Stereo relief: TMC-2 stereo (1.52 → 0.84 px RMSE, 44.7% error reduction)
-✓ Controlled illumination: Mode C retains &gt;2,000 inliers (&gt;99% precision @ 1px)
-✓ Fail-safe abstention: Disjoint pair rejected safely without hallucinating</a:t>
+              <a:t>✓ OHRC repeat: 822 inliers, held-out RMSE 0.779 px
+✓ TMC-2 stereo: 1.52 → 0.84 px RMSE (44.7% gain)
+✓ Safe rejection: Disjoint scene rejected (0 accepted)</a:t>
             </a:r>
           </a:p>
         </p:txBody>
@@ -12654,8 +12506,125 @@
         </p:nvSpPr>
         <p:spPr>
           <a:xfrm>
-            <a:off x="8458200" y="2450592"/>
-            <a:ext cx="3520440" cy="1417320"/>
+            <a:off x="8458200" y="2029968"/>
+            <a:ext cx="3520440" cy="914400"/>
+          </a:xfrm>
+          <a:prstGeom prst="rect">
+            <a:avLst/>
+          </a:prstGeom>
+          <a:solidFill>
+            <a:srgbClr val="EEF5FA"/>
+          </a:solidFill>
+          <a:ln w="6350">
+            <a:solidFill>
+              <a:srgbClr val="147D77"/>
+            </a:solidFill>
+          </a:ln>
+        </p:spPr>
+        <p:style>
+          <a:lnRef idx="1">
+            <a:schemeClr val="accent1"/>
+          </a:lnRef>
+          <a:fillRef idx="3">
+            <a:schemeClr val="accent1"/>
+          </a:fillRef>
+          <a:effectRef idx="2">
+            <a:schemeClr val="accent1"/>
+          </a:effectRef>
+          <a:fontRef idx="minor">
+            <a:schemeClr val="lt1"/>
+          </a:fontRef>
+        </p:style>
+        <p:txBody>
+          <a:bodyPr rtlCol="0" anchor="ctr"/>
+          <a:lstStyle/>
+          <a:p>
+            <a:pPr algn="ctr"/>
+          </a:p>
+        </p:txBody>
+      </p:sp>
+      <p:sp>
+        <p:nvSpPr>
+          <p:cNvPr id="17" name="TextBox 16"/>
+          <p:cNvSpPr txBox="1"/>
+          <p:nvPr/>
+        </p:nvSpPr>
+        <p:spPr>
+          <a:xfrm>
+            <a:off x="8549640" y="2057400"/>
+            <a:ext cx="3337560" cy="164592"/>
+          </a:xfrm>
+          <a:prstGeom prst="rect">
+            <a:avLst/>
+          </a:prstGeom>
+          <a:noFill/>
+        </p:spPr>
+        <p:txBody>
+          <a:bodyPr wrap="square">
+            <a:spAutoFit/>
+          </a:bodyPr>
+          <a:lstStyle/>
+          <a:p>
+            <a:pPr algn="l"/>
+            <a:r>
+              <a:rPr sz="780" b="1" i="0">
+                <a:solidFill>
+                  <a:srgbClr val="147D77"/>
+                </a:solidFill>
+                <a:latin typeface="Calibri"/>
+              </a:rPr>
+              <a:t>CONTROLLED SIMULATION (LOLA DEM):</a:t>
+            </a:r>
+          </a:p>
+        </p:txBody>
+      </p:sp>
+      <p:sp>
+        <p:nvSpPr>
+          <p:cNvPr id="18" name="TextBox 17"/>
+          <p:cNvSpPr txBox="1"/>
+          <p:nvPr/>
+        </p:nvSpPr>
+        <p:spPr>
+          <a:xfrm>
+            <a:off x="8549640" y="2221992"/>
+            <a:ext cx="3337560" cy="685800"/>
+          </a:xfrm>
+          <a:prstGeom prst="rect">
+            <a:avLst/>
+          </a:prstGeom>
+          <a:noFill/>
+        </p:spPr>
+        <p:txBody>
+          <a:bodyPr wrap="square">
+            <a:spAutoFit/>
+          </a:bodyPr>
+          <a:lstStyle/>
+          <a:p>
+            <a:pPr algn="l"/>
+            <a:r>
+              <a:rPr sz="750" b="0" i="0">
+                <a:solidFill>
+                  <a:srgbClr val="1A2B35"/>
+                </a:solidFill>
+                <a:latin typeface="Calibri"/>
+              </a:rPr>
+              <a:t>• Mode C retains 1,679–2,859 inliers across 0°–180°
+• True Precision @ 1px: &gt;99% in tested synthetic field
+• Direct matching collapses at Δ ≥ 60° (14 inliers)</a:t>
+            </a:r>
+          </a:p>
+        </p:txBody>
+      </p:sp>
+      <p:sp>
+        <p:nvSpPr>
+          <p:cNvPr id="19" name="Rectangle 18"/>
+          <p:cNvSpPr/>
+          <p:nvPr/>
+        </p:nvSpPr>
+        <p:spPr>
+          <a:xfrm>
+            <a:off x="8458200" y="2999232"/>
+            <a:ext cx="3520440" cy="1261872"/>
           </a:xfrm>
           <a:prstGeom prst="rect">
             <a:avLst/>
@@ -12693,13 +12662,13 @@
       </p:sp>
       <p:sp>
         <p:nvSpPr>
-          <p:cNvPr id="17" name="TextBox 16"/>
-          <p:cNvSpPr txBox="1"/>
-          <p:nvPr/>
-        </p:nvSpPr>
-        <p:spPr>
-          <a:xfrm>
-            <a:off x="8549640" y="2487168"/>
+          <p:cNvPr id="20" name="TextBox 19"/>
+          <p:cNvSpPr txBox="1"/>
+          <p:nvPr/>
+        </p:nvSpPr>
+        <p:spPr>
+          <a:xfrm>
+            <a:off x="8549640" y="3026664"/>
             <a:ext cx="3337560" cy="164592"/>
           </a:xfrm>
           <a:prstGeom prst="rect">
@@ -12715,7 +12684,7 @@
           <a:p>
             <a:pPr algn="l"/>
             <a:r>
-              <a:rPr sz="800" b="1" i="0">
+              <a:rPr sz="780" b="1" i="0">
                 <a:solidFill>
                   <a:srgbClr val="C4891E"/>
                 </a:solidFill>
@@ -12728,14 +12697,14 @@
       </p:sp>
       <p:sp>
         <p:nvSpPr>
-          <p:cNvPr id="18" name="TextBox 17"/>
-          <p:cNvSpPr txBox="1"/>
-          <p:nvPr/>
-        </p:nvSpPr>
-        <p:spPr>
-          <a:xfrm>
-            <a:off x="8549640" y="2660904"/>
-            <a:ext cx="3337560" cy="1143000"/>
+          <p:cNvPr id="21" name="TextBox 20"/>
+          <p:cNvSpPr txBox="1"/>
+          <p:nvPr/>
+        </p:nvSpPr>
+        <p:spPr>
+          <a:xfrm>
+            <a:off x="8549640" y="3191256"/>
+            <a:ext cx="3337560" cy="1024128"/>
           </a:xfrm>
           <a:prstGeom prst="rect">
             <a:avLst/>
@@ -12756,17 +12725,17 @@
                 </a:solidFill>
                 <a:latin typeface="Calibri"/>
               </a:rPr>
-              <a:t>⏳ Real cross-sensor correspondence: OHRC ↔ TMC-2 ↔ IIRS overlap
-⏳ Independent geodetic ground truth: LOLA laser altimetry check points
-⏳ Real multi-phase flight pairs: Extreme solar phase differences
-⏳ Regional holdout: Testing across polar, mare, and highland terrains</a:t>
-            </a:r>
-          </a:p>
-        </p:txBody>
-      </p:sp>
-      <p:sp>
-        <p:nvSpPr>
-          <p:cNvPr id="19" name="Rectangle 18"/>
+              <a:t>⏳ Real cross-sensor correspondence: OHRC ↔ TMC-2 ↔ IIRS
+⏳ Independent geodetic ground truth: LOLA laser altimetry
+⏳ Real multi-phase flight pairs: Extreme phase angles
+⏳ Regional holdout: Polar, mare, and highland terrains</a:t>
+            </a:r>
+          </a:p>
+        </p:txBody>
+      </p:sp>
+      <p:sp>
+        <p:nvSpPr>
+          <p:cNvPr id="22" name="Rectangle 21"/>
           <p:cNvSpPr/>
           <p:nvPr/>
         </p:nvSpPr>
@@ -12809,7 +12778,7 @@
       </p:sp>
       <p:sp>
         <p:nvSpPr>
-          <p:cNvPr id="20" name="TextBox 19"/>
+          <p:cNvPr id="23" name="TextBox 22"/>
           <p:cNvSpPr txBox="1"/>
           <p:nvPr/>
         </p:nvSpPr>
@@ -12844,7 +12813,7 @@
       </p:sp>
       <p:sp>
         <p:nvSpPr>
-          <p:cNvPr id="21" name="Rectangle 20"/>
+          <p:cNvPr id="24" name="Rectangle 23"/>
           <p:cNvSpPr/>
           <p:nvPr/>
         </p:nvSpPr>
@@ -12889,7 +12858,7 @@
       </p:sp>
       <p:sp>
         <p:nvSpPr>
-          <p:cNvPr id="22" name="TextBox 21"/>
+          <p:cNvPr id="25" name="TextBox 24"/>
           <p:cNvSpPr txBox="1"/>
           <p:nvPr/>
         </p:nvSpPr>
@@ -12924,7 +12893,7 @@
       </p:sp>
       <p:sp>
         <p:nvSpPr>
-          <p:cNvPr id="23" name="TextBox 22"/>
+          <p:cNvPr id="26" name="TextBox 25"/>
           <p:cNvSpPr txBox="1"/>
           <p:nvPr/>
         </p:nvSpPr>
@@ -12959,7 +12928,7 @@
       </p:sp>
       <p:sp>
         <p:nvSpPr>
-          <p:cNvPr id="24" name="Rectangle 23"/>
+          <p:cNvPr id="27" name="Rectangle 26"/>
           <p:cNvSpPr/>
           <p:nvPr/>
         </p:nvSpPr>
@@ -13004,7 +12973,7 @@
       </p:sp>
       <p:sp>
         <p:nvSpPr>
-          <p:cNvPr id="25" name="TextBox 24"/>
+          <p:cNvPr id="28" name="TextBox 27"/>
           <p:cNvSpPr txBox="1"/>
           <p:nvPr/>
         </p:nvSpPr>
@@ -13039,7 +13008,7 @@
       </p:sp>
       <p:sp>
         <p:nvSpPr>
-          <p:cNvPr id="26" name="TextBox 25"/>
+          <p:cNvPr id="29" name="TextBox 28"/>
           <p:cNvSpPr txBox="1"/>
           <p:nvPr/>
         </p:nvSpPr>
@@ -13074,7 +13043,7 @@
       </p:sp>
       <p:sp>
         <p:nvSpPr>
-          <p:cNvPr id="27" name="Rectangle 26"/>
+          <p:cNvPr id="30" name="Rectangle 29"/>
           <p:cNvSpPr/>
           <p:nvPr/>
         </p:nvSpPr>
@@ -13119,7 +13088,7 @@
       </p:sp>
       <p:sp>
         <p:nvSpPr>
-          <p:cNvPr id="28" name="TextBox 27"/>
+          <p:cNvPr id="31" name="TextBox 30"/>
           <p:cNvSpPr txBox="1"/>
           <p:nvPr/>
         </p:nvSpPr>
@@ -13154,7 +13123,7 @@
       </p:sp>
       <p:sp>
         <p:nvSpPr>
-          <p:cNvPr id="29" name="TextBox 28"/>
+          <p:cNvPr id="32" name="TextBox 31"/>
           <p:cNvSpPr txBox="1"/>
           <p:nvPr/>
         </p:nvSpPr>
@@ -13189,7 +13158,7 @@
       </p:sp>
       <p:sp>
         <p:nvSpPr>
-          <p:cNvPr id="30" name="Rectangle 29"/>
+          <p:cNvPr id="33" name="Rectangle 32"/>
           <p:cNvSpPr/>
           <p:nvPr/>
         </p:nvSpPr>
@@ -13234,7 +13203,7 @@
       </p:sp>
       <p:sp>
         <p:nvSpPr>
-          <p:cNvPr id="31" name="TextBox 30"/>
+          <p:cNvPr id="34" name="TextBox 33"/>
           <p:cNvSpPr txBox="1"/>
           <p:nvPr/>
         </p:nvSpPr>
@@ -13269,7 +13238,7 @@
       </p:sp>
       <p:sp>
         <p:nvSpPr>
-          <p:cNvPr id="32" name="TextBox 31"/>
+          <p:cNvPr id="35" name="TextBox 34"/>
           <p:cNvSpPr txBox="1"/>
           <p:nvPr/>
         </p:nvSpPr>
@@ -13304,7 +13273,7 @@
       </p:sp>
       <p:sp>
         <p:nvSpPr>
-          <p:cNvPr id="33" name="Rectangle 32"/>
+          <p:cNvPr id="36" name="Rectangle 35"/>
           <p:cNvSpPr/>
           <p:nvPr/>
         </p:nvSpPr>
@@ -13347,7 +13316,7 @@
       </p:sp>
       <p:sp>
         <p:nvSpPr>
-          <p:cNvPr id="34" name="TextBox 33"/>
+          <p:cNvPr id="37" name="TextBox 36"/>
           <p:cNvSpPr txBox="1"/>
           <p:nvPr/>
         </p:nvSpPr>
@@ -13382,7 +13351,7 @@
       </p:sp>
       <p:sp>
         <p:nvSpPr>
-          <p:cNvPr id="35" name="Rectangle 34"/>
+          <p:cNvPr id="38" name="Rectangle 37"/>
           <p:cNvSpPr/>
           <p:nvPr/>
         </p:nvSpPr>
@@ -13427,7 +13396,7 @@
       </p:sp>
       <p:sp>
         <p:nvSpPr>
-          <p:cNvPr id="36" name="TextBox 35"/>
+          <p:cNvPr id="39" name="TextBox 38"/>
           <p:cNvSpPr txBox="1"/>
           <p:nvPr/>
         </p:nvSpPr>
@@ -13462,7 +13431,7 @@
       </p:sp>
       <p:sp>
         <p:nvSpPr>
-          <p:cNvPr id="37" name="TextBox 36"/>
+          <p:cNvPr id="40" name="TextBox 39"/>
           <p:cNvSpPr txBox="1"/>
           <p:nvPr/>
         </p:nvSpPr>
@@ -13497,7 +13466,7 @@
       </p:sp>
       <p:sp>
         <p:nvSpPr>
-          <p:cNvPr id="38" name="Rectangle 37"/>
+          <p:cNvPr id="41" name="Rectangle 40"/>
           <p:cNvSpPr/>
           <p:nvPr/>
         </p:nvSpPr>
@@ -13542,7 +13511,7 @@
       </p:sp>
       <p:sp>
         <p:nvSpPr>
-          <p:cNvPr id="39" name="TextBox 38"/>
+          <p:cNvPr id="42" name="TextBox 41"/>
           <p:cNvSpPr txBox="1"/>
           <p:nvPr/>
         </p:nvSpPr>
@@ -13570,14 +13539,14 @@
                 </a:solidFill>
                 <a:latin typeface="Calibri"/>
               </a:rPr>
-              <a:t>RISK: No Real Footprint Overlap</a:t>
-            </a:r>
-          </a:p>
-        </p:txBody>
-      </p:sp>
-      <p:sp>
-        <p:nvSpPr>
-          <p:cNvPr id="40" name="TextBox 39"/>
+              <a:t>RISK: No Real Overlap</a:t>
+            </a:r>
+          </a:p>
+        </p:txBody>
+      </p:sp>
+      <p:sp>
+        <p:nvSpPr>
+          <p:cNvPr id="43" name="TextBox 42"/>
           <p:cNvSpPr txBox="1"/>
           <p:nvPr/>
         </p:nvSpPr>
@@ -13605,14 +13574,14 @@
                 </a:solidFill>
                 <a:latin typeface="Calibri"/>
               </a:rPr>
-              <a:t>→ Automated SPICE bounding-box intersection check</a:t>
-            </a:r>
-          </a:p>
-        </p:txBody>
-      </p:sp>
-      <p:sp>
-        <p:nvSpPr>
-          <p:cNvPr id="41" name="Rectangle 40"/>
+              <a:t>→ Detect spatial overlap first; route to search/abstain</a:t>
+            </a:r>
+          </a:p>
+        </p:txBody>
+      </p:sp>
+      <p:sp>
+        <p:nvSpPr>
+          <p:cNvPr id="44" name="Rectangle 43"/>
           <p:cNvSpPr/>
           <p:nvPr/>
         </p:nvSpPr>
@@ -13657,7 +13626,7 @@
       </p:sp>
       <p:sp>
         <p:nvSpPr>
-          <p:cNvPr id="42" name="TextBox 41"/>
+          <p:cNvPr id="45" name="TextBox 44"/>
           <p:cNvSpPr txBox="1"/>
           <p:nvPr/>
         </p:nvSpPr>
@@ -13692,7 +13661,7 @@
       </p:sp>
       <p:sp>
         <p:nvSpPr>
-          <p:cNvPr id="43" name="TextBox 42"/>
+          <p:cNvPr id="46" name="TextBox 45"/>
           <p:cNvSpPr txBox="1"/>
           <p:nvPr/>
         </p:nvSpPr>
@@ -13727,7 +13696,7 @@
       </p:sp>
       <p:sp>
         <p:nvSpPr>
-          <p:cNvPr id="44" name="Rectangle 43"/>
+          <p:cNvPr id="47" name="Rectangle 46"/>
           <p:cNvSpPr/>
           <p:nvPr/>
         </p:nvSpPr>
@@ -13772,7 +13741,7 @@
       </p:sp>
       <p:sp>
         <p:nvSpPr>
-          <p:cNvPr id="45" name="TextBox 44"/>
+          <p:cNvPr id="48" name="TextBox 47"/>
           <p:cNvSpPr txBox="1"/>
           <p:nvPr/>
         </p:nvSpPr>
@@ -13807,7 +13776,7 @@
       </p:sp>
       <p:sp>
         <p:nvSpPr>
-          <p:cNvPr id="46" name="TextBox 45"/>
+          <p:cNvPr id="49" name="TextBox 48"/>
           <p:cNvSpPr txBox="1"/>
           <p:nvPr/>
         </p:nvSpPr>
@@ -13835,14 +13804,14 @@
                 </a:solidFill>
                 <a:latin typeface="Calibri"/>
               </a:rPr>
-              <a:t>→ Multi-resolution pyramid + scale-space matching</a:t>
-            </a:r>
-          </a:p>
-        </p:txBody>
-      </p:sp>
-      <p:sp>
-        <p:nvSpPr>
-          <p:cNvPr id="47" name="Rectangle 46"/>
+              <a:t>→ Proposed mitigation: pyramid matching (pending)</a:t>
+            </a:r>
+          </a:p>
+        </p:txBody>
+      </p:sp>
+      <p:sp>
+        <p:nvSpPr>
+          <p:cNvPr id="50" name="Rectangle 49"/>
           <p:cNvSpPr/>
           <p:nvPr/>
         </p:nvSpPr>
@@ -13885,7 +13854,7 @@
       </p:sp>
       <p:sp>
         <p:nvSpPr>
-          <p:cNvPr id="48" name="TextBox 47"/>
+          <p:cNvPr id="51" name="TextBox 50"/>
           <p:cNvSpPr txBox="1"/>
           <p:nvPr/>
         </p:nvSpPr>
@@ -13920,7 +13889,7 @@
       </p:sp>
       <p:sp>
         <p:nvSpPr>
-          <p:cNvPr id="49" name="Rectangle 48"/>
+          <p:cNvPr id="52" name="Rectangle 51"/>
           <p:cNvSpPr/>
           <p:nvPr/>
         </p:nvSpPr>
@@ -13965,7 +13934,7 @@
       </p:sp>
       <p:sp>
         <p:nvSpPr>
-          <p:cNvPr id="50" name="TextBox 49"/>
+          <p:cNvPr id="53" name="TextBox 52"/>
           <p:cNvSpPr txBox="1"/>
           <p:nvPr/>
         </p:nvSpPr>
@@ -14000,7 +13969,7 @@
       </p:sp>
       <p:sp>
         <p:nvSpPr>
-          <p:cNvPr id="51" name="Rectangle 50"/>
+          <p:cNvPr id="54" name="Rectangle 53"/>
           <p:cNvSpPr/>
           <p:nvPr/>
         </p:nvSpPr>
@@ -14045,7 +14014,7 @@
       </p:sp>
       <p:sp>
         <p:nvSpPr>
-          <p:cNvPr id="52" name="TextBox 51"/>
+          <p:cNvPr id="55" name="TextBox 54"/>
           <p:cNvSpPr txBox="1"/>
           <p:nvPr/>
         </p:nvSpPr>
@@ -14080,7 +14049,7 @@
       </p:sp>
       <p:sp>
         <p:nvSpPr>
-          <p:cNvPr id="53" name="Rectangle 52"/>
+          <p:cNvPr id="56" name="Rectangle 55"/>
           <p:cNvSpPr/>
           <p:nvPr/>
         </p:nvSpPr>
@@ -14125,7 +14094,7 @@
       </p:sp>
       <p:sp>
         <p:nvSpPr>
-          <p:cNvPr id="54" name="TextBox 53"/>
+          <p:cNvPr id="57" name="TextBox 56"/>
           <p:cNvSpPr txBox="1"/>
           <p:nvPr/>
         </p:nvSpPr>
@@ -14160,7 +14129,7 @@
       </p:sp>
       <p:sp>
         <p:nvSpPr>
-          <p:cNvPr id="55" name="Rectangle 54"/>
+          <p:cNvPr id="58" name="Rectangle 57"/>
           <p:cNvSpPr/>
           <p:nvPr/>
         </p:nvSpPr>
@@ -14205,7 +14174,7 @@
       </p:sp>
       <p:sp>
         <p:nvSpPr>
-          <p:cNvPr id="56" name="TextBox 55"/>
+          <p:cNvPr id="59" name="TextBox 58"/>
           <p:cNvSpPr txBox="1"/>
           <p:nvPr/>
         </p:nvSpPr>
@@ -14240,7 +14209,7 @@
       </p:sp>
       <p:sp>
         <p:nvSpPr>
-          <p:cNvPr id="57" name="Rectangle 56"/>
+          <p:cNvPr id="60" name="Rectangle 59"/>
           <p:cNvSpPr/>
           <p:nvPr/>
         </p:nvSpPr>
@@ -14283,7 +14252,7 @@
       </p:sp>
       <p:sp>
         <p:nvSpPr>
-          <p:cNvPr id="58" name="TextBox 57"/>
+          <p:cNvPr id="61" name="TextBox 60"/>
           <p:cNvSpPr txBox="1"/>
           <p:nvPr/>
         </p:nvSpPr>
@@ -15272,7 +15241,7 @@
                 </a:solidFill>
                 <a:latin typeface="Calibri"/>
               </a:rPr>
-              <a:t>Directly addresses lunar illumination physics via LCN and DEM reflectance simulation, preventing optical correlation collapse.</a:t>
+              <a:t>Directly addresses lunar illumination physics via LCN and DEM reflectance simulation, designed to mitigate illumination-induced correspondence collapse.</a:t>
             </a:r>
           </a:p>
         </p:txBody>
@@ -15387,7 +15356,7 @@
                 </a:solidFill>
                 <a:latin typeface="Calibri"/>
               </a:rPr>
-              <a:t>Coherence-gated TPS elastic warping compensates 3D topography without forcing an oversimplified planar homography.</a:t>
+              <a:t>Coherence-gated TPS elastic warping compensates apparent relief-induced 2D displacement without forcing an oversimplified planar homography.</a:t>
             </a:r>
           </a:p>
         </p:txBody>
@@ -15467,7 +15436,7 @@
                 </a:solidFill>
                 <a:latin typeface="Calibri"/>
               </a:rPr>
-              <a:t>Fail-Safe Abstention</a:t>
+              <a:t>Fail-Safe Quality Control</a:t>
             </a:r>
           </a:p>
         </p:txBody>
@@ -15502,7 +15471,7 @@
                 </a:solidFill>
                 <a:latin typeface="Calibri"/>
               </a:rPr>
-              <a:t>Mission-critical safety: rejects invalid or ambiguous pairs with explicit reason codes rather than corrupting mapping products.</a:t>
+              <a:t>Rejects invalid or ambiguous registrations with explicit reason codes rather than forcing alignment on unmatchable scenes.</a:t>
             </a:r>
           </a:p>
         </p:txBody>
@@ -15720,7 +15689,7 @@
                 </a:solidFill>
                 <a:latin typeface="Calibri"/>
               </a:rPr>
-              <a:t>✓  Georeferenced registered product GeoTIFF (registered_image.tif)</a:t>
+              <a:t>✓  Registered raster aligned to reference grid (registered_image.tif)</a:t>
             </a:r>
           </a:p>
         </p:txBody>
@@ -15868,7 +15837,7 @@
                 </a:solidFill>
                 <a:latin typeface="Calibri"/>
               </a:rPr>
-              <a:t>REPOSITORY AND CONTACT</a:t>
+              <a:t>REPOSITORY AND IDENTIFICATION</a:t>
             </a:r>
           </a:p>
         </p:txBody>
@@ -15881,7 +15850,7 @@
         </p:nvSpPr>
         <p:spPr>
           <a:xfrm>
-            <a:off x="7726679" y="4828032"/>
+            <a:off x="7726679" y="4846320"/>
             <a:ext cx="4160520" cy="201168"/>
           </a:xfrm>
           <a:prstGeom prst="rect">
@@ -15916,7 +15885,7 @@
         </p:nvSpPr>
         <p:spPr>
           <a:xfrm>
-            <a:off x="7726679" y="5047488"/>
+            <a:off x="7726679" y="5102352"/>
             <a:ext cx="4160520" cy="201168"/>
           </a:xfrm>
           <a:prstGeom prst="rect">
@@ -15951,7 +15920,7 @@
         </p:nvSpPr>
         <p:spPr>
           <a:xfrm>
-            <a:off x="7726679" y="5266944"/>
+            <a:off x="7726679" y="5358384"/>
             <a:ext cx="4160520" cy="201168"/>
           </a:xfrm>
           <a:prstGeom prst="rect">
@@ -15980,42 +15949,7 @@
       </p:sp>
       <p:sp>
         <p:nvSpPr>
-          <p:cNvPr id="46" name="TextBox 45"/>
-          <p:cNvSpPr txBox="1"/>
-          <p:nvPr/>
-        </p:nvSpPr>
-        <p:spPr>
-          <a:xfrm>
-            <a:off x="7726679" y="5486400"/>
-            <a:ext cx="4160520" cy="182880"/>
-          </a:xfrm>
-          <a:prstGeom prst="rect">
-            <a:avLst/>
-          </a:prstGeom>
-          <a:noFill/>
-        </p:spPr>
-        <p:txBody>
-          <a:bodyPr wrap="square">
-            <a:spAutoFit/>
-          </a:bodyPr>
-          <a:lstStyle/>
-          <a:p>
-            <a:pPr algn="l"/>
-            <a:r>
-              <a:rPr sz="800" b="0" i="1">
-                <a:solidFill>
-                  <a:srgbClr val="6B7E88"/>
-                </a:solidFill>
-                <a:latin typeface="Calibri"/>
-              </a:rPr>
-              <a:t>Contact through official SIH 2026 portal only.</a:t>
-            </a:r>
-          </a:p>
-        </p:txBody>
-      </p:sp>
-      <p:sp>
-        <p:nvSpPr>
-          <p:cNvPr id="47" name="Rectangle 46"/>
+          <p:cNvPr id="46" name="Rectangle 45"/>
           <p:cNvSpPr/>
           <p:nvPr/>
         </p:nvSpPr>
@@ -16058,7 +15992,7 @@
       </p:sp>
       <p:sp>
         <p:nvSpPr>
-          <p:cNvPr id="48" name="TextBox 47"/>
+          <p:cNvPr id="47" name="TextBox 46"/>
           <p:cNvSpPr txBox="1"/>
           <p:nvPr/>
         </p:nvSpPr>

</xml_diff>

<commit_message>
Remove Deliverable Checklist and refine Slide 6 layout
</commit_message>
<xml_diff>
--- a/LUNA-CORR_SIH2026_Presentation.pptx
+++ b/LUNA-CORR_SIH2026_Presentation.pptx
@@ -14384,7 +14384,7 @@
                 </a:solidFill>
                 <a:latin typeface="Calibri"/>
               </a:rPr>
-              <a:t>SUMMARY, DELIVERABLES AND REFERENCES</a:t>
+              <a:t>SUMMARY, SCIENTIFIC BOUNDARIES AND REFERENCES</a:t>
             </a:r>
           </a:p>
         </p:txBody>
@@ -15126,7 +15126,7 @@
                 </a:solidFill>
                 <a:latin typeface="Calibri"/>
               </a:rPr>
-              <a:t>THREE CORE TAKEAWAYS</a:t>
+              <a:t>THREE CORE SCIENTIFIC TAKEAWAYS</a:t>
             </a:r>
           </a:p>
         </p:txBody>
@@ -15140,7 +15140,7 @@
         <p:spPr>
           <a:xfrm>
             <a:off x="7635240" y="969264"/>
-            <a:ext cx="4343400" cy="566928"/>
+            <a:ext cx="4343400" cy="868680"/>
           </a:xfrm>
           <a:prstGeom prst="rect">
             <a:avLst/>
@@ -15148,7 +15148,7 @@
           <a:solidFill>
             <a:srgbClr val="F4F6F8"/>
           </a:solidFill>
-          <a:ln w="3810">
+          <a:ln w="5080">
             <a:solidFill>
               <a:srgbClr val="D0D8DD"/>
             </a:solidFill>
@@ -15178,314 +15178,14 @@
       </p:sp>
       <p:sp>
         <p:nvSpPr>
-          <p:cNvPr id="25" name="TextBox 24"/>
-          <p:cNvSpPr txBox="1"/>
-          <p:nvPr/>
-        </p:nvSpPr>
-        <p:spPr>
-          <a:xfrm>
-            <a:off x="7726679" y="1005840"/>
-            <a:ext cx="4160520" cy="182880"/>
-          </a:xfrm>
-          <a:prstGeom prst="rect">
-            <a:avLst/>
-          </a:prstGeom>
-          <a:noFill/>
-        </p:spPr>
-        <p:txBody>
-          <a:bodyPr wrap="square">
-            <a:spAutoFit/>
-          </a:bodyPr>
-          <a:lstStyle/>
-          <a:p>
-            <a:pPr algn="l"/>
-            <a:r>
-              <a:rPr sz="800" b="1" i="0">
-                <a:solidFill>
-                  <a:srgbClr val="147D77"/>
-                </a:solidFill>
-                <a:latin typeface="Calibri"/>
-              </a:rPr>
-              <a:t>Physics-Conditioned Appearance</a:t>
-            </a:r>
-          </a:p>
-        </p:txBody>
-      </p:sp>
-      <p:sp>
-        <p:nvSpPr>
-          <p:cNvPr id="26" name="TextBox 25"/>
-          <p:cNvSpPr txBox="1"/>
-          <p:nvPr/>
-        </p:nvSpPr>
-        <p:spPr>
-          <a:xfrm>
-            <a:off x="7726679" y="1188720"/>
-            <a:ext cx="4160520" cy="347472"/>
-          </a:xfrm>
-          <a:prstGeom prst="rect">
-            <a:avLst/>
-          </a:prstGeom>
-          <a:noFill/>
-        </p:spPr>
-        <p:txBody>
-          <a:bodyPr wrap="square">
-            <a:spAutoFit/>
-          </a:bodyPr>
-          <a:lstStyle/>
-          <a:p>
-            <a:pPr algn="l"/>
-            <a:r>
-              <a:rPr sz="750" b="0" i="0">
-                <a:solidFill>
-                  <a:srgbClr val="1A2B35"/>
-                </a:solidFill>
-                <a:latin typeface="Calibri"/>
-              </a:rPr>
-              <a:t>Directly addresses lunar illumination physics via LCN and DEM reflectance simulation, designed to mitigate illumination-induced correspondence collapse.</a:t>
-            </a:r>
-          </a:p>
-        </p:txBody>
-      </p:sp>
-      <p:sp>
-        <p:nvSpPr>
-          <p:cNvPr id="27" name="Rectangle 26"/>
+          <p:cNvPr id="25" name="Rectangle 24"/>
           <p:cNvSpPr/>
           <p:nvPr/>
         </p:nvSpPr>
         <p:spPr>
           <a:xfrm>
-            <a:off x="7635240" y="1591056"/>
-            <a:ext cx="4343400" cy="566928"/>
-          </a:xfrm>
-          <a:prstGeom prst="rect">
-            <a:avLst/>
-          </a:prstGeom>
-          <a:solidFill>
-            <a:srgbClr val="F4F6F8"/>
-          </a:solidFill>
-          <a:ln w="3810">
-            <a:solidFill>
-              <a:srgbClr val="D0D8DD"/>
-            </a:solidFill>
-          </a:ln>
-        </p:spPr>
-        <p:style>
-          <a:lnRef idx="1">
-            <a:schemeClr val="accent1"/>
-          </a:lnRef>
-          <a:fillRef idx="3">
-            <a:schemeClr val="accent1"/>
-          </a:fillRef>
-          <a:effectRef idx="2">
-            <a:schemeClr val="accent1"/>
-          </a:effectRef>
-          <a:fontRef idx="minor">
-            <a:schemeClr val="lt1"/>
-          </a:fontRef>
-        </p:style>
-        <p:txBody>
-          <a:bodyPr rtlCol="0" anchor="ctr"/>
-          <a:lstStyle/>
-          <a:p>
-            <a:pPr algn="ctr"/>
-          </a:p>
-        </p:txBody>
-      </p:sp>
-      <p:sp>
-        <p:nvSpPr>
-          <p:cNvPr id="28" name="TextBox 27"/>
-          <p:cNvSpPr txBox="1"/>
-          <p:nvPr/>
-        </p:nvSpPr>
-        <p:spPr>
-          <a:xfrm>
-            <a:off x="7726679" y="1627632"/>
-            <a:ext cx="4160520" cy="182880"/>
-          </a:xfrm>
-          <a:prstGeom prst="rect">
-            <a:avLst/>
-          </a:prstGeom>
-          <a:noFill/>
-        </p:spPr>
-        <p:txBody>
-          <a:bodyPr wrap="square">
-            <a:spAutoFit/>
-          </a:bodyPr>
-          <a:lstStyle/>
-          <a:p>
-            <a:pPr algn="l"/>
-            <a:r>
-              <a:rPr sz="800" b="1" i="0">
-                <a:solidFill>
-                  <a:srgbClr val="147D77"/>
-                </a:solidFill>
-                <a:latin typeface="Calibri"/>
-              </a:rPr>
-              <a:t>Adaptive Geometry for Relief</a:t>
-            </a:r>
-          </a:p>
-        </p:txBody>
-      </p:sp>
-      <p:sp>
-        <p:nvSpPr>
-          <p:cNvPr id="29" name="TextBox 28"/>
-          <p:cNvSpPr txBox="1"/>
-          <p:nvPr/>
-        </p:nvSpPr>
-        <p:spPr>
-          <a:xfrm>
-            <a:off x="7726679" y="1810512"/>
-            <a:ext cx="4160520" cy="347472"/>
-          </a:xfrm>
-          <a:prstGeom prst="rect">
-            <a:avLst/>
-          </a:prstGeom>
-          <a:noFill/>
-        </p:spPr>
-        <p:txBody>
-          <a:bodyPr wrap="square">
-            <a:spAutoFit/>
-          </a:bodyPr>
-          <a:lstStyle/>
-          <a:p>
-            <a:pPr algn="l"/>
-            <a:r>
-              <a:rPr sz="750" b="0" i="0">
-                <a:solidFill>
-                  <a:srgbClr val="1A2B35"/>
-                </a:solidFill>
-                <a:latin typeface="Calibri"/>
-              </a:rPr>
-              <a:t>Coherence-gated TPS elastic warping compensates apparent relief-induced 2D displacement without forcing an oversimplified planar homography.</a:t>
-            </a:r>
-          </a:p>
-        </p:txBody>
-      </p:sp>
-      <p:sp>
-        <p:nvSpPr>
-          <p:cNvPr id="30" name="Rectangle 29"/>
-          <p:cNvSpPr/>
-          <p:nvPr/>
-        </p:nvSpPr>
-        <p:spPr>
-          <a:xfrm>
-            <a:off x="7635240" y="2212848"/>
-            <a:ext cx="4343400" cy="566928"/>
-          </a:xfrm>
-          <a:prstGeom prst="rect">
-            <a:avLst/>
-          </a:prstGeom>
-          <a:solidFill>
-            <a:srgbClr val="F4F6F8"/>
-          </a:solidFill>
-          <a:ln w="3810">
-            <a:solidFill>
-              <a:srgbClr val="D0D8DD"/>
-            </a:solidFill>
-          </a:ln>
-        </p:spPr>
-        <p:style>
-          <a:lnRef idx="1">
-            <a:schemeClr val="accent1"/>
-          </a:lnRef>
-          <a:fillRef idx="3">
-            <a:schemeClr val="accent1"/>
-          </a:fillRef>
-          <a:effectRef idx="2">
-            <a:schemeClr val="accent1"/>
-          </a:effectRef>
-          <a:fontRef idx="minor">
-            <a:schemeClr val="lt1"/>
-          </a:fontRef>
-        </p:style>
-        <p:txBody>
-          <a:bodyPr rtlCol="0" anchor="ctr"/>
-          <a:lstStyle/>
-          <a:p>
-            <a:pPr algn="ctr"/>
-          </a:p>
-        </p:txBody>
-      </p:sp>
-      <p:sp>
-        <p:nvSpPr>
-          <p:cNvPr id="31" name="TextBox 30"/>
-          <p:cNvSpPr txBox="1"/>
-          <p:nvPr/>
-        </p:nvSpPr>
-        <p:spPr>
-          <a:xfrm>
-            <a:off x="7726679" y="2249424"/>
-            <a:ext cx="4160520" cy="182880"/>
-          </a:xfrm>
-          <a:prstGeom prst="rect">
-            <a:avLst/>
-          </a:prstGeom>
-          <a:noFill/>
-        </p:spPr>
-        <p:txBody>
-          <a:bodyPr wrap="square">
-            <a:spAutoFit/>
-          </a:bodyPr>
-          <a:lstStyle/>
-          <a:p>
-            <a:pPr algn="l"/>
-            <a:r>
-              <a:rPr sz="800" b="1" i="0">
-                <a:solidFill>
-                  <a:srgbClr val="147D77"/>
-                </a:solidFill>
-                <a:latin typeface="Calibri"/>
-              </a:rPr>
-              <a:t>Fail-Safe Quality Control</a:t>
-            </a:r>
-          </a:p>
-        </p:txBody>
-      </p:sp>
-      <p:sp>
-        <p:nvSpPr>
-          <p:cNvPr id="32" name="TextBox 31"/>
-          <p:cNvSpPr txBox="1"/>
-          <p:nvPr/>
-        </p:nvSpPr>
-        <p:spPr>
-          <a:xfrm>
-            <a:off x="7726679" y="2432304"/>
-            <a:ext cx="4160520" cy="347472"/>
-          </a:xfrm>
-          <a:prstGeom prst="rect">
-            <a:avLst/>
-          </a:prstGeom>
-          <a:noFill/>
-        </p:spPr>
-        <p:txBody>
-          <a:bodyPr wrap="square">
-            <a:spAutoFit/>
-          </a:bodyPr>
-          <a:lstStyle/>
-          <a:p>
-            <a:pPr algn="l"/>
-            <a:r>
-              <a:rPr sz="750" b="0" i="0">
-                <a:solidFill>
-                  <a:srgbClr val="1A2B35"/>
-                </a:solidFill>
-                <a:latin typeface="Calibri"/>
-              </a:rPr>
-              <a:t>Rejects invalid or ambiguous registrations with explicit reason codes rather than forcing alignment on unmatchable scenes.</a:t>
-            </a:r>
-          </a:p>
-        </p:txBody>
-      </p:sp>
-      <p:sp>
-        <p:nvSpPr>
-          <p:cNvPr id="33" name="Rectangle 32"/>
-          <p:cNvSpPr/>
-          <p:nvPr/>
-        </p:nvSpPr>
-        <p:spPr>
-          <a:xfrm>
-            <a:off x="7635240" y="2944368"/>
-            <a:ext cx="4343400" cy="182880"/>
+            <a:off x="7635240" y="969264"/>
+            <a:ext cx="91440" cy="868680"/>
           </a:xfrm>
           <a:prstGeom prst="rect">
             <a:avLst/>
@@ -15521,259 +15221,129 @@
       </p:sp>
       <p:sp>
         <p:nvSpPr>
-          <p:cNvPr id="34" name="TextBox 33"/>
-          <p:cNvSpPr txBox="1"/>
-          <p:nvPr/>
-        </p:nvSpPr>
-        <p:spPr>
-          <a:xfrm>
-            <a:off x="7726679" y="2962656"/>
-            <a:ext cx="4206240" cy="182880"/>
-          </a:xfrm>
-          <a:prstGeom prst="rect">
-            <a:avLst/>
-          </a:prstGeom>
-          <a:noFill/>
-        </p:spPr>
-        <p:txBody>
-          <a:bodyPr wrap="square">
-            <a:spAutoFit/>
-          </a:bodyPr>
-          <a:lstStyle/>
-          <a:p>
-            <a:pPr algn="l"/>
-            <a:r>
-              <a:rPr sz="750" b="1" i="0">
-                <a:solidFill>
-                  <a:srgbClr val="FFFFFF"/>
-                </a:solidFill>
-                <a:latin typeface="Calibri"/>
-              </a:rPr>
-              <a:t>DELIVERABLE CHECKLIST</a:t>
-            </a:r>
-          </a:p>
-        </p:txBody>
-      </p:sp>
-      <p:sp>
-        <p:nvSpPr>
-          <p:cNvPr id="35" name="TextBox 34"/>
-          <p:cNvSpPr txBox="1"/>
-          <p:nvPr/>
-        </p:nvSpPr>
-        <p:spPr>
-          <a:xfrm>
-            <a:off x="7726679" y="3163824"/>
-            <a:ext cx="4160520" cy="201168"/>
-          </a:xfrm>
-          <a:prstGeom prst="rect">
-            <a:avLst/>
-          </a:prstGeom>
-          <a:noFill/>
-        </p:spPr>
-        <p:txBody>
-          <a:bodyPr wrap="square">
-            <a:spAutoFit/>
-          </a:bodyPr>
-          <a:lstStyle/>
-          <a:p>
-            <a:pPr algn="l"/>
-            <a:r>
-              <a:rPr sz="750" b="0" i="0">
+          <p:cNvPr id="26" name="TextBox 25"/>
+          <p:cNvSpPr txBox="1"/>
+          <p:nvPr/>
+        </p:nvSpPr>
+        <p:spPr>
+          <a:xfrm>
+            <a:off x="7818120" y="1024128"/>
+            <a:ext cx="4069080" cy="201168"/>
+          </a:xfrm>
+          <a:prstGeom prst="rect">
+            <a:avLst/>
+          </a:prstGeom>
+          <a:noFill/>
+        </p:spPr>
+        <p:txBody>
+          <a:bodyPr wrap="square">
+            <a:spAutoFit/>
+          </a:bodyPr>
+          <a:lstStyle/>
+          <a:p>
+            <a:pPr algn="l"/>
+            <a:r>
+              <a:rPr sz="900" b="1" i="0">
+                <a:solidFill>
+                  <a:srgbClr val="147D77"/>
+                </a:solidFill>
+                <a:latin typeface="Calibri"/>
+              </a:rPr>
+              <a:t>1. Physics-Conditioned Appearance</a:t>
+            </a:r>
+          </a:p>
+        </p:txBody>
+      </p:sp>
+      <p:sp>
+        <p:nvSpPr>
+          <p:cNvPr id="27" name="TextBox 26"/>
+          <p:cNvSpPr txBox="1"/>
+          <p:nvPr/>
+        </p:nvSpPr>
+        <p:spPr>
+          <a:xfrm>
+            <a:off x="7818120" y="1243584"/>
+            <a:ext cx="4069080" cy="548640"/>
+          </a:xfrm>
+          <a:prstGeom prst="rect">
+            <a:avLst/>
+          </a:prstGeom>
+          <a:noFill/>
+        </p:spPr>
+        <p:txBody>
+          <a:bodyPr wrap="square">
+            <a:spAutoFit/>
+          </a:bodyPr>
+          <a:lstStyle/>
+          <a:p>
+            <a:pPr algn="l"/>
+            <a:r>
+              <a:rPr sz="800" b="0" i="0">
                 <a:solidFill>
                   <a:srgbClr val="1A2B35"/>
                 </a:solidFill>
                 <a:latin typeface="Calibri"/>
               </a:rPr>
-              <a:t>✓  Runnable Python pipeline package (lunacorr/)</a:t>
-            </a:r>
-          </a:p>
-        </p:txBody>
-      </p:sp>
-      <p:sp>
-        <p:nvSpPr>
-          <p:cNvPr id="36" name="TextBox 35"/>
-          <p:cNvSpPr txBox="1"/>
-          <p:nvPr/>
-        </p:nvSpPr>
-        <p:spPr>
-          <a:xfrm>
-            <a:off x="7726679" y="3383280"/>
-            <a:ext cx="4160520" cy="201168"/>
-          </a:xfrm>
-          <a:prstGeom prst="rect">
-            <a:avLst/>
-          </a:prstGeom>
-          <a:noFill/>
-        </p:spPr>
-        <p:txBody>
-          <a:bodyPr wrap="square">
-            <a:spAutoFit/>
-          </a:bodyPr>
-          <a:lstStyle/>
-          <a:p>
-            <a:pPr algn="l"/>
-            <a:r>
-              <a:rPr sz="750" b="0" i="0">
-                <a:solidFill>
-                  <a:srgbClr val="1A2B35"/>
-                </a:solidFill>
-                <a:latin typeface="Calibri"/>
-              </a:rPr>
-              <a:t>✓  Container / environment specification (Docker / pip)</a:t>
-            </a:r>
-          </a:p>
-        </p:txBody>
-      </p:sp>
-      <p:sp>
-        <p:nvSpPr>
-          <p:cNvPr id="37" name="TextBox 36"/>
-          <p:cNvSpPr txBox="1"/>
-          <p:nvPr/>
-        </p:nvSpPr>
-        <p:spPr>
-          <a:xfrm>
-            <a:off x="7726679" y="3602736"/>
-            <a:ext cx="4160520" cy="201168"/>
-          </a:xfrm>
-          <a:prstGeom prst="rect">
-            <a:avLst/>
-          </a:prstGeom>
-          <a:noFill/>
-        </p:spPr>
-        <p:txBody>
-          <a:bodyPr wrap="square">
-            <a:spAutoFit/>
-          </a:bodyPr>
-          <a:lstStyle/>
-          <a:p>
-            <a:pPr algn="l"/>
-            <a:r>
-              <a:rPr sz="750" b="0" i="0">
-                <a:solidFill>
-                  <a:srgbClr val="1A2B35"/>
-                </a:solidFill>
-                <a:latin typeface="Calibri"/>
-              </a:rPr>
-              <a:t>✓  Structured result.json per pair with complete metrics</a:t>
-            </a:r>
-          </a:p>
-        </p:txBody>
-      </p:sp>
-      <p:sp>
-        <p:nvSpPr>
-          <p:cNvPr id="38" name="TextBox 37"/>
-          <p:cNvSpPr txBox="1"/>
-          <p:nvPr/>
-        </p:nvSpPr>
-        <p:spPr>
-          <a:xfrm>
-            <a:off x="7726679" y="3822192"/>
-            <a:ext cx="4160520" cy="201168"/>
-          </a:xfrm>
-          <a:prstGeom prst="rect">
-            <a:avLst/>
-          </a:prstGeom>
-          <a:noFill/>
-        </p:spPr>
-        <p:txBody>
-          <a:bodyPr wrap="square">
-            <a:spAutoFit/>
-          </a:bodyPr>
-          <a:lstStyle/>
-          <a:p>
-            <a:pPr algn="l"/>
-            <a:r>
-              <a:rPr sz="750" b="0" i="0">
-                <a:solidFill>
-                  <a:srgbClr val="1A2B35"/>
-                </a:solidFill>
-                <a:latin typeface="Calibri"/>
-              </a:rPr>
-              <a:t>✓  Registered raster aligned to reference grid (registered_image.tif)</a:t>
-            </a:r>
-          </a:p>
-        </p:txBody>
-      </p:sp>
-      <p:sp>
-        <p:nvSpPr>
-          <p:cNvPr id="39" name="TextBox 38"/>
-          <p:cNvSpPr txBox="1"/>
-          <p:nvPr/>
-        </p:nvSpPr>
-        <p:spPr>
-          <a:xfrm>
-            <a:off x="7726679" y="4041648"/>
-            <a:ext cx="4160520" cy="201168"/>
-          </a:xfrm>
-          <a:prstGeom prst="rect">
-            <a:avLst/>
-          </a:prstGeom>
-          <a:noFill/>
-        </p:spPr>
-        <p:txBody>
-          <a:bodyPr wrap="square">
-            <a:spAutoFit/>
-          </a:bodyPr>
-          <a:lstStyle/>
-          <a:p>
-            <a:pPr algn="l"/>
-            <a:r>
-              <a:rPr sz="750" b="0" i="0">
-                <a:solidFill>
-                  <a:srgbClr val="1A2B35"/>
-                </a:solidFill>
-                <a:latin typeface="Calibri"/>
-              </a:rPr>
-              <a:t>✓  Operator diagnostic checkerboard overlay (checkerboard_overlay.png)</a:t>
-            </a:r>
-          </a:p>
-        </p:txBody>
-      </p:sp>
-      <p:sp>
-        <p:nvSpPr>
-          <p:cNvPr id="40" name="TextBox 39"/>
-          <p:cNvSpPr txBox="1"/>
-          <p:nvPr/>
-        </p:nvSpPr>
-        <p:spPr>
-          <a:xfrm>
-            <a:off x="7726679" y="4261104"/>
-            <a:ext cx="4160520" cy="201168"/>
-          </a:xfrm>
-          <a:prstGeom prst="rect">
-            <a:avLst/>
-          </a:prstGeom>
-          <a:noFill/>
-        </p:spPr>
-        <p:txBody>
-          <a:bodyPr wrap="square">
-            <a:spAutoFit/>
-          </a:bodyPr>
-          <a:lstStyle/>
-          <a:p>
-            <a:pPr algn="l"/>
-            <a:r>
-              <a:rPr sz="750" b="0" i="0">
-                <a:solidFill>
-                  <a:srgbClr val="1A2B35"/>
-                </a:solidFill>
-                <a:latin typeface="Calibri"/>
-              </a:rPr>
-              <a:t>✓  Automated test suite with frozen benchmark seeds</a:t>
-            </a:r>
-          </a:p>
-        </p:txBody>
-      </p:sp>
-      <p:sp>
-        <p:nvSpPr>
-          <p:cNvPr id="41" name="Rectangle 40"/>
+              <a:t>Directly addresses lunar illumination physics via LCN and DEM reflectance simulation, designed to mitigate illumination-induced correspondence collapse across extreme sun angles.</a:t>
+            </a:r>
+          </a:p>
+        </p:txBody>
+      </p:sp>
+      <p:sp>
+        <p:nvSpPr>
+          <p:cNvPr id="28" name="Rectangle 27"/>
           <p:cNvSpPr/>
           <p:nvPr/>
         </p:nvSpPr>
         <p:spPr>
           <a:xfrm>
-            <a:off x="7635240" y="4608576"/>
-            <a:ext cx="4343400" cy="182880"/>
+            <a:off x="7635240" y="1956816"/>
+            <a:ext cx="4343400" cy="868680"/>
+          </a:xfrm>
+          <a:prstGeom prst="rect">
+            <a:avLst/>
+          </a:prstGeom>
+          <a:solidFill>
+            <a:srgbClr val="F4F6F8"/>
+          </a:solidFill>
+          <a:ln w="5080">
+            <a:solidFill>
+              <a:srgbClr val="D0D8DD"/>
+            </a:solidFill>
+          </a:ln>
+        </p:spPr>
+        <p:style>
+          <a:lnRef idx="1">
+            <a:schemeClr val="accent1"/>
+          </a:lnRef>
+          <a:fillRef idx="3">
+            <a:schemeClr val="accent1"/>
+          </a:fillRef>
+          <a:effectRef idx="2">
+            <a:schemeClr val="accent1"/>
+          </a:effectRef>
+          <a:fontRef idx="minor">
+            <a:schemeClr val="lt1"/>
+          </a:fontRef>
+        </p:style>
+        <p:txBody>
+          <a:bodyPr rtlCol="0" anchor="ctr"/>
+          <a:lstStyle/>
+          <a:p>
+            <a:pPr algn="ctr"/>
+          </a:p>
+        </p:txBody>
+      </p:sp>
+      <p:sp>
+        <p:nvSpPr>
+          <p:cNvPr id="29" name="Rectangle 28"/>
+          <p:cNvSpPr/>
+          <p:nvPr/>
+        </p:nvSpPr>
+        <p:spPr>
+          <a:xfrm>
+            <a:off x="7635240" y="1956816"/>
+            <a:ext cx="91440" cy="868680"/>
           </a:xfrm>
           <a:prstGeom prst="rect">
             <a:avLst/>
@@ -15809,35 +15379,491 @@
       </p:sp>
       <p:sp>
         <p:nvSpPr>
+          <p:cNvPr id="30" name="TextBox 29"/>
+          <p:cNvSpPr txBox="1"/>
+          <p:nvPr/>
+        </p:nvSpPr>
+        <p:spPr>
+          <a:xfrm>
+            <a:off x="7818120" y="2011680"/>
+            <a:ext cx="4069080" cy="201168"/>
+          </a:xfrm>
+          <a:prstGeom prst="rect">
+            <a:avLst/>
+          </a:prstGeom>
+          <a:noFill/>
+        </p:spPr>
+        <p:txBody>
+          <a:bodyPr wrap="square">
+            <a:spAutoFit/>
+          </a:bodyPr>
+          <a:lstStyle/>
+          <a:p>
+            <a:pPr algn="l"/>
+            <a:r>
+              <a:rPr sz="900" b="1" i="0">
+                <a:solidFill>
+                  <a:srgbClr val="147D77"/>
+                </a:solidFill>
+                <a:latin typeface="Calibri"/>
+              </a:rPr>
+              <a:t>2. Adaptive Geometry for Relief</a:t>
+            </a:r>
+          </a:p>
+        </p:txBody>
+      </p:sp>
+      <p:sp>
+        <p:nvSpPr>
+          <p:cNvPr id="31" name="TextBox 30"/>
+          <p:cNvSpPr txBox="1"/>
+          <p:nvPr/>
+        </p:nvSpPr>
+        <p:spPr>
+          <a:xfrm>
+            <a:off x="7818120" y="2231136"/>
+            <a:ext cx="4069080" cy="548640"/>
+          </a:xfrm>
+          <a:prstGeom prst="rect">
+            <a:avLst/>
+          </a:prstGeom>
+          <a:noFill/>
+        </p:spPr>
+        <p:txBody>
+          <a:bodyPr wrap="square">
+            <a:spAutoFit/>
+          </a:bodyPr>
+          <a:lstStyle/>
+          <a:p>
+            <a:pPr algn="l"/>
+            <a:r>
+              <a:rPr sz="800" b="0" i="0">
+                <a:solidFill>
+                  <a:srgbClr val="1A2B35"/>
+                </a:solidFill>
+                <a:latin typeface="Calibri"/>
+              </a:rPr>
+              <a:t>Coherence-gated TPS elastic warping compensates apparent relief-induced 2D displacement without forcing an oversimplified planar homography across complex 3D crater terrain.</a:t>
+            </a:r>
+          </a:p>
+        </p:txBody>
+      </p:sp>
+      <p:sp>
+        <p:nvSpPr>
+          <p:cNvPr id="32" name="Rectangle 31"/>
+          <p:cNvSpPr/>
+          <p:nvPr/>
+        </p:nvSpPr>
+        <p:spPr>
+          <a:xfrm>
+            <a:off x="7635240" y="2944368"/>
+            <a:ext cx="4343400" cy="868680"/>
+          </a:xfrm>
+          <a:prstGeom prst="rect">
+            <a:avLst/>
+          </a:prstGeom>
+          <a:solidFill>
+            <a:srgbClr val="F4F6F8"/>
+          </a:solidFill>
+          <a:ln w="5080">
+            <a:solidFill>
+              <a:srgbClr val="D0D8DD"/>
+            </a:solidFill>
+          </a:ln>
+        </p:spPr>
+        <p:style>
+          <a:lnRef idx="1">
+            <a:schemeClr val="accent1"/>
+          </a:lnRef>
+          <a:fillRef idx="3">
+            <a:schemeClr val="accent1"/>
+          </a:fillRef>
+          <a:effectRef idx="2">
+            <a:schemeClr val="accent1"/>
+          </a:effectRef>
+          <a:fontRef idx="minor">
+            <a:schemeClr val="lt1"/>
+          </a:fontRef>
+        </p:style>
+        <p:txBody>
+          <a:bodyPr rtlCol="0" anchor="ctr"/>
+          <a:lstStyle/>
+          <a:p>
+            <a:pPr algn="ctr"/>
+          </a:p>
+        </p:txBody>
+      </p:sp>
+      <p:sp>
+        <p:nvSpPr>
+          <p:cNvPr id="33" name="Rectangle 32"/>
+          <p:cNvSpPr/>
+          <p:nvPr/>
+        </p:nvSpPr>
+        <p:spPr>
+          <a:xfrm>
+            <a:off x="7635240" y="2944368"/>
+            <a:ext cx="91440" cy="868680"/>
+          </a:xfrm>
+          <a:prstGeom prst="rect">
+            <a:avLst/>
+          </a:prstGeom>
+          <a:solidFill>
+            <a:srgbClr val="147D77"/>
+          </a:solidFill>
+          <a:ln>
+            <a:noFill/>
+          </a:ln>
+        </p:spPr>
+        <p:style>
+          <a:lnRef idx="1">
+            <a:schemeClr val="accent1"/>
+          </a:lnRef>
+          <a:fillRef idx="3">
+            <a:schemeClr val="accent1"/>
+          </a:fillRef>
+          <a:effectRef idx="2">
+            <a:schemeClr val="accent1"/>
+          </a:effectRef>
+          <a:fontRef idx="minor">
+            <a:schemeClr val="lt1"/>
+          </a:fontRef>
+        </p:style>
+        <p:txBody>
+          <a:bodyPr rtlCol="0" anchor="ctr"/>
+          <a:lstStyle/>
+          <a:p>
+            <a:pPr algn="ctr"/>
+          </a:p>
+        </p:txBody>
+      </p:sp>
+      <p:sp>
+        <p:nvSpPr>
+          <p:cNvPr id="34" name="TextBox 33"/>
+          <p:cNvSpPr txBox="1"/>
+          <p:nvPr/>
+        </p:nvSpPr>
+        <p:spPr>
+          <a:xfrm>
+            <a:off x="7818120" y="2999232"/>
+            <a:ext cx="4069080" cy="201168"/>
+          </a:xfrm>
+          <a:prstGeom prst="rect">
+            <a:avLst/>
+          </a:prstGeom>
+          <a:noFill/>
+        </p:spPr>
+        <p:txBody>
+          <a:bodyPr wrap="square">
+            <a:spAutoFit/>
+          </a:bodyPr>
+          <a:lstStyle/>
+          <a:p>
+            <a:pPr algn="l"/>
+            <a:r>
+              <a:rPr sz="900" b="1" i="0">
+                <a:solidFill>
+                  <a:srgbClr val="147D77"/>
+                </a:solidFill>
+                <a:latin typeface="Calibri"/>
+              </a:rPr>
+              <a:t>3. Fail-Safe Quality Control</a:t>
+            </a:r>
+          </a:p>
+        </p:txBody>
+      </p:sp>
+      <p:sp>
+        <p:nvSpPr>
+          <p:cNvPr id="35" name="TextBox 34"/>
+          <p:cNvSpPr txBox="1"/>
+          <p:nvPr/>
+        </p:nvSpPr>
+        <p:spPr>
+          <a:xfrm>
+            <a:off x="7818120" y="3218688"/>
+            <a:ext cx="4069080" cy="548640"/>
+          </a:xfrm>
+          <a:prstGeom prst="rect">
+            <a:avLst/>
+          </a:prstGeom>
+          <a:noFill/>
+        </p:spPr>
+        <p:txBody>
+          <a:bodyPr wrap="square">
+            <a:spAutoFit/>
+          </a:bodyPr>
+          <a:lstStyle/>
+          <a:p>
+            <a:pPr algn="l"/>
+            <a:r>
+              <a:rPr sz="800" b="0" i="0">
+                <a:solidFill>
+                  <a:srgbClr val="1A2B35"/>
+                </a:solidFill>
+                <a:latin typeface="Calibri"/>
+              </a:rPr>
+              <a:t>Rejects invalid or ambiguous registrations with explicit reason codes rather than forcing alignment on unmatchable scenes (proven via disjoint negative control pair).</a:t>
+            </a:r>
+          </a:p>
+        </p:txBody>
+      </p:sp>
+      <p:sp>
+        <p:nvSpPr>
+          <p:cNvPr id="36" name="Rectangle 35"/>
+          <p:cNvSpPr/>
+          <p:nvPr/>
+        </p:nvSpPr>
+        <p:spPr>
+          <a:xfrm>
+            <a:off x="7635240" y="3931920"/>
+            <a:ext cx="4343400" cy="182880"/>
+          </a:xfrm>
+          <a:prstGeom prst="rect">
+            <a:avLst/>
+          </a:prstGeom>
+          <a:solidFill>
+            <a:srgbClr val="147D77"/>
+          </a:solidFill>
+          <a:ln>
+            <a:noFill/>
+          </a:ln>
+        </p:spPr>
+        <p:style>
+          <a:lnRef idx="1">
+            <a:schemeClr val="accent1"/>
+          </a:lnRef>
+          <a:fillRef idx="3">
+            <a:schemeClr val="accent1"/>
+          </a:fillRef>
+          <a:effectRef idx="2">
+            <a:schemeClr val="accent1"/>
+          </a:effectRef>
+          <a:fontRef idx="minor">
+            <a:schemeClr val="lt1"/>
+          </a:fontRef>
+        </p:style>
+        <p:txBody>
+          <a:bodyPr rtlCol="0" anchor="ctr"/>
+          <a:lstStyle/>
+          <a:p>
+            <a:pPr algn="ctr"/>
+          </a:p>
+        </p:txBody>
+      </p:sp>
+      <p:sp>
+        <p:nvSpPr>
+          <p:cNvPr id="37" name="TextBox 36"/>
+          <p:cNvSpPr txBox="1"/>
+          <p:nvPr/>
+        </p:nvSpPr>
+        <p:spPr>
+          <a:xfrm>
+            <a:off x="7726679" y="3950207"/>
+            <a:ext cx="4206240" cy="182880"/>
+          </a:xfrm>
+          <a:prstGeom prst="rect">
+            <a:avLst/>
+          </a:prstGeom>
+          <a:noFill/>
+        </p:spPr>
+        <p:txBody>
+          <a:bodyPr wrap="square">
+            <a:spAutoFit/>
+          </a:bodyPr>
+          <a:lstStyle/>
+          <a:p>
+            <a:pPr algn="l"/>
+            <a:r>
+              <a:rPr sz="750" b="1" i="0">
+                <a:solidFill>
+                  <a:srgbClr val="FFFFFF"/>
+                </a:solidFill>
+                <a:latin typeface="Calibri"/>
+              </a:rPr>
+              <a:t>PROJECT REPOSITORY &amp; DETAILS</a:t>
+            </a:r>
+          </a:p>
+        </p:txBody>
+      </p:sp>
+      <p:sp>
+        <p:nvSpPr>
+          <p:cNvPr id="38" name="Rectangle 37"/>
+          <p:cNvSpPr/>
+          <p:nvPr/>
+        </p:nvSpPr>
+        <p:spPr>
+          <a:xfrm>
+            <a:off x="7635240" y="4151376"/>
+            <a:ext cx="4343400" cy="1920240"/>
+          </a:xfrm>
+          <a:prstGeom prst="rect">
+            <a:avLst/>
+          </a:prstGeom>
+          <a:solidFill>
+            <a:srgbClr val="F4F6F8"/>
+          </a:solidFill>
+          <a:ln w="5080">
+            <a:solidFill>
+              <a:srgbClr val="D0D8DD"/>
+            </a:solidFill>
+          </a:ln>
+        </p:spPr>
+        <p:style>
+          <a:lnRef idx="1">
+            <a:schemeClr val="accent1"/>
+          </a:lnRef>
+          <a:fillRef idx="3">
+            <a:schemeClr val="accent1"/>
+          </a:fillRef>
+          <a:effectRef idx="2">
+            <a:schemeClr val="accent1"/>
+          </a:effectRef>
+          <a:fontRef idx="minor">
+            <a:schemeClr val="lt1"/>
+          </a:fontRef>
+        </p:style>
+        <p:txBody>
+          <a:bodyPr rtlCol="0" anchor="ctr"/>
+          <a:lstStyle/>
+          <a:p>
+            <a:pPr algn="ctr"/>
+          </a:p>
+        </p:txBody>
+      </p:sp>
+      <p:sp>
+        <p:nvSpPr>
+          <p:cNvPr id="39" name="TextBox 38"/>
+          <p:cNvSpPr txBox="1"/>
+          <p:nvPr/>
+        </p:nvSpPr>
+        <p:spPr>
+          <a:xfrm>
+            <a:off x="7772400" y="4224528"/>
+            <a:ext cx="1188720" cy="219456"/>
+          </a:xfrm>
+          <a:prstGeom prst="rect">
+            <a:avLst/>
+          </a:prstGeom>
+          <a:noFill/>
+        </p:spPr>
+        <p:txBody>
+          <a:bodyPr wrap="square">
+            <a:spAutoFit/>
+          </a:bodyPr>
+          <a:lstStyle/>
+          <a:p>
+            <a:pPr algn="l"/>
+            <a:r>
+              <a:rPr sz="800" b="1" i="0">
+                <a:solidFill>
+                  <a:srgbClr val="147D77"/>
+                </a:solidFill>
+                <a:latin typeface="Calibri"/>
+              </a:rPr>
+              <a:t>GitHub (Public):</a:t>
+            </a:r>
+          </a:p>
+        </p:txBody>
+      </p:sp>
+      <p:sp>
+        <p:nvSpPr>
+          <p:cNvPr id="40" name="TextBox 39"/>
+          <p:cNvSpPr txBox="1"/>
+          <p:nvPr/>
+        </p:nvSpPr>
+        <p:spPr>
+          <a:xfrm>
+            <a:off x="9006840" y="4224528"/>
+            <a:ext cx="2880360" cy="219456"/>
+          </a:xfrm>
+          <a:prstGeom prst="rect">
+            <a:avLst/>
+          </a:prstGeom>
+          <a:noFill/>
+        </p:spPr>
+        <p:txBody>
+          <a:bodyPr wrap="square">
+            <a:spAutoFit/>
+          </a:bodyPr>
+          <a:lstStyle/>
+          <a:p>
+            <a:pPr algn="l"/>
+            <a:r>
+              <a:rPr sz="800" b="1" i="0">
+                <a:solidFill>
+                  <a:srgbClr val="1A2B35"/>
+                </a:solidFill>
+                <a:latin typeface="Calibri"/>
+              </a:rPr>
+              <a:t>github.com/TanukuSai/luna-corr</a:t>
+            </a:r>
+          </a:p>
+        </p:txBody>
+      </p:sp>
+      <p:sp>
+        <p:nvSpPr>
+          <p:cNvPr id="41" name="TextBox 40"/>
+          <p:cNvSpPr txBox="1"/>
+          <p:nvPr/>
+        </p:nvSpPr>
+        <p:spPr>
+          <a:xfrm>
+            <a:off x="7772400" y="4553712"/>
+            <a:ext cx="1188720" cy="219456"/>
+          </a:xfrm>
+          <a:prstGeom prst="rect">
+            <a:avLst/>
+          </a:prstGeom>
+          <a:noFill/>
+        </p:spPr>
+        <p:txBody>
+          <a:bodyPr wrap="square">
+            <a:spAutoFit/>
+          </a:bodyPr>
+          <a:lstStyle/>
+          <a:p>
+            <a:pPr algn="l"/>
+            <a:r>
+              <a:rPr sz="800" b="1" i="0">
+                <a:solidFill>
+                  <a:srgbClr val="147D77"/>
+                </a:solidFill>
+                <a:latin typeface="Calibri"/>
+              </a:rPr>
+              <a:t>Team Name:</a:t>
+            </a:r>
+          </a:p>
+        </p:txBody>
+      </p:sp>
+      <p:sp>
+        <p:nvSpPr>
           <p:cNvPr id="42" name="TextBox 41"/>
           <p:cNvSpPr txBox="1"/>
           <p:nvPr/>
         </p:nvSpPr>
         <p:spPr>
           <a:xfrm>
-            <a:off x="7726679" y="4626864"/>
-            <a:ext cx="4206240" cy="182880"/>
-          </a:xfrm>
-          <a:prstGeom prst="rect">
-            <a:avLst/>
-          </a:prstGeom>
-          <a:noFill/>
-        </p:spPr>
-        <p:txBody>
-          <a:bodyPr wrap="square">
-            <a:spAutoFit/>
-          </a:bodyPr>
-          <a:lstStyle/>
-          <a:p>
-            <a:pPr algn="l"/>
-            <a:r>
-              <a:rPr sz="750" b="1" i="0">
-                <a:solidFill>
-                  <a:srgbClr val="FFFFFF"/>
-                </a:solidFill>
-                <a:latin typeface="Calibri"/>
-              </a:rPr>
-              <a:t>REPOSITORY AND IDENTIFICATION</a:t>
+            <a:off x="9006840" y="4553712"/>
+            <a:ext cx="2880360" cy="219456"/>
+          </a:xfrm>
+          <a:prstGeom prst="rect">
+            <a:avLst/>
+          </a:prstGeom>
+          <a:noFill/>
+        </p:spPr>
+        <p:txBody>
+          <a:bodyPr wrap="square">
+            <a:spAutoFit/>
+          </a:bodyPr>
+          <a:lstStyle/>
+          <a:p>
+            <a:pPr algn="l"/>
+            <a:r>
+              <a:rPr sz="800" b="0" i="0">
+                <a:solidFill>
+                  <a:srgbClr val="1A2B35"/>
+                </a:solidFill>
+                <a:latin typeface="Calibri"/>
+              </a:rPr>
+              <a:t>R9@MedMitra (Team ID: 189281)</a:t>
             </a:r>
           </a:p>
         </p:txBody>
@@ -15850,106 +15876,211 @@
         </p:nvSpPr>
         <p:spPr>
           <a:xfrm>
-            <a:off x="7726679" y="4846320"/>
-            <a:ext cx="4160520" cy="201168"/>
-          </a:xfrm>
-          <a:prstGeom prst="rect">
-            <a:avLst/>
-          </a:prstGeom>
-          <a:noFill/>
-        </p:spPr>
-        <p:txBody>
-          <a:bodyPr wrap="square">
-            <a:spAutoFit/>
-          </a:bodyPr>
-          <a:lstStyle/>
-          <a:p>
-            <a:pPr algn="l"/>
-            <a:r>
-              <a:rPr sz="900" b="1" i="0">
+            <a:off x="7772400" y="4882896"/>
+            <a:ext cx="1188720" cy="219456"/>
+          </a:xfrm>
+          <a:prstGeom prst="rect">
+            <a:avLst/>
+          </a:prstGeom>
+          <a:noFill/>
+        </p:spPr>
+        <p:txBody>
+          <a:bodyPr wrap="square">
+            <a:spAutoFit/>
+          </a:bodyPr>
+          <a:lstStyle/>
+          <a:p>
+            <a:pPr algn="l"/>
+            <a:r>
+              <a:rPr sz="800" b="1" i="0">
+                <a:solidFill>
+                  <a:srgbClr val="147D77"/>
+                </a:solidFill>
+                <a:latin typeface="Calibri"/>
+              </a:rPr>
+              <a:t>Problem Stmt:</a:t>
+            </a:r>
+          </a:p>
+        </p:txBody>
+      </p:sp>
+      <p:sp>
+        <p:nvSpPr>
+          <p:cNvPr id="44" name="TextBox 43"/>
+          <p:cNvSpPr txBox="1"/>
+          <p:nvPr/>
+        </p:nvSpPr>
+        <p:spPr>
+          <a:xfrm>
+            <a:off x="9006840" y="4882896"/>
+            <a:ext cx="2880360" cy="219456"/>
+          </a:xfrm>
+          <a:prstGeom prst="rect">
+            <a:avLst/>
+          </a:prstGeom>
+          <a:noFill/>
+        </p:spPr>
+        <p:txBody>
+          <a:bodyPr wrap="square">
+            <a:spAutoFit/>
+          </a:bodyPr>
+          <a:lstStyle/>
+          <a:p>
+            <a:pPr algn="l"/>
+            <a:r>
+              <a:rPr sz="800" b="0" i="0">
                 <a:solidFill>
                   <a:srgbClr val="1A2B35"/>
                 </a:solidFill>
                 <a:latin typeface="Calibri"/>
               </a:rPr>
-              <a:t>GitHub (public):  github.com/TanukuSai/luna-corr</a:t>
-            </a:r>
-          </a:p>
-        </p:txBody>
-      </p:sp>
-      <p:sp>
-        <p:nvSpPr>
-          <p:cNvPr id="44" name="TextBox 43"/>
-          <p:cNvSpPr txBox="1"/>
-          <p:nvPr/>
-        </p:nvSpPr>
-        <p:spPr>
-          <a:xfrm>
-            <a:off x="7726679" y="5102352"/>
-            <a:ext cx="4160520" cy="201168"/>
-          </a:xfrm>
-          <a:prstGeom prst="rect">
-            <a:avLst/>
-          </a:prstGeom>
-          <a:noFill/>
-        </p:spPr>
-        <p:txBody>
-          <a:bodyPr wrap="square">
-            <a:spAutoFit/>
-          </a:bodyPr>
-          <a:lstStyle/>
-          <a:p>
-            <a:pPr algn="l"/>
-            <a:r>
-              <a:rPr sz="850" b="0" i="0">
+              <a:t>PS 26166 | Space Applications Centre (SAC), ISRO</a:t>
+            </a:r>
+          </a:p>
+        </p:txBody>
+      </p:sp>
+      <p:sp>
+        <p:nvSpPr>
+          <p:cNvPr id="45" name="TextBox 44"/>
+          <p:cNvSpPr txBox="1"/>
+          <p:nvPr/>
+        </p:nvSpPr>
+        <p:spPr>
+          <a:xfrm>
+            <a:off x="7772400" y="5212080"/>
+            <a:ext cx="1188720" cy="219456"/>
+          </a:xfrm>
+          <a:prstGeom prst="rect">
+            <a:avLst/>
+          </a:prstGeom>
+          <a:noFill/>
+        </p:spPr>
+        <p:txBody>
+          <a:bodyPr wrap="square">
+            <a:spAutoFit/>
+          </a:bodyPr>
+          <a:lstStyle/>
+          <a:p>
+            <a:pPr algn="l"/>
+            <a:r>
+              <a:rPr sz="800" b="1" i="0">
+                <a:solidFill>
+                  <a:srgbClr val="147D77"/>
+                </a:solidFill>
+                <a:latin typeface="Calibri"/>
+              </a:rPr>
+              <a:t>Theme / Category:</a:t>
+            </a:r>
+          </a:p>
+        </p:txBody>
+      </p:sp>
+      <p:sp>
+        <p:nvSpPr>
+          <p:cNvPr id="46" name="TextBox 45"/>
+          <p:cNvSpPr txBox="1"/>
+          <p:nvPr/>
+        </p:nvSpPr>
+        <p:spPr>
+          <a:xfrm>
+            <a:off x="9006840" y="5212080"/>
+            <a:ext cx="2880360" cy="219456"/>
+          </a:xfrm>
+          <a:prstGeom prst="rect">
+            <a:avLst/>
+          </a:prstGeom>
+          <a:noFill/>
+        </p:spPr>
+        <p:txBody>
+          <a:bodyPr wrap="square">
+            <a:spAutoFit/>
+          </a:bodyPr>
+          <a:lstStyle/>
+          <a:p>
+            <a:pPr algn="l"/>
+            <a:r>
+              <a:rPr sz="800" b="0" i="0">
                 <a:solidFill>
                   <a:srgbClr val="1A2B35"/>
                 </a:solidFill>
                 <a:latin typeface="Calibri"/>
               </a:rPr>
-              <a:t>Team:  R9@MedMitra  |  Team ID 189281</a:t>
-            </a:r>
-          </a:p>
-        </p:txBody>
-      </p:sp>
-      <p:sp>
-        <p:nvSpPr>
-          <p:cNvPr id="45" name="TextBox 44"/>
-          <p:cNvSpPr txBox="1"/>
-          <p:nvPr/>
-        </p:nvSpPr>
-        <p:spPr>
-          <a:xfrm>
-            <a:off x="7726679" y="5358384"/>
-            <a:ext cx="4160520" cy="201168"/>
-          </a:xfrm>
-          <a:prstGeom prst="rect">
-            <a:avLst/>
-          </a:prstGeom>
-          <a:noFill/>
-        </p:spPr>
-        <p:txBody>
-          <a:bodyPr wrap="square">
-            <a:spAutoFit/>
-          </a:bodyPr>
-          <a:lstStyle/>
-          <a:p>
-            <a:pPr algn="l"/>
-            <a:r>
-              <a:rPr sz="850" b="0" i="0">
+              <a:t>Space Technology  |  Software</a:t>
+            </a:r>
+          </a:p>
+        </p:txBody>
+      </p:sp>
+      <p:sp>
+        <p:nvSpPr>
+          <p:cNvPr id="47" name="TextBox 46"/>
+          <p:cNvSpPr txBox="1"/>
+          <p:nvPr/>
+        </p:nvSpPr>
+        <p:spPr>
+          <a:xfrm>
+            <a:off x="7772400" y="5541264"/>
+            <a:ext cx="1188720" cy="219456"/>
+          </a:xfrm>
+          <a:prstGeom prst="rect">
+            <a:avLst/>
+          </a:prstGeom>
+          <a:noFill/>
+        </p:spPr>
+        <p:txBody>
+          <a:bodyPr wrap="square">
+            <a:spAutoFit/>
+          </a:bodyPr>
+          <a:lstStyle/>
+          <a:p>
+            <a:pPr algn="l"/>
+            <a:r>
+              <a:rPr sz="800" b="1" i="0">
+                <a:solidFill>
+                  <a:srgbClr val="147D77"/>
+                </a:solidFill>
+                <a:latin typeface="Calibri"/>
+              </a:rPr>
+              <a:t>Deliverables:</a:t>
+            </a:r>
+          </a:p>
+        </p:txBody>
+      </p:sp>
+      <p:sp>
+        <p:nvSpPr>
+          <p:cNvPr id="48" name="TextBox 47"/>
+          <p:cNvSpPr txBox="1"/>
+          <p:nvPr/>
+        </p:nvSpPr>
+        <p:spPr>
+          <a:xfrm>
+            <a:off x="9006840" y="5541264"/>
+            <a:ext cx="2880360" cy="219456"/>
+          </a:xfrm>
+          <a:prstGeom prst="rect">
+            <a:avLst/>
+          </a:prstGeom>
+          <a:noFill/>
+        </p:spPr>
+        <p:txBody>
+          <a:bodyPr wrap="square">
+            <a:spAutoFit/>
+          </a:bodyPr>
+          <a:lstStyle/>
+          <a:p>
+            <a:pPr algn="l"/>
+            <a:r>
+              <a:rPr sz="800" b="0" i="0">
                 <a:solidFill>
                   <a:srgbClr val="1A2B35"/>
                 </a:solidFill>
                 <a:latin typeface="Calibri"/>
               </a:rPr>
-              <a:t>PS:    26166  |  Space Applications Centre (SAC), ISRO</a:t>
-            </a:r>
-          </a:p>
-        </p:txBody>
-      </p:sp>
-      <p:sp>
-        <p:nvSpPr>
-          <p:cNvPr id="46" name="Rectangle 45"/>
+              <a:t>Python package (lunacorr), CLI, benchmarks, test suite</a:t>
+            </a:r>
+          </a:p>
+        </p:txBody>
+      </p:sp>
+      <p:sp>
+        <p:nvSpPr>
+          <p:cNvPr id="49" name="Rectangle 48"/>
           <p:cNvSpPr/>
           <p:nvPr/>
         </p:nvSpPr>
@@ -15992,7 +16123,7 @@
       </p:sp>
       <p:sp>
         <p:nvSpPr>
-          <p:cNvPr id="47" name="TextBox 46"/>
+          <p:cNvPr id="50" name="TextBox 49"/>
           <p:cNvSpPr txBox="1"/>
           <p:nvPr/>
         </p:nvSpPr>

</xml_diff>

<commit_message>
fix(sign-off): synchronize PPT canonical 0.836px / 47.9%, align report epsilon to 0.05px, clarify Mode C branch architecture, and soften negative control claims
</commit_message>
<xml_diff>
--- a/LUNA-CORR_SIH2026_Presentation.pptx
+++ b/LUNA-CORR_SIH2026_Presentation.pptx
@@ -3971,7 +3971,7 @@
                 <a:latin typeface="Calibri"/>
               </a:rPr>
               <a:t>• EXP-OHRC-E2E: 822 inliers (99.2% ratio)  ·  Held-out RMSE: 0.679 px (N=165 withheld, TPS Warping Accepted)
-• EXP-TMC-FIXED: 1.61 px → 0.84 px RMSE (47.9% gain vs Stage 3, N=150)  |  EXP-TMC-E2E: 686 inliers, 1.110 px RMSE</a:t>
+• EXP-TMC-FIXED: 1.606 px → 0.836 px RMSE (47.9% gain vs Stage 3, N=150)  |  EXP-TMC-E2E: 686 inliers, 1.110 px RMSE</a:t>
             </a:r>
           </a:p>
         </p:txBody>
@@ -5493,7 +5493,7 @@
                 </a:solidFill>
                 <a:latin typeface="Calibri"/>
               </a:rPr>
-              <a:t>▸  LCN + Mode C DEM Rendering (Physics Branch): Normalizes dynamic range; simulates DEM at target sun angle.</a:t>
+              <a:t>▸  LCN Normalization (Core E2E) / Mode C (Physics Branch): LCN normalizes dynamic range; branch simulates DEM at target sun angle.</a:t>
             </a:r>
           </a:p>
         </p:txBody>
@@ -5818,7 +5818,7 @@
                 </a:solidFill>
                 <a:latin typeface="Calibri"/>
               </a:rPr>
-              <a:t>▸  Disjoint Safe Failure: 1/1 disjoint scene pair rejected; system fails safely.</a:t>
+              <a:t>▸  Disjoint Safe Failure: Tested disjoint pair rejected without accepted registration.</a:t>
             </a:r>
           </a:p>
         </p:txBody>
@@ -6306,7 +6306,7 @@
                 </a:solidFill>
                 <a:latin typeface="Calibri"/>
               </a:rPr>
-              <a:t>END-TO-END 8-STAGE PIPELINE FLOW</a:t>
+              <a:t>CORE 8-STAGE E2E PIPELINE FLOW  /  EXPERIMENTAL PHYSICS BRANCH</a:t>
             </a:r>
           </a:p>
         </p:txBody>
@@ -6486,9 +6486,9 @@
           <a:solidFill>
             <a:srgbClr val="F4F6F8"/>
           </a:solidFill>
-          <a:ln w="6350">
+          <a:ln w="10160">
             <a:solidFill>
-              <a:srgbClr val="D0D8DD"/>
+              <a:srgbClr val="147D77"/>
             </a:solidFill>
           </a:ln>
         </p:spPr>
@@ -6600,8 +6600,8 @@
         </p:nvSpPr>
         <p:spPr>
           <a:xfrm>
-            <a:off x="1920239" y="1865376"/>
-            <a:ext cx="1261872" cy="502920"/>
+            <a:off x="1911095" y="1847088"/>
+            <a:ext cx="1280160" cy="530352"/>
           </a:xfrm>
           <a:prstGeom prst="rect">
             <a:avLst/>
@@ -6616,14 +6616,16 @@
           <a:p>
             <a:pPr algn="ctr"/>
             <a:r>
-              <a:rPr sz="780" b="0" i="0">
+              <a:rPr sz="680" b="0" i="0">
                 <a:solidFill>
                   <a:srgbClr val="1A2B35"/>
                 </a:solidFill>
                 <a:latin typeface="Calibri"/>
               </a:rPr>
-              <a:t>LCN normalization
-[Mode C: Physics branch]</a:t>
+              <a:t>LCN Normalization (Core)
+─────────────────
+Branch: Mode C DEM
+(Physics branch)</a:t>
             </a:r>
           </a:p>
         </p:txBody>
@@ -7788,7 +7790,7 @@
                 </a:solidFill>
                 <a:latin typeface="Calibri"/>
               </a:rPr>
-              <a:t>Held-out RMSE: 1.110 px (fitting: 0.841 px, N=138)  |  EXP-TMC-FIXED (N=150): 1.61 → 0.836 px (47.9% gain)</a:t>
+              <a:t>Held-out RMSE: 1.110 px (fitting: 0.841 px, N=138)  |  EXP-TMC-FIXED (N=150): 1.606 → 0.836 px (47.9% gain)</a:t>
             </a:r>
           </a:p>
         </p:txBody>
@@ -11086,7 +11088,7 @@
                 <a:latin typeface="Calibri"/>
               </a:rPr>
               <a:t>• Tested on completely disjoint lunar scenes: South Pole OHRC vs Equatorial TMC-2.
-• Result: 1/1 tested pair rejected; 5 candidates retained; QualityGate refused alignment with typed codes ['LOW_INLIERS', 'LOW_COVERAGE']. Zero false acceptance.</a:t>
+• Result: The tested disjoint pair was rejected without an accepted registration; 5 candidates retained; QualityGate refused alignment with typed codes ['LOW_INLIERS', 'LOW_COVERAGE'].</a:t>
             </a:r>
           </a:p>
         </p:txBody>
@@ -11723,8 +11725,8 @@
               </a:rPr>
               <a:t>✓ EXP-OHRC-E2E: 822 inliers, held-out RMSE 0.679 px
 ✓ EXP-TMC-E2E: 686 inliers, held-out RMSE 1.110 px
-✓ EXP-TMC-FIXED: 1.61 → 0.836 px (47.9% gain on N=150)
-✓ Safe rejection: 1/1 disjoint scene pair rejected (0 accepted)</a:t>
+✓ EXP-TMC-FIXED: 1.606 → 0.836 px (47.9% gain on N=150)
+✓ Safe rejection: Tested disjoint pair rejected without accepted registration</a:t>
             </a:r>
           </a:p>
         </p:txBody>
@@ -14515,7 +14517,7 @@
                 </a:solidFill>
                 <a:latin typeface="Calibri"/>
               </a:rPr>
-              <a:t>Directly addresses lunar illumination physics via LCN and DEM reflectance simulation, designed to mitigate illumination-induced correspondence collapse across extreme sun angles.</a:t>
+              <a:t>Directly addresses lunar illumination physics via LCN (core pipeline) and DEM reflectance simulation (experimental branch) to mitigate correspondence collapse across extreme sun angles.</a:t>
             </a:r>
           </a:p>
         </p:txBody>
@@ -14831,7 +14833,7 @@
                 </a:solidFill>
                 <a:latin typeface="Calibri"/>
               </a:rPr>
-              <a:t>Rejects invalid or ambiguous registrations with explicit reason codes rather than forcing alignment on unmatchable scenes (demonstrated on a disjoint negative-control pair).</a:t>
+              <a:t>Rejects invalid or ambiguous registrations with explicit reason codes rather than forcing alignment on unmatchable scenes (demonstrated on disjoint negative-control test).</a:t>
             </a:r>
           </a:p>
         </p:txBody>

</xml_diff>

<commit_message>
fix(pipeline): resolve evaluation leakage with pre-split test set, integrate LCN, and synchronize canonical benchmarks
</commit_message>
<xml_diff>
--- a/LUNA-CORR_SIH2026_Presentation.pptx
+++ b/LUNA-CORR_SIH2026_Presentation.pptx
@@ -3970,8 +3970,8 @@
                 </a:solidFill>
                 <a:latin typeface="Calibri"/>
               </a:rPr>
-              <a:t>• EXP-OHRC-E2E: 822 inliers (99.2% ratio)  ·  Held-out RMSE: 0.679 px (N=165 withheld, TPS Warping Accepted)
-• EXP-TMC-FIXED: 1.606 px → 0.836 px RMSE (47.9% gain vs Stage 3, N=150)  |  EXP-TMC-E2E: 686 inliers, 1.110 px RMSE</a:t>
+              <a:t>• EXP-OHRC-E2E: 818 inliers (99.3% ratio)  ·  Held-out RMSE: 0.786 px (N=789 candidate split, TPS Warping Accepted)
+• EXP-TMC-FIXED: 1.606 px → 0.836 px RMSE (47.9% gain vs Stage 3, N=150)  |  EXP-TMC-E2E: 660 inliers, 1.073 px RMSE</a:t>
             </a:r>
           </a:p>
         </p:txBody>
@@ -7755,7 +7755,7 @@
                 </a:solidFill>
                 <a:latin typeface="Calibri"/>
               </a:rPr>
-              <a:t>TMC-2 STEREO — 686 INLIERS — ACCEPTED (EXP-TMC-E2E):</a:t>
+              <a:t>TMC-2 STEREO — 660 INLIERS — ACCEPTED (EXP-TMC-E2E):</a:t>
             </a:r>
           </a:p>
         </p:txBody>
@@ -7790,7 +7790,7 @@
                 </a:solidFill>
                 <a:latin typeface="Calibri"/>
               </a:rPr>
-              <a:t>Held-out RMSE: 1.110 px (fitting: 0.841 px, N=138)  |  EXP-TMC-FIXED (N=150): 1.606 → 0.836 px (47.9% gain)</a:t>
+              <a:t>Held-out RMSE: 1.073 px (fitting: 0.647 px, N=297)  |  EXP-TMC-FIXED (N=150): 1.606 → 0.836 px (47.9% gain)</a:t>
             </a:r>
           </a:p>
         </p:txBody>
@@ -9587,7 +9587,7 @@
                 </a:solidFill>
                 <a:latin typeface="Calibri"/>
               </a:rPr>
-              <a:t>0.679 px RMSE (822 inliers)</a:t>
+              <a:t>0.786 px RMSE (818 inliers)</a:t>
             </a:r>
           </a:p>
         </p:txBody>
@@ -9772,7 +9772,7 @@
                 </a:solidFill>
                 <a:latin typeface="Calibri"/>
               </a:rPr>
-              <a:t>1.110 px RMSE (686 inliers)</a:t>
+              <a:t>1.073 px RMSE (660 inliers)</a:t>
             </a:r>
           </a:p>
         </p:txBody>
@@ -10925,11 +10925,11 @@
                 </a:solidFill>
                 <a:latin typeface="Calibri"/>
               </a:rPr>
-              <a:t>• Match Yield &amp; Inliers: 686 inliers retained (77.0% ratio) from 891 raw candidate matches.
-• Spatial Coverage: 84.4% occupied bins across 8×8 grid; empty circle radius = 0.084.
-• Autonomous Model Selection: Spatial autocorrelation S_relief = 0.676 &gt; 0.20 and fitting P95 = 1.55 px triggered elastic TPS over planar homography.
-• Withheld Test Error (N=138): Held-out RMSE = 1.110 px (fitting: 0.841 px on N=548, median: 0.689 px, P95: 2.012 px).
-• Operational Decision: ACCEPTED with Quality Score 0.802 (min_inliers=20 criterion met).</a:t>
+              <a:t>• Match Yield &amp; Inliers: 660 inliers retained (76.1% ratio) on training partition.
+• Spatial Coverage: 81.2% occupied bins across 8×8 grid; empty circle radius = 0.084.
+• Autonomous Model Selection: Spatial autocorrelation S_relief = 0.725 &gt; 0.20 and fitting P95 = 1.43 px triggered elastic TPS over planar homography.
+• Withheld Test Error (N=297): Held-out RMSE = 1.073 px (fitting: 0.647 px on N=660, median: 0.656 px, P95: 2.072 px).
+• Operational Decision: ACCEPTED with Quality Score 0.742 (min_inliers=20 criterion met).</a:t>
             </a:r>
           </a:p>
         </p:txBody>
@@ -11723,8 +11723,8 @@
                 </a:solidFill>
                 <a:latin typeface="Calibri"/>
               </a:rPr>
-              <a:t>✓ EXP-OHRC-E2E: 822 inliers, held-out RMSE 0.679 px
-✓ EXP-TMC-E2E: 686 inliers, held-out RMSE 1.110 px
+              <a:t>✓ EXP-OHRC-E2E: 818 inliers, held-out RMSE 0.786 px
+✓ EXP-TMC-E2E: 660 inliers, held-out RMSE 1.073 px
 ✓ EXP-TMC-FIXED: 1.606 → 0.836 px (47.9% gain on N=150)
 ✓ Safe rejection: Tested disjoint pair rejected without accepted registration</a:t>
             </a:r>

</xml_diff>

<commit_message>
feat(ppt): integrate official SIH 2026 logo in top right across all slides
</commit_message>
<xml_diff>
--- a/LUNA-CORR_SIH2026_Presentation.pptx
+++ b/LUNA-CORR_SIH2026_Presentation.pptx
@@ -4042,8 +4042,8 @@
         </p:nvSpPr>
         <p:spPr>
           <a:xfrm>
-            <a:off x="4023360" y="228600"/>
-            <a:ext cx="8092440" cy="201168"/>
+            <a:off x="4023360" y="201168"/>
+            <a:ext cx="6537960" cy="201168"/>
           </a:xfrm>
           <a:prstGeom prst="rect">
             <a:avLst/>
@@ -4085,8 +4085,8 @@
         </p:nvSpPr>
         <p:spPr>
           <a:xfrm>
-            <a:off x="4096512" y="246888"/>
-            <a:ext cx="7982712" cy="201168"/>
+            <a:off x="4096512" y="219456"/>
+            <a:ext cx="6428232" cy="201168"/>
           </a:xfrm>
           <a:prstGeom prst="rect">
             <a:avLst/>
@@ -4121,7 +4121,7 @@
       </p:sp>
       <p:pic>
         <p:nvPicPr>
-          <p:cNvPr id="26" name="Picture 25" descr="fig1_title_hero.png"/>
+          <p:cNvPr id="26" name="Picture 25" descr="sih_logo.png"/>
           <p:cNvPicPr>
             <a:picLocks noChangeAspect="1"/>
           </p:cNvPicPr>
@@ -4135,6 +4135,30 @@
         </p:blipFill>
         <p:spPr>
           <a:xfrm>
+            <a:off x="10698480" y="36576"/>
+            <a:ext cx="1216152" cy="566928"/>
+          </a:xfrm>
+          <a:prstGeom prst="rect">
+            <a:avLst/>
+          </a:prstGeom>
+        </p:spPr>
+      </p:pic>
+      <p:pic>
+        <p:nvPicPr>
+          <p:cNvPr id="27" name="Picture 26" descr="fig1_title_hero.png"/>
+          <p:cNvPicPr>
+            <a:picLocks noChangeAspect="1"/>
+          </p:cNvPicPr>
+          <p:nvPr/>
+        </p:nvPicPr>
+        <p:blipFill>
+          <a:blip r:embed="rId3"/>
+          <a:stretch>
+            <a:fillRect/>
+          </a:stretch>
+        </p:blipFill>
+        <p:spPr>
+          <a:xfrm>
             <a:off x="4023360" y="457200"/>
             <a:ext cx="8092440" cy="2606040"/>
           </a:xfrm>
@@ -4145,7 +4169,7 @@
       </p:pic>
       <p:sp>
         <p:nvSpPr>
-          <p:cNvPr id="27" name="Rectangle 26"/>
+          <p:cNvPr id="28" name="Rectangle 27"/>
           <p:cNvSpPr/>
           <p:nvPr/>
         </p:nvSpPr>
@@ -4190,7 +4214,7 @@
       </p:sp>
       <p:sp>
         <p:nvSpPr>
-          <p:cNvPr id="28" name="TextBox 27"/>
+          <p:cNvPr id="29" name="TextBox 28"/>
           <p:cNvSpPr txBox="1"/>
           <p:nvPr/>
         </p:nvSpPr>
@@ -4232,7 +4256,7 @@
       </p:sp>
       <p:sp>
         <p:nvSpPr>
-          <p:cNvPr id="29" name="TextBox 28"/>
+          <p:cNvPr id="30" name="TextBox 29"/>
           <p:cNvSpPr txBox="1"/>
           <p:nvPr/>
         </p:nvSpPr>
@@ -4275,7 +4299,7 @@
       </p:sp>
       <p:sp>
         <p:nvSpPr>
-          <p:cNvPr id="30" name="Rectangle 29"/>
+          <p:cNvPr id="31" name="Rectangle 30"/>
           <p:cNvSpPr/>
           <p:nvPr/>
         </p:nvSpPr>
@@ -4292,7 +4316,7 @@
           </a:solidFill>
           <a:ln w="6350">
             <a:solidFill>
-              <a:srgbClr val="D0D8DD"/>
+              <a:srgbClr val="D0D8D9"/>
             </a:solidFill>
           </a:ln>
         </p:spPr>
@@ -4320,7 +4344,7 @@
       </p:sp>
       <p:sp>
         <p:nvSpPr>
-          <p:cNvPr id="31" name="Rectangle 30"/>
+          <p:cNvPr id="32" name="Rectangle 31"/>
           <p:cNvSpPr/>
           <p:nvPr/>
         </p:nvSpPr>
@@ -4363,7 +4387,7 @@
       </p:sp>
       <p:sp>
         <p:nvSpPr>
-          <p:cNvPr id="32" name="TextBox 31"/>
+          <p:cNvPr id="33" name="TextBox 32"/>
           <p:cNvSpPr txBox="1"/>
           <p:nvPr/>
         </p:nvSpPr>
@@ -4405,7 +4429,7 @@
       </p:sp>
       <p:sp>
         <p:nvSpPr>
-          <p:cNvPr id="33" name="TextBox 32"/>
+          <p:cNvPr id="34" name="TextBox 33"/>
           <p:cNvSpPr txBox="1"/>
           <p:nvPr/>
         </p:nvSpPr>
@@ -4447,7 +4471,7 @@
       </p:sp>
       <p:sp>
         <p:nvSpPr>
-          <p:cNvPr id="34" name="Rectangle 33"/>
+          <p:cNvPr id="35" name="Rectangle 34"/>
           <p:cNvSpPr/>
           <p:nvPr/>
         </p:nvSpPr>
@@ -4464,7 +4488,7 @@
           </a:solidFill>
           <a:ln w="6350">
             <a:solidFill>
-              <a:srgbClr val="D0D8DD"/>
+              <a:srgbClr val="D0D8D9"/>
             </a:solidFill>
           </a:ln>
         </p:spPr>
@@ -4492,7 +4516,7 @@
       </p:sp>
       <p:sp>
         <p:nvSpPr>
-          <p:cNvPr id="35" name="Rectangle 34"/>
+          <p:cNvPr id="36" name="Rectangle 35"/>
           <p:cNvSpPr/>
           <p:nvPr/>
         </p:nvSpPr>
@@ -4535,7 +4559,7 @@
       </p:sp>
       <p:sp>
         <p:nvSpPr>
-          <p:cNvPr id="36" name="TextBox 35"/>
+          <p:cNvPr id="37" name="TextBox 36"/>
           <p:cNvSpPr txBox="1"/>
           <p:nvPr/>
         </p:nvSpPr>
@@ -4577,7 +4601,7 @@
       </p:sp>
       <p:sp>
         <p:nvSpPr>
-          <p:cNvPr id="37" name="TextBox 36"/>
+          <p:cNvPr id="38" name="TextBox 37"/>
           <p:cNvSpPr txBox="1"/>
           <p:nvPr/>
         </p:nvSpPr>
@@ -4619,7 +4643,7 @@
       </p:sp>
       <p:sp>
         <p:nvSpPr>
-          <p:cNvPr id="38" name="Rectangle 37"/>
+          <p:cNvPr id="39" name="Rectangle 38"/>
           <p:cNvSpPr/>
           <p:nvPr/>
         </p:nvSpPr>
@@ -4636,7 +4660,7 @@
           </a:solidFill>
           <a:ln w="6350">
             <a:solidFill>
-              <a:srgbClr val="D0D8DD"/>
+              <a:srgbClr val="D0D8D9"/>
             </a:solidFill>
           </a:ln>
         </p:spPr>
@@ -4664,7 +4688,7 @@
       </p:sp>
       <p:sp>
         <p:nvSpPr>
-          <p:cNvPr id="39" name="Rectangle 38"/>
+          <p:cNvPr id="40" name="Rectangle 39"/>
           <p:cNvSpPr/>
           <p:nvPr/>
         </p:nvSpPr>
@@ -4707,7 +4731,7 @@
       </p:sp>
       <p:sp>
         <p:nvSpPr>
-          <p:cNvPr id="40" name="TextBox 39"/>
+          <p:cNvPr id="41" name="TextBox 40"/>
           <p:cNvSpPr txBox="1"/>
           <p:nvPr/>
         </p:nvSpPr>
@@ -4749,7 +4773,7 @@
       </p:sp>
       <p:sp>
         <p:nvSpPr>
-          <p:cNvPr id="41" name="TextBox 40"/>
+          <p:cNvPr id="42" name="TextBox 41"/>
           <p:cNvSpPr txBox="1"/>
           <p:nvPr/>
         </p:nvSpPr>
@@ -4791,7 +4815,7 @@
       </p:sp>
       <p:sp>
         <p:nvSpPr>
-          <p:cNvPr id="42" name="Rectangle 41"/>
+          <p:cNvPr id="43" name="Rectangle 42"/>
           <p:cNvSpPr/>
           <p:nvPr/>
         </p:nvSpPr>
@@ -4808,7 +4832,7 @@
           </a:solidFill>
           <a:ln w="6350">
             <a:solidFill>
-              <a:srgbClr val="D0D8DD"/>
+              <a:srgbClr val="D0D8D9"/>
             </a:solidFill>
           </a:ln>
         </p:spPr>
@@ -4836,7 +4860,7 @@
       </p:sp>
       <p:sp>
         <p:nvSpPr>
-          <p:cNvPr id="43" name="TextBox 42"/>
+          <p:cNvPr id="44" name="TextBox 43"/>
           <p:cNvSpPr txBox="1"/>
           <p:nvPr/>
         </p:nvSpPr>
@@ -4878,7 +4902,7 @@
       </p:sp>
       <p:sp>
         <p:nvSpPr>
-          <p:cNvPr id="44" name="TextBox 43"/>
+          <p:cNvPr id="45" name="TextBox 44"/>
           <p:cNvSpPr txBox="1"/>
           <p:nvPr/>
         </p:nvSpPr>
@@ -4920,7 +4944,7 @@
       </p:sp>
       <p:sp>
         <p:nvSpPr>
-          <p:cNvPr id="45" name="TextBox 44"/>
+          <p:cNvPr id="46" name="TextBox 45"/>
           <p:cNvSpPr txBox="1"/>
           <p:nvPr/>
         </p:nvSpPr>
@@ -4962,7 +4986,7 @@
       </p:sp>
       <p:sp>
         <p:nvSpPr>
-          <p:cNvPr id="46" name="Rectangle 45"/>
+          <p:cNvPr id="47" name="Rectangle 46"/>
           <p:cNvSpPr/>
           <p:nvPr/>
         </p:nvSpPr>
@@ -5007,7 +5031,7 @@
       </p:sp>
       <p:sp>
         <p:nvSpPr>
-          <p:cNvPr id="47" name="TextBox 46"/>
+          <p:cNvPr id="48" name="TextBox 47"/>
           <p:cNvSpPr txBox="1"/>
           <p:nvPr/>
         </p:nvSpPr>
@@ -5049,7 +5073,7 @@
       </p:sp>
       <p:sp>
         <p:nvSpPr>
-          <p:cNvPr id="48" name="TextBox 47"/>
+          <p:cNvPr id="49" name="TextBox 48"/>
           <p:cNvSpPr txBox="1"/>
           <p:nvPr/>
         </p:nvSpPr>
@@ -5076,7 +5100,7 @@
                   <a:srgbClr val="147D77"/>
                 </a:solidFill>
                 <a:latin typeface="Calibri"/>
-                <a:hlinkClick r:id="rId3"/>
+                <a:hlinkClick r:id="rId4"/>
               </a:rPr>
               <a:t>github.com/TanukuSai/luna-corr</a:t>
             </a:r>
@@ -5085,7 +5109,7 @@
       </p:sp>
       <p:sp>
         <p:nvSpPr>
-          <p:cNvPr id="49" name="TextBox 48"/>
+          <p:cNvPr id="50" name="TextBox 49"/>
           <p:cNvSpPr txBox="1"/>
           <p:nvPr/>
         </p:nvSpPr>
@@ -5127,7 +5151,7 @@
       </p:sp>
       <p:sp>
         <p:nvSpPr>
-          <p:cNvPr id="50" name="Rectangle 49"/>
+          <p:cNvPr id="51" name="Rectangle 50"/>
           <p:cNvSpPr/>
           <p:nvPr/>
         </p:nvSpPr>
@@ -5140,7 +5164,7 @@
             <a:avLst/>
           </a:prstGeom>
           <a:solidFill>
-            <a:srgbClr val="D0D8DD"/>
+            <a:srgbClr val="D0D8D9"/>
           </a:solidFill>
           <a:ln>
             <a:noFill/>
@@ -5170,7 +5194,7 @@
       </p:sp>
       <p:sp>
         <p:nvSpPr>
-          <p:cNvPr id="51" name="TextBox 50"/>
+          <p:cNvPr id="52" name="TextBox 51"/>
           <p:cNvSpPr txBox="1"/>
           <p:nvPr/>
         </p:nvSpPr>
@@ -5288,7 +5312,7 @@
         <p:spPr>
           <a:xfrm>
             <a:off x="457200" y="91440"/>
-            <a:ext cx="11274552" cy="310896"/>
+            <a:ext cx="10058400" cy="310896"/>
           </a:xfrm>
           <a:prstGeom prst="rect">
             <a:avLst/>
@@ -5330,7 +5354,7 @@
         <p:spPr>
           <a:xfrm>
             <a:off x="457200" y="402336"/>
-            <a:ext cx="11274552" cy="164592"/>
+            <a:ext cx="10058400" cy="164592"/>
           </a:xfrm>
           <a:prstGeom prst="rect">
             <a:avLst/>
@@ -5363,9 +5387,33 @@
           </a:p>
         </p:txBody>
       </p:sp>
-      <p:sp>
-        <p:nvSpPr>
-          <p:cNvPr id="5" name="Rectangle 4"/>
+      <p:pic>
+        <p:nvPicPr>
+          <p:cNvPr id="5" name="Picture 4" descr="sih_logo.png"/>
+          <p:cNvPicPr>
+            <a:picLocks noChangeAspect="1"/>
+          </p:cNvPicPr>
+          <p:nvPr/>
+        </p:nvPicPr>
+        <p:blipFill>
+          <a:blip r:embed="rId2"/>
+          <a:stretch>
+            <a:fillRect/>
+          </a:stretch>
+        </p:blipFill>
+        <p:spPr>
+          <a:xfrm>
+            <a:off x="10698480" y="36576"/>
+            <a:ext cx="1216152" cy="566928"/>
+          </a:xfrm>
+          <a:prstGeom prst="rect">
+            <a:avLst/>
+          </a:prstGeom>
+        </p:spPr>
+      </p:pic>
+      <p:sp>
+        <p:nvSpPr>
+          <p:cNvPr id="6" name="Rectangle 5"/>
           <p:cNvSpPr/>
           <p:nvPr/>
         </p:nvSpPr>
@@ -5378,7 +5426,7 @@
             <a:avLst/>
           </a:prstGeom>
           <a:solidFill>
-            <a:srgbClr val="D0D8DD"/>
+            <a:srgbClr val="D0D8D9"/>
           </a:solidFill>
           <a:ln>
             <a:noFill/>
@@ -5408,7 +5456,7 @@
       </p:sp>
       <p:sp>
         <p:nvSpPr>
-          <p:cNvPr id="6" name="Rectangle 5"/>
+          <p:cNvPr id="7" name="Rectangle 6"/>
           <p:cNvSpPr/>
           <p:nvPr/>
         </p:nvSpPr>
@@ -5451,7 +5499,7 @@
       </p:sp>
       <p:sp>
         <p:nvSpPr>
-          <p:cNvPr id="7" name="TextBox 6"/>
+          <p:cNvPr id="8" name="TextBox 7"/>
           <p:cNvSpPr txBox="1"/>
           <p:nvPr/>
         </p:nvSpPr>
@@ -5493,7 +5541,7 @@
       </p:sp>
       <p:sp>
         <p:nvSpPr>
-          <p:cNvPr id="8" name="Rectangle 7"/>
+          <p:cNvPr id="9" name="Rectangle 8"/>
           <p:cNvSpPr/>
           <p:nvPr/>
         </p:nvSpPr>
@@ -5538,7 +5586,7 @@
       </p:sp>
       <p:sp>
         <p:nvSpPr>
-          <p:cNvPr id="9" name="TextBox 8"/>
+          <p:cNvPr id="10" name="TextBox 9"/>
           <p:cNvSpPr txBox="1"/>
           <p:nvPr/>
         </p:nvSpPr>
@@ -5580,7 +5628,7 @@
       </p:sp>
       <p:sp>
         <p:nvSpPr>
-          <p:cNvPr id="10" name="TextBox 9"/>
+          <p:cNvPr id="11" name="TextBox 10"/>
           <p:cNvSpPr txBox="1"/>
           <p:nvPr/>
         </p:nvSpPr>
@@ -5622,7 +5670,7 @@
       </p:sp>
       <p:sp>
         <p:nvSpPr>
-          <p:cNvPr id="11" name="Rectangle 10"/>
+          <p:cNvPr id="12" name="Rectangle 11"/>
           <p:cNvSpPr/>
           <p:nvPr/>
         </p:nvSpPr>
@@ -5667,7 +5715,7 @@
       </p:sp>
       <p:sp>
         <p:nvSpPr>
-          <p:cNvPr id="12" name="TextBox 11"/>
+          <p:cNvPr id="13" name="TextBox 12"/>
           <p:cNvSpPr txBox="1"/>
           <p:nvPr/>
         </p:nvSpPr>
@@ -5709,7 +5757,7 @@
       </p:sp>
       <p:sp>
         <p:nvSpPr>
-          <p:cNvPr id="13" name="Rectangle 12"/>
+          <p:cNvPr id="14" name="Rectangle 13"/>
           <p:cNvSpPr/>
           <p:nvPr/>
         </p:nvSpPr>
@@ -5754,7 +5802,7 @@
       </p:sp>
       <p:sp>
         <p:nvSpPr>
-          <p:cNvPr id="14" name="TextBox 13"/>
+          <p:cNvPr id="15" name="TextBox 14"/>
           <p:cNvSpPr txBox="1"/>
           <p:nvPr/>
         </p:nvSpPr>
@@ -5796,7 +5844,7 @@
       </p:sp>
       <p:sp>
         <p:nvSpPr>
-          <p:cNvPr id="15" name="Rectangle 14"/>
+          <p:cNvPr id="16" name="Rectangle 15"/>
           <p:cNvSpPr/>
           <p:nvPr/>
         </p:nvSpPr>
@@ -5841,7 +5889,7 @@
       </p:sp>
       <p:sp>
         <p:nvSpPr>
-          <p:cNvPr id="16" name="TextBox 15"/>
+          <p:cNvPr id="17" name="TextBox 16"/>
           <p:cNvSpPr txBox="1"/>
           <p:nvPr/>
         </p:nvSpPr>
@@ -5883,7 +5931,7 @@
       </p:sp>
       <p:sp>
         <p:nvSpPr>
-          <p:cNvPr id="17" name="Rectangle 16"/>
+          <p:cNvPr id="18" name="Rectangle 17"/>
           <p:cNvSpPr/>
           <p:nvPr/>
         </p:nvSpPr>
@@ -5926,7 +5974,7 @@
       </p:sp>
       <p:sp>
         <p:nvSpPr>
-          <p:cNvPr id="18" name="TextBox 17"/>
+          <p:cNvPr id="19" name="TextBox 18"/>
           <p:cNvSpPr txBox="1"/>
           <p:nvPr/>
         </p:nvSpPr>
@@ -5968,7 +6016,7 @@
       </p:sp>
       <p:sp>
         <p:nvSpPr>
-          <p:cNvPr id="19" name="Rectangle 18"/>
+          <p:cNvPr id="20" name="Rectangle 19"/>
           <p:cNvSpPr/>
           <p:nvPr/>
         </p:nvSpPr>
@@ -5985,7 +6033,7 @@
           </a:solidFill>
           <a:ln w="5080">
             <a:solidFill>
-              <a:srgbClr val="D0D8DD"/>
+              <a:srgbClr val="D0D8D9"/>
             </a:solidFill>
           </a:ln>
         </p:spPr>
@@ -6013,7 +6061,7 @@
       </p:sp>
       <p:sp>
         <p:nvSpPr>
-          <p:cNvPr id="20" name="Rectangle 19"/>
+          <p:cNvPr id="21" name="Rectangle 20"/>
           <p:cNvSpPr/>
           <p:nvPr/>
         </p:nvSpPr>
@@ -6056,7 +6104,7 @@
       </p:sp>
       <p:sp>
         <p:nvSpPr>
-          <p:cNvPr id="21" name="TextBox 20"/>
+          <p:cNvPr id="22" name="TextBox 21"/>
           <p:cNvSpPr txBox="1"/>
           <p:nvPr/>
         </p:nvSpPr>
@@ -6098,7 +6146,7 @@
       </p:sp>
       <p:sp>
         <p:nvSpPr>
-          <p:cNvPr id="22" name="Rectangle 21"/>
+          <p:cNvPr id="23" name="Rectangle 22"/>
           <p:cNvSpPr/>
           <p:nvPr/>
         </p:nvSpPr>
@@ -6115,7 +6163,7 @@
           </a:solidFill>
           <a:ln w="3810">
             <a:solidFill>
-              <a:srgbClr val="D0D8DD"/>
+              <a:srgbClr val="D0D8D9"/>
             </a:solidFill>
           </a:ln>
         </p:spPr>
@@ -6143,7 +6191,7 @@
       </p:sp>
       <p:sp>
         <p:nvSpPr>
-          <p:cNvPr id="23" name="TextBox 22"/>
+          <p:cNvPr id="24" name="TextBox 23"/>
           <p:cNvSpPr txBox="1"/>
           <p:nvPr/>
         </p:nvSpPr>
@@ -6185,7 +6233,7 @@
       </p:sp>
       <p:sp>
         <p:nvSpPr>
-          <p:cNvPr id="24" name="TextBox 23"/>
+          <p:cNvPr id="25" name="TextBox 24"/>
           <p:cNvSpPr txBox="1"/>
           <p:nvPr/>
         </p:nvSpPr>
@@ -6227,7 +6275,7 @@
       </p:sp>
       <p:sp>
         <p:nvSpPr>
-          <p:cNvPr id="25" name="Rectangle 24"/>
+          <p:cNvPr id="26" name="Rectangle 25"/>
           <p:cNvSpPr/>
           <p:nvPr/>
         </p:nvSpPr>
@@ -6244,7 +6292,7 @@
           </a:solidFill>
           <a:ln w="3810">
             <a:solidFill>
-              <a:srgbClr val="D0D8DD"/>
+              <a:srgbClr val="D0D8D9"/>
             </a:solidFill>
           </a:ln>
         </p:spPr>
@@ -6272,7 +6320,7 @@
       </p:sp>
       <p:sp>
         <p:nvSpPr>
-          <p:cNvPr id="26" name="TextBox 25"/>
+          <p:cNvPr id="27" name="TextBox 26"/>
           <p:cNvSpPr txBox="1"/>
           <p:nvPr/>
         </p:nvSpPr>
@@ -6314,7 +6362,7 @@
       </p:sp>
       <p:sp>
         <p:nvSpPr>
-          <p:cNvPr id="27" name="TextBox 26"/>
+          <p:cNvPr id="28" name="TextBox 27"/>
           <p:cNvSpPr txBox="1"/>
           <p:nvPr/>
         </p:nvSpPr>
@@ -6356,7 +6404,7 @@
       </p:sp>
       <p:sp>
         <p:nvSpPr>
-          <p:cNvPr id="28" name="Rectangle 27"/>
+          <p:cNvPr id="29" name="Rectangle 28"/>
           <p:cNvSpPr/>
           <p:nvPr/>
         </p:nvSpPr>
@@ -6373,7 +6421,7 @@
           </a:solidFill>
           <a:ln w="3810">
             <a:solidFill>
-              <a:srgbClr val="D0D8DD"/>
+              <a:srgbClr val="D0D8D9"/>
             </a:solidFill>
           </a:ln>
         </p:spPr>
@@ -6401,7 +6449,7 @@
       </p:sp>
       <p:sp>
         <p:nvSpPr>
-          <p:cNvPr id="29" name="TextBox 28"/>
+          <p:cNvPr id="30" name="TextBox 29"/>
           <p:cNvSpPr txBox="1"/>
           <p:nvPr/>
         </p:nvSpPr>
@@ -6443,7 +6491,7 @@
       </p:sp>
       <p:sp>
         <p:nvSpPr>
-          <p:cNvPr id="30" name="TextBox 29"/>
+          <p:cNvPr id="31" name="TextBox 30"/>
           <p:cNvSpPr txBox="1"/>
           <p:nvPr/>
         </p:nvSpPr>
@@ -6485,7 +6533,7 @@
       </p:sp>
       <p:sp>
         <p:nvSpPr>
-          <p:cNvPr id="31" name="Rectangle 30"/>
+          <p:cNvPr id="32" name="Rectangle 31"/>
           <p:cNvSpPr/>
           <p:nvPr/>
         </p:nvSpPr>
@@ -6502,7 +6550,7 @@
           </a:solidFill>
           <a:ln w="3810">
             <a:solidFill>
-              <a:srgbClr val="D0D8DD"/>
+              <a:srgbClr val="D0D8D9"/>
             </a:solidFill>
           </a:ln>
         </p:spPr>
@@ -6530,7 +6578,7 @@
       </p:sp>
       <p:sp>
         <p:nvSpPr>
-          <p:cNvPr id="32" name="TextBox 31"/>
+          <p:cNvPr id="33" name="TextBox 32"/>
           <p:cNvSpPr txBox="1"/>
           <p:nvPr/>
         </p:nvSpPr>
@@ -6572,7 +6620,7 @@
       </p:sp>
       <p:sp>
         <p:nvSpPr>
-          <p:cNvPr id="33" name="TextBox 32"/>
+          <p:cNvPr id="34" name="TextBox 33"/>
           <p:cNvSpPr txBox="1"/>
           <p:nvPr/>
         </p:nvSpPr>
@@ -6614,7 +6662,7 @@
       </p:sp>
       <p:sp>
         <p:nvSpPr>
-          <p:cNvPr id="34" name="Rectangle 33"/>
+          <p:cNvPr id="35" name="Rectangle 34"/>
           <p:cNvSpPr/>
           <p:nvPr/>
         </p:nvSpPr>
@@ -6631,7 +6679,7 @@
           </a:solidFill>
           <a:ln w="5080">
             <a:solidFill>
-              <a:srgbClr val="D0D8DD"/>
+              <a:srgbClr val="D0D8D9"/>
             </a:solidFill>
           </a:ln>
         </p:spPr>
@@ -6659,7 +6707,7 @@
       </p:sp>
       <p:sp>
         <p:nvSpPr>
-          <p:cNvPr id="35" name="Rectangle 34"/>
+          <p:cNvPr id="36" name="Rectangle 35"/>
           <p:cNvSpPr/>
           <p:nvPr/>
         </p:nvSpPr>
@@ -6702,7 +6750,7 @@
       </p:sp>
       <p:sp>
         <p:nvSpPr>
-          <p:cNvPr id="36" name="TextBox 35"/>
+          <p:cNvPr id="37" name="TextBox 36"/>
           <p:cNvSpPr txBox="1"/>
           <p:nvPr/>
         </p:nvSpPr>
@@ -6744,7 +6792,7 @@
       </p:sp>
       <p:sp>
         <p:nvSpPr>
-          <p:cNvPr id="37" name="Rectangle 36"/>
+          <p:cNvPr id="38" name="Rectangle 37"/>
           <p:cNvSpPr/>
           <p:nvPr/>
         </p:nvSpPr>
@@ -6761,7 +6809,7 @@
           </a:solidFill>
           <a:ln w="3810">
             <a:solidFill>
-              <a:srgbClr val="D0D8DD"/>
+              <a:srgbClr val="D0D8D9"/>
             </a:solidFill>
           </a:ln>
         </p:spPr>
@@ -6789,7 +6837,7 @@
       </p:sp>
       <p:sp>
         <p:nvSpPr>
-          <p:cNvPr id="38" name="TextBox 37"/>
+          <p:cNvPr id="39" name="TextBox 38"/>
           <p:cNvSpPr txBox="1"/>
           <p:nvPr/>
         </p:nvSpPr>
@@ -6831,7 +6879,7 @@
       </p:sp>
       <p:sp>
         <p:nvSpPr>
-          <p:cNvPr id="39" name="TextBox 38"/>
+          <p:cNvPr id="40" name="TextBox 39"/>
           <p:cNvSpPr txBox="1"/>
           <p:nvPr/>
         </p:nvSpPr>
@@ -6873,7 +6921,7 @@
       </p:sp>
       <p:sp>
         <p:nvSpPr>
-          <p:cNvPr id="40" name="Rectangle 39"/>
+          <p:cNvPr id="41" name="Rectangle 40"/>
           <p:cNvSpPr/>
           <p:nvPr/>
         </p:nvSpPr>
@@ -6890,7 +6938,7 @@
           </a:solidFill>
           <a:ln w="3810">
             <a:solidFill>
-              <a:srgbClr val="D0D8DD"/>
+              <a:srgbClr val="D0D8D9"/>
             </a:solidFill>
           </a:ln>
         </p:spPr>
@@ -6918,7 +6966,7 @@
       </p:sp>
       <p:sp>
         <p:nvSpPr>
-          <p:cNvPr id="41" name="TextBox 40"/>
+          <p:cNvPr id="42" name="TextBox 41"/>
           <p:cNvSpPr txBox="1"/>
           <p:nvPr/>
         </p:nvSpPr>
@@ -6960,7 +7008,7 @@
       </p:sp>
       <p:sp>
         <p:nvSpPr>
-          <p:cNvPr id="42" name="TextBox 41"/>
+          <p:cNvPr id="43" name="TextBox 42"/>
           <p:cNvSpPr txBox="1"/>
           <p:nvPr/>
         </p:nvSpPr>
@@ -7002,7 +7050,7 @@
       </p:sp>
       <p:sp>
         <p:nvSpPr>
-          <p:cNvPr id="43" name="Rectangle 42"/>
+          <p:cNvPr id="44" name="Rectangle 43"/>
           <p:cNvSpPr/>
           <p:nvPr/>
         </p:nvSpPr>
@@ -7019,7 +7067,7 @@
           </a:solidFill>
           <a:ln w="3810">
             <a:solidFill>
-              <a:srgbClr val="D0D8DD"/>
+              <a:srgbClr val="D0D8D9"/>
             </a:solidFill>
           </a:ln>
         </p:spPr>
@@ -7047,7 +7095,7 @@
       </p:sp>
       <p:sp>
         <p:nvSpPr>
-          <p:cNvPr id="44" name="TextBox 43"/>
+          <p:cNvPr id="45" name="TextBox 44"/>
           <p:cNvSpPr txBox="1"/>
           <p:nvPr/>
         </p:nvSpPr>
@@ -7089,7 +7137,7 @@
       </p:sp>
       <p:sp>
         <p:nvSpPr>
-          <p:cNvPr id="45" name="TextBox 44"/>
+          <p:cNvPr id="46" name="TextBox 45"/>
           <p:cNvSpPr txBox="1"/>
           <p:nvPr/>
         </p:nvSpPr>
@@ -7131,7 +7179,7 @@
       </p:sp>
       <p:sp>
         <p:nvSpPr>
-          <p:cNvPr id="46" name="Rectangle 45"/>
+          <p:cNvPr id="47" name="Rectangle 46"/>
           <p:cNvSpPr/>
           <p:nvPr/>
         </p:nvSpPr>
@@ -7148,7 +7196,7 @@
           </a:solidFill>
           <a:ln w="3810">
             <a:solidFill>
-              <a:srgbClr val="D0D8DD"/>
+              <a:srgbClr val="D0D8D9"/>
             </a:solidFill>
           </a:ln>
         </p:spPr>
@@ -7176,7 +7224,7 @@
       </p:sp>
       <p:sp>
         <p:nvSpPr>
-          <p:cNvPr id="47" name="TextBox 46"/>
+          <p:cNvPr id="48" name="TextBox 47"/>
           <p:cNvSpPr txBox="1"/>
           <p:nvPr/>
         </p:nvSpPr>
@@ -7218,7 +7266,7 @@
       </p:sp>
       <p:sp>
         <p:nvSpPr>
-          <p:cNvPr id="48" name="TextBox 47"/>
+          <p:cNvPr id="49" name="TextBox 48"/>
           <p:cNvSpPr txBox="1"/>
           <p:nvPr/>
         </p:nvSpPr>
@@ -7260,7 +7308,7 @@
       </p:sp>
       <p:sp>
         <p:nvSpPr>
-          <p:cNvPr id="49" name="Rectangle 48"/>
+          <p:cNvPr id="50" name="Rectangle 49"/>
           <p:cNvSpPr/>
           <p:nvPr/>
         </p:nvSpPr>
@@ -7277,7 +7325,7 @@
           </a:solidFill>
           <a:ln w="5080">
             <a:solidFill>
-              <a:srgbClr val="D0D8DD"/>
+              <a:srgbClr val="D0D8D9"/>
             </a:solidFill>
           </a:ln>
         </p:spPr>
@@ -7305,7 +7353,7 @@
       </p:sp>
       <p:sp>
         <p:nvSpPr>
-          <p:cNvPr id="50" name="Rectangle 49"/>
+          <p:cNvPr id="51" name="Rectangle 50"/>
           <p:cNvSpPr/>
           <p:nvPr/>
         </p:nvSpPr>
@@ -7348,7 +7396,7 @@
       </p:sp>
       <p:sp>
         <p:nvSpPr>
-          <p:cNvPr id="51" name="TextBox 50"/>
+          <p:cNvPr id="52" name="TextBox 51"/>
           <p:cNvSpPr txBox="1"/>
           <p:nvPr/>
         </p:nvSpPr>
@@ -7390,7 +7438,7 @@
       </p:sp>
       <p:sp>
         <p:nvSpPr>
-          <p:cNvPr id="52" name="Rectangle 51"/>
+          <p:cNvPr id="53" name="Rectangle 52"/>
           <p:cNvSpPr/>
           <p:nvPr/>
         </p:nvSpPr>
@@ -7407,7 +7455,7 @@
           </a:solidFill>
           <a:ln w="3810">
             <a:solidFill>
-              <a:srgbClr val="D0D8DD"/>
+              <a:srgbClr val="D0D8D9"/>
             </a:solidFill>
           </a:ln>
         </p:spPr>
@@ -7435,7 +7483,7 @@
       </p:sp>
       <p:sp>
         <p:nvSpPr>
-          <p:cNvPr id="53" name="TextBox 52"/>
+          <p:cNvPr id="54" name="TextBox 53"/>
           <p:cNvSpPr txBox="1"/>
           <p:nvPr/>
         </p:nvSpPr>
@@ -7477,7 +7525,7 @@
       </p:sp>
       <p:sp>
         <p:nvSpPr>
-          <p:cNvPr id="54" name="TextBox 53"/>
+          <p:cNvPr id="55" name="TextBox 54"/>
           <p:cNvSpPr txBox="1"/>
           <p:nvPr/>
         </p:nvSpPr>
@@ -7519,7 +7567,7 @@
       </p:sp>
       <p:sp>
         <p:nvSpPr>
-          <p:cNvPr id="55" name="Rectangle 54"/>
+          <p:cNvPr id="56" name="Rectangle 55"/>
           <p:cNvSpPr/>
           <p:nvPr/>
         </p:nvSpPr>
@@ -7536,7 +7584,7 @@
           </a:solidFill>
           <a:ln w="3810">
             <a:solidFill>
-              <a:srgbClr val="D0D8DD"/>
+              <a:srgbClr val="D0D8D9"/>
             </a:solidFill>
           </a:ln>
         </p:spPr>
@@ -7564,7 +7612,7 @@
       </p:sp>
       <p:sp>
         <p:nvSpPr>
-          <p:cNvPr id="56" name="TextBox 55"/>
+          <p:cNvPr id="57" name="TextBox 56"/>
           <p:cNvSpPr txBox="1"/>
           <p:nvPr/>
         </p:nvSpPr>
@@ -7606,7 +7654,7 @@
       </p:sp>
       <p:sp>
         <p:nvSpPr>
-          <p:cNvPr id="57" name="TextBox 56"/>
+          <p:cNvPr id="58" name="TextBox 57"/>
           <p:cNvSpPr txBox="1"/>
           <p:nvPr/>
         </p:nvSpPr>
@@ -7648,7 +7696,7 @@
       </p:sp>
       <p:sp>
         <p:nvSpPr>
-          <p:cNvPr id="58" name="Rectangle 57"/>
+          <p:cNvPr id="59" name="Rectangle 58"/>
           <p:cNvSpPr/>
           <p:nvPr/>
         </p:nvSpPr>
@@ -7665,7 +7713,7 @@
           </a:solidFill>
           <a:ln w="3810">
             <a:solidFill>
-              <a:srgbClr val="D0D8DD"/>
+              <a:srgbClr val="D0D8D9"/>
             </a:solidFill>
           </a:ln>
         </p:spPr>
@@ -7693,7 +7741,7 @@
       </p:sp>
       <p:sp>
         <p:nvSpPr>
-          <p:cNvPr id="59" name="TextBox 58"/>
+          <p:cNvPr id="60" name="TextBox 59"/>
           <p:cNvSpPr txBox="1"/>
           <p:nvPr/>
         </p:nvSpPr>
@@ -7735,7 +7783,7 @@
       </p:sp>
       <p:sp>
         <p:nvSpPr>
-          <p:cNvPr id="60" name="TextBox 59"/>
+          <p:cNvPr id="61" name="TextBox 60"/>
           <p:cNvSpPr txBox="1"/>
           <p:nvPr/>
         </p:nvSpPr>
@@ -7777,7 +7825,7 @@
       </p:sp>
       <p:sp>
         <p:nvSpPr>
-          <p:cNvPr id="61" name="Rectangle 60"/>
+          <p:cNvPr id="62" name="Rectangle 61"/>
           <p:cNvSpPr/>
           <p:nvPr/>
         </p:nvSpPr>
@@ -7794,7 +7842,7 @@
           </a:solidFill>
           <a:ln w="3810">
             <a:solidFill>
-              <a:srgbClr val="D0D8DD"/>
+              <a:srgbClr val="D0D8D9"/>
             </a:solidFill>
           </a:ln>
         </p:spPr>
@@ -7822,7 +7870,7 @@
       </p:sp>
       <p:sp>
         <p:nvSpPr>
-          <p:cNvPr id="62" name="TextBox 61"/>
+          <p:cNvPr id="63" name="TextBox 62"/>
           <p:cNvSpPr txBox="1"/>
           <p:nvPr/>
         </p:nvSpPr>
@@ -7864,7 +7912,7 @@
       </p:sp>
       <p:sp>
         <p:nvSpPr>
-          <p:cNvPr id="63" name="TextBox 62"/>
+          <p:cNvPr id="64" name="TextBox 63"/>
           <p:cNvSpPr txBox="1"/>
           <p:nvPr/>
         </p:nvSpPr>
@@ -7906,7 +7954,7 @@
       </p:sp>
       <p:sp>
         <p:nvSpPr>
-          <p:cNvPr id="64" name="Rectangle 63"/>
+          <p:cNvPr id="65" name="Rectangle 64"/>
           <p:cNvSpPr/>
           <p:nvPr/>
         </p:nvSpPr>
@@ -7951,7 +7999,7 @@
       </p:sp>
       <p:sp>
         <p:nvSpPr>
-          <p:cNvPr id="65" name="TextBox 64"/>
+          <p:cNvPr id="66" name="TextBox 65"/>
           <p:cNvSpPr txBox="1"/>
           <p:nvPr/>
         </p:nvSpPr>
@@ -7993,7 +8041,7 @@
       </p:sp>
       <p:sp>
         <p:nvSpPr>
-          <p:cNvPr id="66" name="Rectangle 65"/>
+          <p:cNvPr id="67" name="Rectangle 66"/>
           <p:cNvSpPr/>
           <p:nvPr/>
         </p:nvSpPr>
@@ -8006,7 +8054,7 @@
             <a:avLst/>
           </a:prstGeom>
           <a:solidFill>
-            <a:srgbClr val="D0D8DD"/>
+            <a:srgbClr val="D0D8D9"/>
           </a:solidFill>
           <a:ln>
             <a:noFill/>
@@ -8036,7 +8084,7 @@
       </p:sp>
       <p:sp>
         <p:nvSpPr>
-          <p:cNvPr id="67" name="TextBox 66"/>
+          <p:cNvPr id="68" name="TextBox 67"/>
           <p:cNvSpPr txBox="1"/>
           <p:nvPr/>
         </p:nvSpPr>
@@ -8196,7 +8244,7 @@
         <p:spPr>
           <a:xfrm>
             <a:off x="457200" y="402336"/>
-            <a:ext cx="10972800" cy="164592"/>
+            <a:ext cx="10058400" cy="164592"/>
           </a:xfrm>
           <a:prstGeom prst="rect">
             <a:avLst/>
@@ -8229,9 +8277,33 @@
           </a:p>
         </p:txBody>
       </p:sp>
-      <p:sp>
-        <p:nvSpPr>
-          <p:cNvPr id="5" name="Rectangle 4"/>
+      <p:pic>
+        <p:nvPicPr>
+          <p:cNvPr id="5" name="Picture 4" descr="sih_logo.png"/>
+          <p:cNvPicPr>
+            <a:picLocks noChangeAspect="1"/>
+          </p:cNvPicPr>
+          <p:nvPr/>
+        </p:nvPicPr>
+        <p:blipFill>
+          <a:blip r:embed="rId2"/>
+          <a:stretch>
+            <a:fillRect/>
+          </a:stretch>
+        </p:blipFill>
+        <p:spPr>
+          <a:xfrm>
+            <a:off x="10698480" y="36576"/>
+            <a:ext cx="1216152" cy="566928"/>
+          </a:xfrm>
+          <a:prstGeom prst="rect">
+            <a:avLst/>
+          </a:prstGeom>
+        </p:spPr>
+      </p:pic>
+      <p:sp>
+        <p:nvSpPr>
+          <p:cNvPr id="6" name="Rectangle 5"/>
           <p:cNvSpPr/>
           <p:nvPr/>
         </p:nvSpPr>
@@ -8244,7 +8316,7 @@
             <a:avLst/>
           </a:prstGeom>
           <a:solidFill>
-            <a:srgbClr val="D0D8DD"/>
+            <a:srgbClr val="D0D8D9"/>
           </a:solidFill>
           <a:ln>
             <a:noFill/>
@@ -8274,7 +8346,7 @@
       </p:sp>
       <p:sp>
         <p:nvSpPr>
-          <p:cNvPr id="6" name="Rectangle 5"/>
+          <p:cNvPr id="7" name="Rectangle 6"/>
           <p:cNvSpPr/>
           <p:nvPr/>
         </p:nvSpPr>
@@ -8317,7 +8389,7 @@
       </p:sp>
       <p:sp>
         <p:nvSpPr>
-          <p:cNvPr id="7" name="TextBox 6"/>
+          <p:cNvPr id="8" name="TextBox 7"/>
           <p:cNvSpPr txBox="1"/>
           <p:nvPr/>
         </p:nvSpPr>
@@ -8359,7 +8431,7 @@
       </p:sp>
       <p:sp>
         <p:nvSpPr>
-          <p:cNvPr id="8" name="Rectangle 7"/>
+          <p:cNvPr id="9" name="Rectangle 8"/>
           <p:cNvSpPr/>
           <p:nvPr/>
         </p:nvSpPr>
@@ -8376,7 +8448,7 @@
           </a:solidFill>
           <a:ln w="5080">
             <a:solidFill>
-              <a:srgbClr val="D0D8DD"/>
+              <a:srgbClr val="D0D8D9"/>
             </a:solidFill>
           </a:ln>
         </p:spPr>
@@ -8404,7 +8476,7 @@
       </p:sp>
       <p:sp>
         <p:nvSpPr>
-          <p:cNvPr id="9" name="TextBox 8"/>
+          <p:cNvPr id="10" name="TextBox 9"/>
           <p:cNvSpPr txBox="1"/>
           <p:nvPr/>
         </p:nvSpPr>
@@ -8446,7 +8518,7 @@
       </p:sp>
       <p:sp>
         <p:nvSpPr>
-          <p:cNvPr id="10" name="TextBox 9"/>
+          <p:cNvPr id="11" name="TextBox 10"/>
           <p:cNvSpPr txBox="1"/>
           <p:nvPr/>
         </p:nvSpPr>
@@ -8488,7 +8560,7 @@
       </p:sp>
       <p:sp>
         <p:nvSpPr>
-          <p:cNvPr id="11" name="Rectangle 10"/>
+          <p:cNvPr id="12" name="Rectangle 11"/>
           <p:cNvSpPr/>
           <p:nvPr/>
         </p:nvSpPr>
@@ -8505,7 +8577,7 @@
           </a:solidFill>
           <a:ln w="5080">
             <a:solidFill>
-              <a:srgbClr val="D0D8DD"/>
+              <a:srgbClr val="D0D8D9"/>
             </a:solidFill>
           </a:ln>
         </p:spPr>
@@ -8533,7 +8605,7 @@
       </p:sp>
       <p:sp>
         <p:nvSpPr>
-          <p:cNvPr id="12" name="TextBox 11"/>
+          <p:cNvPr id="13" name="TextBox 12"/>
           <p:cNvSpPr txBox="1"/>
           <p:nvPr/>
         </p:nvSpPr>
@@ -8575,7 +8647,7 @@
       </p:sp>
       <p:sp>
         <p:nvSpPr>
-          <p:cNvPr id="13" name="TextBox 12"/>
+          <p:cNvPr id="14" name="TextBox 13"/>
           <p:cNvSpPr txBox="1"/>
           <p:nvPr/>
         </p:nvSpPr>
@@ -8617,7 +8689,7 @@
       </p:sp>
       <p:sp>
         <p:nvSpPr>
-          <p:cNvPr id="14" name="Rectangle 13"/>
+          <p:cNvPr id="15" name="Rectangle 14"/>
           <p:cNvSpPr/>
           <p:nvPr/>
         </p:nvSpPr>
@@ -8634,7 +8706,7 @@
           </a:solidFill>
           <a:ln w="5080">
             <a:solidFill>
-              <a:srgbClr val="D0D8DD"/>
+              <a:srgbClr val="D0D8D9"/>
             </a:solidFill>
           </a:ln>
         </p:spPr>
@@ -8662,7 +8734,7 @@
       </p:sp>
       <p:sp>
         <p:nvSpPr>
-          <p:cNvPr id="15" name="TextBox 14"/>
+          <p:cNvPr id="16" name="TextBox 15"/>
           <p:cNvSpPr txBox="1"/>
           <p:nvPr/>
         </p:nvSpPr>
@@ -8704,7 +8776,7 @@
       </p:sp>
       <p:sp>
         <p:nvSpPr>
-          <p:cNvPr id="16" name="TextBox 15"/>
+          <p:cNvPr id="17" name="TextBox 16"/>
           <p:cNvSpPr txBox="1"/>
           <p:nvPr/>
         </p:nvSpPr>
@@ -8746,7 +8818,7 @@
       </p:sp>
       <p:sp>
         <p:nvSpPr>
-          <p:cNvPr id="17" name="Rectangle 16"/>
+          <p:cNvPr id="18" name="Rectangle 17"/>
           <p:cNvSpPr/>
           <p:nvPr/>
         </p:nvSpPr>
@@ -8763,7 +8835,7 @@
           </a:solidFill>
           <a:ln w="5080">
             <a:solidFill>
-              <a:srgbClr val="D0D8DD"/>
+              <a:srgbClr val="D0D8D9"/>
             </a:solidFill>
           </a:ln>
         </p:spPr>
@@ -8791,7 +8863,7 @@
       </p:sp>
       <p:sp>
         <p:nvSpPr>
-          <p:cNvPr id="18" name="TextBox 17"/>
+          <p:cNvPr id="19" name="TextBox 18"/>
           <p:cNvSpPr txBox="1"/>
           <p:nvPr/>
         </p:nvSpPr>
@@ -8833,7 +8905,7 @@
       </p:sp>
       <p:sp>
         <p:nvSpPr>
-          <p:cNvPr id="19" name="TextBox 18"/>
+          <p:cNvPr id="20" name="TextBox 19"/>
           <p:cNvSpPr txBox="1"/>
           <p:nvPr/>
         </p:nvSpPr>
@@ -8875,7 +8947,7 @@
       </p:sp>
       <p:sp>
         <p:nvSpPr>
-          <p:cNvPr id="20" name="Rectangle 19"/>
+          <p:cNvPr id="21" name="Rectangle 20"/>
           <p:cNvSpPr/>
           <p:nvPr/>
         </p:nvSpPr>
@@ -8918,7 +8990,7 @@
       </p:sp>
       <p:sp>
         <p:nvSpPr>
-          <p:cNvPr id="21" name="TextBox 20"/>
+          <p:cNvPr id="22" name="TextBox 21"/>
           <p:cNvSpPr txBox="1"/>
           <p:nvPr/>
         </p:nvSpPr>
@@ -8960,7 +9032,7 @@
       </p:sp>
       <p:sp>
         <p:nvSpPr>
-          <p:cNvPr id="22" name="Rectangle 21"/>
+          <p:cNvPr id="23" name="Rectangle 22"/>
           <p:cNvSpPr/>
           <p:nvPr/>
         </p:nvSpPr>
@@ -8977,7 +9049,7 @@
           </a:solidFill>
           <a:ln w="6350">
             <a:solidFill>
-              <a:srgbClr val="D0D8DD"/>
+              <a:srgbClr val="D0D8D9"/>
             </a:solidFill>
           </a:ln>
         </p:spPr>
@@ -9005,7 +9077,7 @@
       </p:sp>
       <p:sp>
         <p:nvSpPr>
-          <p:cNvPr id="23" name="Rectangle 22"/>
+          <p:cNvPr id="24" name="Rectangle 23"/>
           <p:cNvSpPr/>
           <p:nvPr/>
         </p:nvSpPr>
@@ -9048,7 +9120,7 @@
       </p:sp>
       <p:sp>
         <p:nvSpPr>
-          <p:cNvPr id="24" name="TextBox 23"/>
+          <p:cNvPr id="25" name="TextBox 24"/>
           <p:cNvSpPr txBox="1"/>
           <p:nvPr/>
         </p:nvSpPr>
@@ -9090,7 +9162,7 @@
       </p:sp>
       <p:sp>
         <p:nvSpPr>
-          <p:cNvPr id="25" name="TextBox 24"/>
+          <p:cNvPr id="26" name="TextBox 25"/>
           <p:cNvSpPr txBox="1"/>
           <p:nvPr/>
         </p:nvSpPr>
@@ -9132,7 +9204,7 @@
       </p:sp>
       <p:sp>
         <p:nvSpPr>
-          <p:cNvPr id="26" name="Rectangle 25"/>
+          <p:cNvPr id="27" name="Rectangle 26"/>
           <p:cNvSpPr/>
           <p:nvPr/>
         </p:nvSpPr>
@@ -9177,7 +9249,7 @@
       </p:sp>
       <p:sp>
         <p:nvSpPr>
-          <p:cNvPr id="27" name="Rectangle 26"/>
+          <p:cNvPr id="28" name="Rectangle 27"/>
           <p:cNvSpPr/>
           <p:nvPr/>
         </p:nvSpPr>
@@ -9220,7 +9292,7 @@
       </p:sp>
       <p:sp>
         <p:nvSpPr>
-          <p:cNvPr id="28" name="TextBox 27"/>
+          <p:cNvPr id="29" name="TextBox 28"/>
           <p:cNvSpPr txBox="1"/>
           <p:nvPr/>
         </p:nvSpPr>
@@ -9262,7 +9334,7 @@
       </p:sp>
       <p:sp>
         <p:nvSpPr>
-          <p:cNvPr id="29" name="TextBox 28"/>
+          <p:cNvPr id="30" name="TextBox 29"/>
           <p:cNvSpPr txBox="1"/>
           <p:nvPr/>
         </p:nvSpPr>
@@ -9307,7 +9379,7 @@
       </p:sp>
       <p:sp>
         <p:nvSpPr>
-          <p:cNvPr id="30" name="Rectangle 29"/>
+          <p:cNvPr id="31" name="Rectangle 30"/>
           <p:cNvSpPr/>
           <p:nvPr/>
         </p:nvSpPr>
@@ -9324,7 +9396,7 @@
           </a:solidFill>
           <a:ln w="6350">
             <a:solidFill>
-              <a:srgbClr val="D0D8DD"/>
+              <a:srgbClr val="D0D8D9"/>
             </a:solidFill>
           </a:ln>
         </p:spPr>
@@ -9352,7 +9424,7 @@
       </p:sp>
       <p:sp>
         <p:nvSpPr>
-          <p:cNvPr id="31" name="Rectangle 30"/>
+          <p:cNvPr id="32" name="Rectangle 31"/>
           <p:cNvSpPr/>
           <p:nvPr/>
         </p:nvSpPr>
@@ -9395,7 +9467,7 @@
       </p:sp>
       <p:sp>
         <p:nvSpPr>
-          <p:cNvPr id="32" name="TextBox 31"/>
+          <p:cNvPr id="33" name="TextBox 32"/>
           <p:cNvSpPr txBox="1"/>
           <p:nvPr/>
         </p:nvSpPr>
@@ -9437,7 +9509,7 @@
       </p:sp>
       <p:sp>
         <p:nvSpPr>
-          <p:cNvPr id="33" name="TextBox 32"/>
+          <p:cNvPr id="34" name="TextBox 33"/>
           <p:cNvSpPr txBox="1"/>
           <p:nvPr/>
         </p:nvSpPr>
@@ -9479,7 +9551,7 @@
       </p:sp>
       <p:sp>
         <p:nvSpPr>
-          <p:cNvPr id="34" name="Rectangle 33"/>
+          <p:cNvPr id="35" name="Rectangle 34"/>
           <p:cNvSpPr/>
           <p:nvPr/>
         </p:nvSpPr>
@@ -9496,7 +9568,7 @@
           </a:solidFill>
           <a:ln w="6350">
             <a:solidFill>
-              <a:srgbClr val="D0D8DD"/>
+              <a:srgbClr val="D0D8D9"/>
             </a:solidFill>
           </a:ln>
         </p:spPr>
@@ -9524,7 +9596,7 @@
       </p:sp>
       <p:sp>
         <p:nvSpPr>
-          <p:cNvPr id="35" name="Rectangle 34"/>
+          <p:cNvPr id="36" name="Rectangle 35"/>
           <p:cNvSpPr/>
           <p:nvPr/>
         </p:nvSpPr>
@@ -9567,7 +9639,7 @@
       </p:sp>
       <p:sp>
         <p:nvSpPr>
-          <p:cNvPr id="36" name="TextBox 35"/>
+          <p:cNvPr id="37" name="TextBox 36"/>
           <p:cNvSpPr txBox="1"/>
           <p:nvPr/>
         </p:nvSpPr>
@@ -9609,7 +9681,7 @@
       </p:sp>
       <p:sp>
         <p:nvSpPr>
-          <p:cNvPr id="37" name="TextBox 36"/>
+          <p:cNvPr id="38" name="TextBox 37"/>
           <p:cNvSpPr txBox="1"/>
           <p:nvPr/>
         </p:nvSpPr>
@@ -9651,7 +9723,7 @@
       </p:sp>
       <p:sp>
         <p:nvSpPr>
-          <p:cNvPr id="38" name="Rectangle 37"/>
+          <p:cNvPr id="39" name="Rectangle 38"/>
           <p:cNvSpPr/>
           <p:nvPr/>
         </p:nvSpPr>
@@ -9668,7 +9740,7 @@
           </a:solidFill>
           <a:ln w="6350">
             <a:solidFill>
-              <a:srgbClr val="D0D8DD"/>
+              <a:srgbClr val="D0D8D9"/>
             </a:solidFill>
           </a:ln>
         </p:spPr>
@@ -9696,7 +9768,7 @@
       </p:sp>
       <p:sp>
         <p:nvSpPr>
-          <p:cNvPr id="39" name="Rectangle 38"/>
+          <p:cNvPr id="40" name="Rectangle 39"/>
           <p:cNvSpPr/>
           <p:nvPr/>
         </p:nvSpPr>
@@ -9739,7 +9811,7 @@
       </p:sp>
       <p:sp>
         <p:nvSpPr>
-          <p:cNvPr id="40" name="TextBox 39"/>
+          <p:cNvPr id="41" name="TextBox 40"/>
           <p:cNvSpPr txBox="1"/>
           <p:nvPr/>
         </p:nvSpPr>
@@ -9781,7 +9853,7 @@
       </p:sp>
       <p:sp>
         <p:nvSpPr>
-          <p:cNvPr id="41" name="TextBox 40"/>
+          <p:cNvPr id="42" name="TextBox 41"/>
           <p:cNvSpPr txBox="1"/>
           <p:nvPr/>
         </p:nvSpPr>
@@ -9823,7 +9895,7 @@
       </p:sp>
       <p:sp>
         <p:nvSpPr>
-          <p:cNvPr id="42" name="Rectangle 41"/>
+          <p:cNvPr id="43" name="Rectangle 42"/>
           <p:cNvSpPr/>
           <p:nvPr/>
         </p:nvSpPr>
@@ -9840,7 +9912,7 @@
           </a:solidFill>
           <a:ln w="6350">
             <a:solidFill>
-              <a:srgbClr val="D0D8DD"/>
+              <a:srgbClr val="D0D8D9"/>
             </a:solidFill>
           </a:ln>
         </p:spPr>
@@ -9868,7 +9940,7 @@
       </p:sp>
       <p:sp>
         <p:nvSpPr>
-          <p:cNvPr id="43" name="Rectangle 42"/>
+          <p:cNvPr id="44" name="Rectangle 43"/>
           <p:cNvSpPr/>
           <p:nvPr/>
         </p:nvSpPr>
@@ -9911,7 +9983,7 @@
       </p:sp>
       <p:sp>
         <p:nvSpPr>
-          <p:cNvPr id="44" name="TextBox 43"/>
+          <p:cNvPr id="45" name="TextBox 44"/>
           <p:cNvSpPr txBox="1"/>
           <p:nvPr/>
         </p:nvSpPr>
@@ -9953,7 +10025,7 @@
       </p:sp>
       <p:sp>
         <p:nvSpPr>
-          <p:cNvPr id="45" name="TextBox 44"/>
+          <p:cNvPr id="46" name="TextBox 45"/>
           <p:cNvSpPr txBox="1"/>
           <p:nvPr/>
         </p:nvSpPr>
@@ -9995,7 +10067,7 @@
       </p:sp>
       <p:sp>
         <p:nvSpPr>
-          <p:cNvPr id="46" name="Rectangle 45"/>
+          <p:cNvPr id="47" name="Rectangle 46"/>
           <p:cNvSpPr/>
           <p:nvPr/>
         </p:nvSpPr>
@@ -10012,7 +10084,7 @@
           </a:solidFill>
           <a:ln w="6350">
             <a:solidFill>
-              <a:srgbClr val="D0D8DD"/>
+              <a:srgbClr val="D0D8D9"/>
             </a:solidFill>
           </a:ln>
         </p:spPr>
@@ -10040,7 +10112,7 @@
       </p:sp>
       <p:sp>
         <p:nvSpPr>
-          <p:cNvPr id="47" name="Rectangle 46"/>
+          <p:cNvPr id="48" name="Rectangle 47"/>
           <p:cNvSpPr/>
           <p:nvPr/>
         </p:nvSpPr>
@@ -10083,7 +10155,7 @@
       </p:sp>
       <p:sp>
         <p:nvSpPr>
-          <p:cNvPr id="48" name="TextBox 47"/>
+          <p:cNvPr id="49" name="TextBox 48"/>
           <p:cNvSpPr txBox="1"/>
           <p:nvPr/>
         </p:nvSpPr>
@@ -10125,7 +10197,7 @@
       </p:sp>
       <p:sp>
         <p:nvSpPr>
-          <p:cNvPr id="49" name="TextBox 48"/>
+          <p:cNvPr id="50" name="TextBox 49"/>
           <p:cNvSpPr txBox="1"/>
           <p:nvPr/>
         </p:nvSpPr>
@@ -10167,7 +10239,7 @@
       </p:sp>
       <p:sp>
         <p:nvSpPr>
-          <p:cNvPr id="50" name="Rectangle 49"/>
+          <p:cNvPr id="51" name="Rectangle 50"/>
           <p:cNvSpPr/>
           <p:nvPr/>
         </p:nvSpPr>
@@ -10184,7 +10256,7 @@
           </a:solidFill>
           <a:ln w="6350">
             <a:solidFill>
-              <a:srgbClr val="D0D8DD"/>
+              <a:srgbClr val="D0D8D9"/>
             </a:solidFill>
           </a:ln>
         </p:spPr>
@@ -10212,7 +10284,7 @@
       </p:sp>
       <p:sp>
         <p:nvSpPr>
-          <p:cNvPr id="51" name="Rectangle 50"/>
+          <p:cNvPr id="52" name="Rectangle 51"/>
           <p:cNvSpPr/>
           <p:nvPr/>
         </p:nvSpPr>
@@ -10255,7 +10327,7 @@
       </p:sp>
       <p:sp>
         <p:nvSpPr>
-          <p:cNvPr id="52" name="TextBox 51"/>
+          <p:cNvPr id="53" name="TextBox 52"/>
           <p:cNvSpPr txBox="1"/>
           <p:nvPr/>
         </p:nvSpPr>
@@ -10297,7 +10369,7 @@
       </p:sp>
       <p:sp>
         <p:nvSpPr>
-          <p:cNvPr id="53" name="TextBox 52"/>
+          <p:cNvPr id="54" name="TextBox 53"/>
           <p:cNvSpPr txBox="1"/>
           <p:nvPr/>
         </p:nvSpPr>
@@ -10339,7 +10411,7 @@
       </p:sp>
       <p:sp>
         <p:nvSpPr>
-          <p:cNvPr id="54" name="Rectangle 53"/>
+          <p:cNvPr id="55" name="Rectangle 54"/>
           <p:cNvSpPr/>
           <p:nvPr/>
         </p:nvSpPr>
@@ -10382,7 +10454,7 @@
       </p:sp>
       <p:sp>
         <p:nvSpPr>
-          <p:cNvPr id="55" name="TextBox 54"/>
+          <p:cNvPr id="56" name="TextBox 55"/>
           <p:cNvSpPr txBox="1"/>
           <p:nvPr/>
         </p:nvSpPr>
@@ -10424,14 +10496,14 @@
       </p:sp>
       <p:pic>
         <p:nvPicPr>
-          <p:cNvPr id="56" name="Picture 55" descr="fig3_checkerboard.png"/>
+          <p:cNvPr id="57" name="Picture 56" descr="fig3_checkerboard.png"/>
           <p:cNvPicPr>
             <a:picLocks noChangeAspect="1"/>
           </p:cNvPicPr>
           <p:nvPr/>
         </p:nvPicPr>
         <p:blipFill>
-          <a:blip r:embed="rId2"/>
+          <a:blip r:embed="rId3"/>
           <a:stretch>
             <a:fillRect/>
           </a:stretch>
@@ -10448,7 +10520,7 @@
       </p:pic>
       <p:sp>
         <p:nvSpPr>
-          <p:cNvPr id="57" name="Rectangle 56"/>
+          <p:cNvPr id="58" name="Rectangle 57"/>
           <p:cNvSpPr/>
           <p:nvPr/>
         </p:nvSpPr>
@@ -10493,7 +10565,7 @@
       </p:sp>
       <p:sp>
         <p:nvSpPr>
-          <p:cNvPr id="58" name="TextBox 57"/>
+          <p:cNvPr id="59" name="TextBox 58"/>
           <p:cNvSpPr txBox="1"/>
           <p:nvPr/>
         </p:nvSpPr>
@@ -10535,7 +10607,7 @@
       </p:sp>
       <p:sp>
         <p:nvSpPr>
-          <p:cNvPr id="59" name="TextBox 58"/>
+          <p:cNvPr id="60" name="TextBox 59"/>
           <p:cNvSpPr txBox="1"/>
           <p:nvPr/>
         </p:nvSpPr>
@@ -10577,7 +10649,7 @@
       </p:sp>
       <p:sp>
         <p:nvSpPr>
-          <p:cNvPr id="60" name="Rectangle 59"/>
+          <p:cNvPr id="61" name="Rectangle 60"/>
           <p:cNvSpPr/>
           <p:nvPr/>
         </p:nvSpPr>
@@ -10620,7 +10692,7 @@
       </p:sp>
       <p:sp>
         <p:nvSpPr>
-          <p:cNvPr id="61" name="TextBox 60"/>
+          <p:cNvPr id="62" name="TextBox 61"/>
           <p:cNvSpPr txBox="1"/>
           <p:nvPr/>
         </p:nvSpPr>
@@ -10662,7 +10734,7 @@
       </p:sp>
       <p:sp>
         <p:nvSpPr>
-          <p:cNvPr id="62" name="Rectangle 61"/>
+          <p:cNvPr id="63" name="Rectangle 62"/>
           <p:cNvSpPr/>
           <p:nvPr/>
         </p:nvSpPr>
@@ -10679,7 +10751,7 @@
           </a:solidFill>
           <a:ln w="3810">
             <a:solidFill>
-              <a:srgbClr val="D0D8DD"/>
+              <a:srgbClr val="D0D8D9"/>
             </a:solidFill>
           </a:ln>
         </p:spPr>
@@ -10707,7 +10779,7 @@
       </p:sp>
       <p:sp>
         <p:nvSpPr>
-          <p:cNvPr id="63" name="TextBox 62"/>
+          <p:cNvPr id="64" name="TextBox 63"/>
           <p:cNvSpPr txBox="1"/>
           <p:nvPr/>
         </p:nvSpPr>
@@ -10749,7 +10821,7 @@
       </p:sp>
       <p:sp>
         <p:nvSpPr>
-          <p:cNvPr id="64" name="TextBox 63"/>
+          <p:cNvPr id="65" name="TextBox 64"/>
           <p:cNvSpPr txBox="1"/>
           <p:nvPr/>
         </p:nvSpPr>
@@ -10791,7 +10863,7 @@
       </p:sp>
       <p:sp>
         <p:nvSpPr>
-          <p:cNvPr id="65" name="Rectangle 64"/>
+          <p:cNvPr id="66" name="Rectangle 65"/>
           <p:cNvSpPr/>
           <p:nvPr/>
         </p:nvSpPr>
@@ -10808,7 +10880,7 @@
           </a:solidFill>
           <a:ln w="3810">
             <a:solidFill>
-              <a:srgbClr val="D0D8DD"/>
+              <a:srgbClr val="D0D8D9"/>
             </a:solidFill>
           </a:ln>
         </p:spPr>
@@ -10836,7 +10908,7 @@
       </p:sp>
       <p:sp>
         <p:nvSpPr>
-          <p:cNvPr id="66" name="TextBox 65"/>
+          <p:cNvPr id="67" name="TextBox 66"/>
           <p:cNvSpPr txBox="1"/>
           <p:nvPr/>
         </p:nvSpPr>
@@ -10878,7 +10950,7 @@
       </p:sp>
       <p:sp>
         <p:nvSpPr>
-          <p:cNvPr id="67" name="TextBox 66"/>
+          <p:cNvPr id="68" name="TextBox 67"/>
           <p:cNvSpPr txBox="1"/>
           <p:nvPr/>
         </p:nvSpPr>
@@ -10920,7 +10992,7 @@
       </p:sp>
       <p:sp>
         <p:nvSpPr>
-          <p:cNvPr id="68" name="Rectangle 67"/>
+          <p:cNvPr id="69" name="Rectangle 68"/>
           <p:cNvSpPr/>
           <p:nvPr/>
         </p:nvSpPr>
@@ -10937,7 +11009,7 @@
           </a:solidFill>
           <a:ln w="3810">
             <a:solidFill>
-              <a:srgbClr val="D0D8DD"/>
+              <a:srgbClr val="D0D8D9"/>
             </a:solidFill>
           </a:ln>
         </p:spPr>
@@ -10965,7 +11037,7 @@
       </p:sp>
       <p:sp>
         <p:nvSpPr>
-          <p:cNvPr id="69" name="TextBox 68"/>
+          <p:cNvPr id="70" name="TextBox 69"/>
           <p:cNvSpPr txBox="1"/>
           <p:nvPr/>
         </p:nvSpPr>
@@ -11007,7 +11079,7 @@
       </p:sp>
       <p:sp>
         <p:nvSpPr>
-          <p:cNvPr id="70" name="TextBox 69"/>
+          <p:cNvPr id="71" name="TextBox 70"/>
           <p:cNvSpPr txBox="1"/>
           <p:nvPr/>
         </p:nvSpPr>
@@ -11049,7 +11121,7 @@
       </p:sp>
       <p:sp>
         <p:nvSpPr>
-          <p:cNvPr id="71" name="Rectangle 70"/>
+          <p:cNvPr id="72" name="Rectangle 71"/>
           <p:cNvSpPr/>
           <p:nvPr/>
         </p:nvSpPr>
@@ -11066,7 +11138,7 @@
           </a:solidFill>
           <a:ln w="3810">
             <a:solidFill>
-              <a:srgbClr val="D0D8DD"/>
+              <a:srgbClr val="D0D8D9"/>
             </a:solidFill>
           </a:ln>
         </p:spPr>
@@ -11094,7 +11166,7 @@
       </p:sp>
       <p:sp>
         <p:nvSpPr>
-          <p:cNvPr id="72" name="TextBox 71"/>
+          <p:cNvPr id="73" name="TextBox 72"/>
           <p:cNvSpPr txBox="1"/>
           <p:nvPr/>
         </p:nvSpPr>
@@ -11136,7 +11208,7 @@
       </p:sp>
       <p:sp>
         <p:nvSpPr>
-          <p:cNvPr id="73" name="TextBox 72"/>
+          <p:cNvPr id="74" name="TextBox 73"/>
           <p:cNvSpPr txBox="1"/>
           <p:nvPr/>
         </p:nvSpPr>
@@ -11178,7 +11250,7 @@
       </p:sp>
       <p:sp>
         <p:nvSpPr>
-          <p:cNvPr id="74" name="Rectangle 73"/>
+          <p:cNvPr id="75" name="Rectangle 74"/>
           <p:cNvSpPr/>
           <p:nvPr/>
         </p:nvSpPr>
@@ -11221,7 +11293,7 @@
       </p:sp>
       <p:sp>
         <p:nvSpPr>
-          <p:cNvPr id="75" name="TextBox 74"/>
+          <p:cNvPr id="76" name="TextBox 75"/>
           <p:cNvSpPr txBox="1"/>
           <p:nvPr/>
         </p:nvSpPr>
@@ -11263,7 +11335,7 @@
       </p:sp>
       <p:sp>
         <p:nvSpPr>
-          <p:cNvPr id="76" name="Rectangle 75"/>
+          <p:cNvPr id="77" name="Rectangle 76"/>
           <p:cNvSpPr/>
           <p:nvPr/>
         </p:nvSpPr>
@@ -11308,7 +11380,7 @@
       </p:sp>
       <p:sp>
         <p:nvSpPr>
-          <p:cNvPr id="77" name="TextBox 76"/>
+          <p:cNvPr id="78" name="TextBox 77"/>
           <p:cNvSpPr txBox="1"/>
           <p:nvPr/>
         </p:nvSpPr>
@@ -11350,7 +11422,7 @@
       </p:sp>
       <p:sp>
         <p:nvSpPr>
-          <p:cNvPr id="78" name="TextBox 77"/>
+          <p:cNvPr id="79" name="TextBox 78"/>
           <p:cNvSpPr txBox="1"/>
           <p:nvPr/>
         </p:nvSpPr>
@@ -11395,7 +11467,7 @@
       </p:sp>
       <p:sp>
         <p:nvSpPr>
-          <p:cNvPr id="79" name="Rectangle 78"/>
+          <p:cNvPr id="80" name="Rectangle 79"/>
           <p:cNvSpPr/>
           <p:nvPr/>
         </p:nvSpPr>
@@ -11408,7 +11480,7 @@
             <a:avLst/>
           </a:prstGeom>
           <a:solidFill>
-            <a:srgbClr val="D0D8DD"/>
+            <a:srgbClr val="D0D8D9"/>
           </a:solidFill>
           <a:ln>
             <a:noFill/>
@@ -11438,7 +11510,7 @@
       </p:sp>
       <p:sp>
         <p:nvSpPr>
-          <p:cNvPr id="80" name="TextBox 79"/>
+          <p:cNvPr id="81" name="TextBox 80"/>
           <p:cNvSpPr txBox="1"/>
           <p:nvPr/>
         </p:nvSpPr>
@@ -11598,7 +11670,7 @@
         <p:spPr>
           <a:xfrm>
             <a:off x="457200" y="402336"/>
-            <a:ext cx="10972800" cy="164592"/>
+            <a:ext cx="10058400" cy="164592"/>
           </a:xfrm>
           <a:prstGeom prst="rect">
             <a:avLst/>
@@ -11631,9 +11703,33 @@
           </a:p>
         </p:txBody>
       </p:sp>
-      <p:sp>
-        <p:nvSpPr>
-          <p:cNvPr id="5" name="Rectangle 4"/>
+      <p:pic>
+        <p:nvPicPr>
+          <p:cNvPr id="5" name="Picture 4" descr="sih_logo.png"/>
+          <p:cNvPicPr>
+            <a:picLocks noChangeAspect="1"/>
+          </p:cNvPicPr>
+          <p:nvPr/>
+        </p:nvPicPr>
+        <p:blipFill>
+          <a:blip r:embed="rId2"/>
+          <a:stretch>
+            <a:fillRect/>
+          </a:stretch>
+        </p:blipFill>
+        <p:spPr>
+          <a:xfrm>
+            <a:off x="10698480" y="36576"/>
+            <a:ext cx="1216152" cy="566928"/>
+          </a:xfrm>
+          <a:prstGeom prst="rect">
+            <a:avLst/>
+          </a:prstGeom>
+        </p:spPr>
+      </p:pic>
+      <p:sp>
+        <p:nvSpPr>
+          <p:cNvPr id="6" name="Rectangle 5"/>
           <p:cNvSpPr/>
           <p:nvPr/>
         </p:nvSpPr>
@@ -11646,7 +11742,7 @@
             <a:avLst/>
           </a:prstGeom>
           <a:solidFill>
-            <a:srgbClr val="D0D8DD"/>
+            <a:srgbClr val="D0D8D9"/>
           </a:solidFill>
           <a:ln>
             <a:noFill/>
@@ -11676,7 +11772,7 @@
       </p:sp>
       <p:sp>
         <p:nvSpPr>
-          <p:cNvPr id="6" name="Rectangle 5"/>
+          <p:cNvPr id="7" name="Rectangle 6"/>
           <p:cNvSpPr/>
           <p:nvPr/>
         </p:nvSpPr>
@@ -11721,7 +11817,7 @@
       </p:sp>
       <p:sp>
         <p:nvSpPr>
-          <p:cNvPr id="7" name="TextBox 6"/>
+          <p:cNvPr id="8" name="TextBox 7"/>
           <p:cNvSpPr txBox="1"/>
           <p:nvPr/>
         </p:nvSpPr>
@@ -11763,7 +11859,7 @@
       </p:sp>
       <p:sp>
         <p:nvSpPr>
-          <p:cNvPr id="8" name="TextBox 7"/>
+          <p:cNvPr id="9" name="TextBox 8"/>
           <p:cNvSpPr txBox="1"/>
           <p:nvPr/>
         </p:nvSpPr>
@@ -11805,7 +11901,7 @@
       </p:sp>
       <p:sp>
         <p:nvSpPr>
-          <p:cNvPr id="9" name="Rectangle 8"/>
+          <p:cNvPr id="10" name="Rectangle 9"/>
           <p:cNvSpPr/>
           <p:nvPr/>
         </p:nvSpPr>
@@ -11822,7 +11918,7 @@
           </a:solidFill>
           <a:ln w="5080">
             <a:solidFill>
-              <a:srgbClr val="D0D8DD"/>
+              <a:srgbClr val="D0D8D9"/>
             </a:solidFill>
           </a:ln>
         </p:spPr>
@@ -11850,7 +11946,7 @@
       </p:sp>
       <p:sp>
         <p:nvSpPr>
-          <p:cNvPr id="10" name="Rectangle 9"/>
+          <p:cNvPr id="11" name="Rectangle 10"/>
           <p:cNvSpPr/>
           <p:nvPr/>
         </p:nvSpPr>
@@ -11893,7 +11989,7 @@
       </p:sp>
       <p:sp>
         <p:nvSpPr>
-          <p:cNvPr id="11" name="TextBox 10"/>
+          <p:cNvPr id="12" name="TextBox 11"/>
           <p:cNvSpPr txBox="1"/>
           <p:nvPr/>
         </p:nvSpPr>
@@ -11935,7 +12031,7 @@
       </p:sp>
       <p:sp>
         <p:nvSpPr>
-          <p:cNvPr id="12" name="Rectangle 11"/>
+          <p:cNvPr id="13" name="Rectangle 12"/>
           <p:cNvSpPr/>
           <p:nvPr/>
         </p:nvSpPr>
@@ -11952,7 +12048,7 @@
           </a:solidFill>
           <a:ln w="3810">
             <a:solidFill>
-              <a:srgbClr val="D0D8DD"/>
+              <a:srgbClr val="D0D8D9"/>
             </a:solidFill>
           </a:ln>
         </p:spPr>
@@ -11980,7 +12076,7 @@
       </p:sp>
       <p:sp>
         <p:nvSpPr>
-          <p:cNvPr id="13" name="TextBox 12"/>
+          <p:cNvPr id="14" name="TextBox 13"/>
           <p:cNvSpPr txBox="1"/>
           <p:nvPr/>
         </p:nvSpPr>
@@ -12022,7 +12118,7 @@
       </p:sp>
       <p:sp>
         <p:nvSpPr>
-          <p:cNvPr id="14" name="TextBox 13"/>
+          <p:cNvPr id="15" name="TextBox 14"/>
           <p:cNvSpPr txBox="1"/>
           <p:nvPr/>
         </p:nvSpPr>
@@ -12064,7 +12160,7 @@
       </p:sp>
       <p:sp>
         <p:nvSpPr>
-          <p:cNvPr id="15" name="Rectangle 14"/>
+          <p:cNvPr id="16" name="Rectangle 15"/>
           <p:cNvSpPr/>
           <p:nvPr/>
         </p:nvSpPr>
@@ -12081,7 +12177,7 @@
           </a:solidFill>
           <a:ln w="3810">
             <a:solidFill>
-              <a:srgbClr val="D0D8DD"/>
+              <a:srgbClr val="D0D8D9"/>
             </a:solidFill>
           </a:ln>
         </p:spPr>
@@ -12109,7 +12205,7 @@
       </p:sp>
       <p:sp>
         <p:nvSpPr>
-          <p:cNvPr id="16" name="TextBox 15"/>
+          <p:cNvPr id="17" name="TextBox 16"/>
           <p:cNvSpPr txBox="1"/>
           <p:nvPr/>
         </p:nvSpPr>
@@ -12151,7 +12247,7 @@
       </p:sp>
       <p:sp>
         <p:nvSpPr>
-          <p:cNvPr id="17" name="TextBox 16"/>
+          <p:cNvPr id="18" name="TextBox 17"/>
           <p:cNvSpPr txBox="1"/>
           <p:nvPr/>
         </p:nvSpPr>
@@ -12193,7 +12289,7 @@
       </p:sp>
       <p:sp>
         <p:nvSpPr>
-          <p:cNvPr id="18" name="Rectangle 17"/>
+          <p:cNvPr id="19" name="Rectangle 18"/>
           <p:cNvSpPr/>
           <p:nvPr/>
         </p:nvSpPr>
@@ -12210,7 +12306,7 @@
           </a:solidFill>
           <a:ln w="3810">
             <a:solidFill>
-              <a:srgbClr val="D0D8DD"/>
+              <a:srgbClr val="D0D8D9"/>
             </a:solidFill>
           </a:ln>
         </p:spPr>
@@ -12238,7 +12334,7 @@
       </p:sp>
       <p:sp>
         <p:nvSpPr>
-          <p:cNvPr id="19" name="TextBox 18"/>
+          <p:cNvPr id="20" name="TextBox 19"/>
           <p:cNvSpPr txBox="1"/>
           <p:nvPr/>
         </p:nvSpPr>
@@ -12280,7 +12376,7 @@
       </p:sp>
       <p:sp>
         <p:nvSpPr>
-          <p:cNvPr id="20" name="TextBox 19"/>
+          <p:cNvPr id="21" name="TextBox 20"/>
           <p:cNvSpPr txBox="1"/>
           <p:nvPr/>
         </p:nvSpPr>
@@ -12322,7 +12418,7 @@
       </p:sp>
       <p:sp>
         <p:nvSpPr>
-          <p:cNvPr id="21" name="Rectangle 20"/>
+          <p:cNvPr id="22" name="Rectangle 21"/>
           <p:cNvSpPr/>
           <p:nvPr/>
         </p:nvSpPr>
@@ -12339,7 +12435,7 @@
           </a:solidFill>
           <a:ln w="3810">
             <a:solidFill>
-              <a:srgbClr val="D0D8DD"/>
+              <a:srgbClr val="D0D8D9"/>
             </a:solidFill>
           </a:ln>
         </p:spPr>
@@ -12367,7 +12463,7 @@
       </p:sp>
       <p:sp>
         <p:nvSpPr>
-          <p:cNvPr id="22" name="TextBox 21"/>
+          <p:cNvPr id="23" name="TextBox 22"/>
           <p:cNvSpPr txBox="1"/>
           <p:nvPr/>
         </p:nvSpPr>
@@ -12409,7 +12505,7 @@
       </p:sp>
       <p:sp>
         <p:nvSpPr>
-          <p:cNvPr id="23" name="TextBox 22"/>
+          <p:cNvPr id="24" name="TextBox 23"/>
           <p:cNvSpPr txBox="1"/>
           <p:nvPr/>
         </p:nvSpPr>
@@ -12451,7 +12547,7 @@
       </p:sp>
       <p:sp>
         <p:nvSpPr>
-          <p:cNvPr id="24" name="Rectangle 23"/>
+          <p:cNvPr id="25" name="Rectangle 24"/>
           <p:cNvSpPr/>
           <p:nvPr/>
         </p:nvSpPr>
@@ -12468,7 +12564,7 @@
           </a:solidFill>
           <a:ln w="5080">
             <a:solidFill>
-              <a:srgbClr val="D0D8DD"/>
+              <a:srgbClr val="D0D8D9"/>
             </a:solidFill>
           </a:ln>
         </p:spPr>
@@ -12496,7 +12592,7 @@
       </p:sp>
       <p:sp>
         <p:nvSpPr>
-          <p:cNvPr id="25" name="Rectangle 24"/>
+          <p:cNvPr id="26" name="Rectangle 25"/>
           <p:cNvSpPr/>
           <p:nvPr/>
         </p:nvSpPr>
@@ -12539,7 +12635,7 @@
       </p:sp>
       <p:sp>
         <p:nvSpPr>
-          <p:cNvPr id="26" name="TextBox 25"/>
+          <p:cNvPr id="27" name="TextBox 26"/>
           <p:cNvSpPr txBox="1"/>
           <p:nvPr/>
         </p:nvSpPr>
@@ -12581,7 +12677,7 @@
       </p:sp>
       <p:sp>
         <p:nvSpPr>
-          <p:cNvPr id="27" name="Rectangle 26"/>
+          <p:cNvPr id="28" name="Rectangle 27"/>
           <p:cNvSpPr/>
           <p:nvPr/>
         </p:nvSpPr>
@@ -12598,7 +12694,7 @@
           </a:solidFill>
           <a:ln w="3810">
             <a:solidFill>
-              <a:srgbClr val="D0D8DD"/>
+              <a:srgbClr val="D0D8D9"/>
             </a:solidFill>
           </a:ln>
         </p:spPr>
@@ -12626,7 +12722,7 @@
       </p:sp>
       <p:sp>
         <p:nvSpPr>
-          <p:cNvPr id="28" name="TextBox 27"/>
+          <p:cNvPr id="29" name="TextBox 28"/>
           <p:cNvSpPr txBox="1"/>
           <p:nvPr/>
         </p:nvSpPr>
@@ -12668,7 +12764,7 @@
       </p:sp>
       <p:sp>
         <p:nvSpPr>
-          <p:cNvPr id="29" name="TextBox 28"/>
+          <p:cNvPr id="30" name="TextBox 29"/>
           <p:cNvSpPr txBox="1"/>
           <p:nvPr/>
         </p:nvSpPr>
@@ -12710,7 +12806,7 @@
       </p:sp>
       <p:sp>
         <p:nvSpPr>
-          <p:cNvPr id="30" name="Rectangle 29"/>
+          <p:cNvPr id="31" name="Rectangle 30"/>
           <p:cNvSpPr/>
           <p:nvPr/>
         </p:nvSpPr>
@@ -12727,7 +12823,7 @@
           </a:solidFill>
           <a:ln w="3810">
             <a:solidFill>
-              <a:srgbClr val="D0D8DD"/>
+              <a:srgbClr val="D0D8D9"/>
             </a:solidFill>
           </a:ln>
         </p:spPr>
@@ -12755,7 +12851,7 @@
       </p:sp>
       <p:sp>
         <p:nvSpPr>
-          <p:cNvPr id="31" name="TextBox 30"/>
+          <p:cNvPr id="32" name="TextBox 31"/>
           <p:cNvSpPr txBox="1"/>
           <p:nvPr/>
         </p:nvSpPr>
@@ -12797,7 +12893,7 @@
       </p:sp>
       <p:sp>
         <p:nvSpPr>
-          <p:cNvPr id="32" name="TextBox 31"/>
+          <p:cNvPr id="33" name="TextBox 32"/>
           <p:cNvSpPr txBox="1"/>
           <p:nvPr/>
         </p:nvSpPr>
@@ -12839,7 +12935,7 @@
       </p:sp>
       <p:sp>
         <p:nvSpPr>
-          <p:cNvPr id="33" name="Rectangle 32"/>
+          <p:cNvPr id="34" name="Rectangle 33"/>
           <p:cNvSpPr/>
           <p:nvPr/>
         </p:nvSpPr>
@@ -12856,7 +12952,7 @@
           </a:solidFill>
           <a:ln w="3810">
             <a:solidFill>
-              <a:srgbClr val="D0D8DD"/>
+              <a:srgbClr val="D0D8D9"/>
             </a:solidFill>
           </a:ln>
         </p:spPr>
@@ -12884,7 +12980,7 @@
       </p:sp>
       <p:sp>
         <p:nvSpPr>
-          <p:cNvPr id="34" name="TextBox 33"/>
+          <p:cNvPr id="35" name="TextBox 34"/>
           <p:cNvSpPr txBox="1"/>
           <p:nvPr/>
         </p:nvSpPr>
@@ -12926,7 +13022,7 @@
       </p:sp>
       <p:sp>
         <p:nvSpPr>
-          <p:cNvPr id="35" name="TextBox 34"/>
+          <p:cNvPr id="36" name="TextBox 35"/>
           <p:cNvSpPr txBox="1"/>
           <p:nvPr/>
         </p:nvSpPr>
@@ -12968,7 +13064,7 @@
       </p:sp>
       <p:sp>
         <p:nvSpPr>
-          <p:cNvPr id="36" name="Rectangle 35"/>
+          <p:cNvPr id="37" name="Rectangle 36"/>
           <p:cNvSpPr/>
           <p:nvPr/>
         </p:nvSpPr>
@@ -12985,7 +13081,7 @@
           </a:solidFill>
           <a:ln w="3810">
             <a:solidFill>
-              <a:srgbClr val="D0D8DD"/>
+              <a:srgbClr val="D0D8D9"/>
             </a:solidFill>
           </a:ln>
         </p:spPr>
@@ -13013,7 +13109,7 @@
       </p:sp>
       <p:sp>
         <p:nvSpPr>
-          <p:cNvPr id="37" name="TextBox 36"/>
+          <p:cNvPr id="38" name="TextBox 37"/>
           <p:cNvSpPr txBox="1"/>
           <p:nvPr/>
         </p:nvSpPr>
@@ -13055,7 +13151,7 @@
       </p:sp>
       <p:sp>
         <p:nvSpPr>
-          <p:cNvPr id="38" name="TextBox 37"/>
+          <p:cNvPr id="39" name="TextBox 38"/>
           <p:cNvSpPr txBox="1"/>
           <p:nvPr/>
         </p:nvSpPr>
@@ -13097,7 +13193,7 @@
       </p:sp>
       <p:sp>
         <p:nvSpPr>
-          <p:cNvPr id="39" name="Rectangle 38"/>
+          <p:cNvPr id="40" name="Rectangle 39"/>
           <p:cNvSpPr/>
           <p:nvPr/>
         </p:nvSpPr>
@@ -13114,7 +13210,7 @@
           </a:solidFill>
           <a:ln w="3810">
             <a:solidFill>
-              <a:srgbClr val="D0D8DD"/>
+              <a:srgbClr val="D0D8D9"/>
             </a:solidFill>
           </a:ln>
         </p:spPr>
@@ -13142,7 +13238,7 @@
       </p:sp>
       <p:sp>
         <p:nvSpPr>
-          <p:cNvPr id="40" name="TextBox 39"/>
+          <p:cNvPr id="41" name="TextBox 40"/>
           <p:cNvSpPr txBox="1"/>
           <p:nvPr/>
         </p:nvSpPr>
@@ -13184,7 +13280,7 @@
       </p:sp>
       <p:sp>
         <p:nvSpPr>
-          <p:cNvPr id="41" name="TextBox 40"/>
+          <p:cNvPr id="42" name="TextBox 41"/>
           <p:cNvSpPr txBox="1"/>
           <p:nvPr/>
         </p:nvSpPr>
@@ -13226,7 +13322,7 @@
       </p:sp>
       <p:sp>
         <p:nvSpPr>
-          <p:cNvPr id="42" name="Rectangle 41"/>
+          <p:cNvPr id="43" name="Rectangle 42"/>
           <p:cNvSpPr/>
           <p:nvPr/>
         </p:nvSpPr>
@@ -13243,7 +13339,7 @@
           </a:solidFill>
           <a:ln w="5080">
             <a:solidFill>
-              <a:srgbClr val="D0D8DD"/>
+              <a:srgbClr val="D0D8D9"/>
             </a:solidFill>
           </a:ln>
         </p:spPr>
@@ -13271,7 +13367,7 @@
       </p:sp>
       <p:sp>
         <p:nvSpPr>
-          <p:cNvPr id="43" name="Rectangle 42"/>
+          <p:cNvPr id="44" name="Rectangle 43"/>
           <p:cNvSpPr/>
           <p:nvPr/>
         </p:nvSpPr>
@@ -13314,7 +13410,7 @@
       </p:sp>
       <p:sp>
         <p:nvSpPr>
-          <p:cNvPr id="44" name="TextBox 43"/>
+          <p:cNvPr id="45" name="TextBox 44"/>
           <p:cNvSpPr txBox="1"/>
           <p:nvPr/>
         </p:nvSpPr>
@@ -13356,7 +13452,7 @@
       </p:sp>
       <p:sp>
         <p:nvSpPr>
-          <p:cNvPr id="45" name="Rectangle 44"/>
+          <p:cNvPr id="46" name="Rectangle 45"/>
           <p:cNvSpPr/>
           <p:nvPr/>
         </p:nvSpPr>
@@ -13373,7 +13469,7 @@
           </a:solidFill>
           <a:ln w="3810">
             <a:solidFill>
-              <a:srgbClr val="D0D8DD"/>
+              <a:srgbClr val="D0D8D9"/>
             </a:solidFill>
           </a:ln>
         </p:spPr>
@@ -13401,7 +13497,7 @@
       </p:sp>
       <p:sp>
         <p:nvSpPr>
-          <p:cNvPr id="46" name="TextBox 45"/>
+          <p:cNvPr id="47" name="TextBox 46"/>
           <p:cNvSpPr txBox="1"/>
           <p:nvPr/>
         </p:nvSpPr>
@@ -13443,7 +13539,7 @@
       </p:sp>
       <p:sp>
         <p:nvSpPr>
-          <p:cNvPr id="47" name="TextBox 46"/>
+          <p:cNvPr id="48" name="TextBox 47"/>
           <p:cNvSpPr txBox="1"/>
           <p:nvPr/>
         </p:nvSpPr>
@@ -13485,7 +13581,7 @@
       </p:sp>
       <p:sp>
         <p:nvSpPr>
-          <p:cNvPr id="48" name="Rectangle 47"/>
+          <p:cNvPr id="49" name="Rectangle 48"/>
           <p:cNvSpPr/>
           <p:nvPr/>
         </p:nvSpPr>
@@ -13502,7 +13598,7 @@
           </a:solidFill>
           <a:ln w="3810">
             <a:solidFill>
-              <a:srgbClr val="D0D8DD"/>
+              <a:srgbClr val="D0D8D9"/>
             </a:solidFill>
           </a:ln>
         </p:spPr>
@@ -13530,7 +13626,7 @@
       </p:sp>
       <p:sp>
         <p:nvSpPr>
-          <p:cNvPr id="49" name="TextBox 48"/>
+          <p:cNvPr id="50" name="TextBox 49"/>
           <p:cNvSpPr txBox="1"/>
           <p:nvPr/>
         </p:nvSpPr>
@@ -13572,7 +13668,7 @@
       </p:sp>
       <p:sp>
         <p:nvSpPr>
-          <p:cNvPr id="50" name="TextBox 49"/>
+          <p:cNvPr id="51" name="TextBox 50"/>
           <p:cNvSpPr txBox="1"/>
           <p:nvPr/>
         </p:nvSpPr>
@@ -13614,7 +13710,7 @@
       </p:sp>
       <p:sp>
         <p:nvSpPr>
-          <p:cNvPr id="51" name="Rectangle 50"/>
+          <p:cNvPr id="52" name="Rectangle 51"/>
           <p:cNvSpPr/>
           <p:nvPr/>
         </p:nvSpPr>
@@ -13631,7 +13727,7 @@
           </a:solidFill>
           <a:ln w="3810">
             <a:solidFill>
-              <a:srgbClr val="D0D8DD"/>
+              <a:srgbClr val="D0D8D9"/>
             </a:solidFill>
           </a:ln>
         </p:spPr>
@@ -13659,7 +13755,7 @@
       </p:sp>
       <p:sp>
         <p:nvSpPr>
-          <p:cNvPr id="52" name="TextBox 51"/>
+          <p:cNvPr id="53" name="TextBox 52"/>
           <p:cNvSpPr txBox="1"/>
           <p:nvPr/>
         </p:nvSpPr>
@@ -13701,7 +13797,7 @@
       </p:sp>
       <p:sp>
         <p:nvSpPr>
-          <p:cNvPr id="53" name="TextBox 52"/>
+          <p:cNvPr id="54" name="TextBox 53"/>
           <p:cNvSpPr txBox="1"/>
           <p:nvPr/>
         </p:nvSpPr>
@@ -13743,7 +13839,7 @@
       </p:sp>
       <p:sp>
         <p:nvSpPr>
-          <p:cNvPr id="54" name="Rectangle 53"/>
+          <p:cNvPr id="55" name="Rectangle 54"/>
           <p:cNvSpPr/>
           <p:nvPr/>
         </p:nvSpPr>
@@ -13760,7 +13856,7 @@
           </a:solidFill>
           <a:ln w="3810">
             <a:solidFill>
-              <a:srgbClr val="D0D8DD"/>
+              <a:srgbClr val="D0D8D9"/>
             </a:solidFill>
           </a:ln>
         </p:spPr>
@@ -13788,7 +13884,7 @@
       </p:sp>
       <p:sp>
         <p:nvSpPr>
-          <p:cNvPr id="55" name="TextBox 54"/>
+          <p:cNvPr id="56" name="TextBox 55"/>
           <p:cNvSpPr txBox="1"/>
           <p:nvPr/>
         </p:nvSpPr>
@@ -13830,7 +13926,7 @@
       </p:sp>
       <p:sp>
         <p:nvSpPr>
-          <p:cNvPr id="56" name="TextBox 55"/>
+          <p:cNvPr id="57" name="TextBox 56"/>
           <p:cNvSpPr txBox="1"/>
           <p:nvPr/>
         </p:nvSpPr>
@@ -13872,7 +13968,7 @@
       </p:sp>
       <p:sp>
         <p:nvSpPr>
-          <p:cNvPr id="57" name="Rectangle 56"/>
+          <p:cNvPr id="58" name="Rectangle 57"/>
           <p:cNvSpPr/>
           <p:nvPr/>
         </p:nvSpPr>
@@ -13889,7 +13985,7 @@
           </a:solidFill>
           <a:ln w="3810">
             <a:solidFill>
-              <a:srgbClr val="D0D8DD"/>
+              <a:srgbClr val="D0D8D9"/>
             </a:solidFill>
           </a:ln>
         </p:spPr>
@@ -13917,7 +14013,7 @@
       </p:sp>
       <p:sp>
         <p:nvSpPr>
-          <p:cNvPr id="58" name="TextBox 57"/>
+          <p:cNvPr id="59" name="TextBox 58"/>
           <p:cNvSpPr txBox="1"/>
           <p:nvPr/>
         </p:nvSpPr>
@@ -13959,7 +14055,7 @@
       </p:sp>
       <p:sp>
         <p:nvSpPr>
-          <p:cNvPr id="59" name="TextBox 58"/>
+          <p:cNvPr id="60" name="TextBox 59"/>
           <p:cNvSpPr txBox="1"/>
           <p:nvPr/>
         </p:nvSpPr>
@@ -14001,7 +14097,7 @@
       </p:sp>
       <p:sp>
         <p:nvSpPr>
-          <p:cNvPr id="60" name="Rectangle 59"/>
+          <p:cNvPr id="61" name="Rectangle 60"/>
           <p:cNvSpPr/>
           <p:nvPr/>
         </p:nvSpPr>
@@ -14046,7 +14142,7 @@
       </p:sp>
       <p:sp>
         <p:nvSpPr>
-          <p:cNvPr id="61" name="TextBox 60"/>
+          <p:cNvPr id="62" name="TextBox 61"/>
           <p:cNvSpPr txBox="1"/>
           <p:nvPr/>
         </p:nvSpPr>
@@ -14088,7 +14184,7 @@
       </p:sp>
       <p:sp>
         <p:nvSpPr>
-          <p:cNvPr id="62" name="Rectangle 61"/>
+          <p:cNvPr id="63" name="Rectangle 62"/>
           <p:cNvSpPr/>
           <p:nvPr/>
         </p:nvSpPr>
@@ -14101,7 +14197,7 @@
             <a:avLst/>
           </a:prstGeom>
           <a:solidFill>
-            <a:srgbClr val="D0D8DD"/>
+            <a:srgbClr val="D0D8D9"/>
           </a:solidFill>
           <a:ln>
             <a:noFill/>
@@ -14131,7 +14227,7 @@
       </p:sp>
       <p:sp>
         <p:nvSpPr>
-          <p:cNvPr id="63" name="TextBox 62"/>
+          <p:cNvPr id="64" name="TextBox 63"/>
           <p:cNvSpPr txBox="1"/>
           <p:nvPr/>
         </p:nvSpPr>
@@ -14291,7 +14387,7 @@
         <p:spPr>
           <a:xfrm>
             <a:off x="457200" y="402336"/>
-            <a:ext cx="10972800" cy="164592"/>
+            <a:ext cx="10058400" cy="164592"/>
           </a:xfrm>
           <a:prstGeom prst="rect">
             <a:avLst/>
@@ -14324,9 +14420,33 @@
           </a:p>
         </p:txBody>
       </p:sp>
-      <p:sp>
-        <p:nvSpPr>
-          <p:cNvPr id="5" name="Rectangle 4"/>
+      <p:pic>
+        <p:nvPicPr>
+          <p:cNvPr id="5" name="Picture 4" descr="sih_logo.png"/>
+          <p:cNvPicPr>
+            <a:picLocks noChangeAspect="1"/>
+          </p:cNvPicPr>
+          <p:nvPr/>
+        </p:nvPicPr>
+        <p:blipFill>
+          <a:blip r:embed="rId2"/>
+          <a:stretch>
+            <a:fillRect/>
+          </a:stretch>
+        </p:blipFill>
+        <p:spPr>
+          <a:xfrm>
+            <a:off x="10698480" y="36576"/>
+            <a:ext cx="1216152" cy="566928"/>
+          </a:xfrm>
+          <a:prstGeom prst="rect">
+            <a:avLst/>
+          </a:prstGeom>
+        </p:spPr>
+      </p:pic>
+      <p:sp>
+        <p:nvSpPr>
+          <p:cNvPr id="6" name="Rectangle 5"/>
           <p:cNvSpPr/>
           <p:nvPr/>
         </p:nvSpPr>
@@ -14339,7 +14459,7 @@
             <a:avLst/>
           </a:prstGeom>
           <a:solidFill>
-            <a:srgbClr val="D0D8DD"/>
+            <a:srgbClr val="D0D8D9"/>
           </a:solidFill>
           <a:ln>
             <a:noFill/>
@@ -14369,7 +14489,7 @@
       </p:sp>
       <p:sp>
         <p:nvSpPr>
-          <p:cNvPr id="6" name="Rectangle 5"/>
+          <p:cNvPr id="7" name="Rectangle 6"/>
           <p:cNvSpPr/>
           <p:nvPr/>
         </p:nvSpPr>
@@ -14412,7 +14532,7 @@
       </p:sp>
       <p:sp>
         <p:nvSpPr>
-          <p:cNvPr id="7" name="TextBox 6"/>
+          <p:cNvPr id="8" name="TextBox 7"/>
           <p:cNvSpPr txBox="1"/>
           <p:nvPr/>
         </p:nvSpPr>
@@ -14454,7 +14574,7 @@
       </p:sp>
       <p:sp>
         <p:nvSpPr>
-          <p:cNvPr id="8" name="Rectangle 7"/>
+          <p:cNvPr id="9" name="Rectangle 8"/>
           <p:cNvSpPr/>
           <p:nvPr/>
         </p:nvSpPr>
@@ -14471,7 +14591,7 @@
           </a:solidFill>
           <a:ln w="5080">
             <a:solidFill>
-              <a:srgbClr val="D0D8DD"/>
+              <a:srgbClr val="D0D8D9"/>
             </a:solidFill>
           </a:ln>
         </p:spPr>
@@ -14499,7 +14619,7 @@
       </p:sp>
       <p:sp>
         <p:nvSpPr>
-          <p:cNvPr id="9" name="Rectangle 8"/>
+          <p:cNvPr id="10" name="Rectangle 9"/>
           <p:cNvSpPr/>
           <p:nvPr/>
         </p:nvSpPr>
@@ -14516,7 +14636,7 @@
           </a:solidFill>
           <a:ln w="3810">
             <a:solidFill>
-              <a:srgbClr val="D0D8DD"/>
+              <a:srgbClr val="D0D8D9"/>
             </a:solidFill>
           </a:ln>
         </p:spPr>
@@ -14544,7 +14664,7 @@
       </p:sp>
       <p:sp>
         <p:nvSpPr>
-          <p:cNvPr id="10" name="TextBox 9"/>
+          <p:cNvPr id="11" name="TextBox 10"/>
           <p:cNvSpPr txBox="1"/>
           <p:nvPr/>
         </p:nvSpPr>
@@ -14586,7 +14706,7 @@
       </p:sp>
       <p:sp>
         <p:nvSpPr>
-          <p:cNvPr id="11" name="TextBox 10"/>
+          <p:cNvPr id="12" name="TextBox 11"/>
           <p:cNvSpPr txBox="1"/>
           <p:nvPr/>
         </p:nvSpPr>
@@ -14628,7 +14748,7 @@
       </p:sp>
       <p:sp>
         <p:nvSpPr>
-          <p:cNvPr id="12" name="Rectangle 11"/>
+          <p:cNvPr id="13" name="Rectangle 12"/>
           <p:cNvSpPr/>
           <p:nvPr/>
         </p:nvSpPr>
@@ -14645,7 +14765,7 @@
           </a:solidFill>
           <a:ln w="3810">
             <a:solidFill>
-              <a:srgbClr val="D0D8DD"/>
+              <a:srgbClr val="D0D8D9"/>
             </a:solidFill>
           </a:ln>
         </p:spPr>
@@ -14673,7 +14793,7 @@
       </p:sp>
       <p:sp>
         <p:nvSpPr>
-          <p:cNvPr id="13" name="TextBox 12"/>
+          <p:cNvPr id="14" name="TextBox 13"/>
           <p:cNvSpPr txBox="1"/>
           <p:nvPr/>
         </p:nvSpPr>
@@ -14715,7 +14835,7 @@
       </p:sp>
       <p:sp>
         <p:nvSpPr>
-          <p:cNvPr id="14" name="TextBox 13"/>
+          <p:cNvPr id="15" name="TextBox 14"/>
           <p:cNvSpPr txBox="1"/>
           <p:nvPr/>
         </p:nvSpPr>
@@ -14757,7 +14877,7 @@
       </p:sp>
       <p:sp>
         <p:nvSpPr>
-          <p:cNvPr id="15" name="Rectangle 14"/>
+          <p:cNvPr id="16" name="Rectangle 15"/>
           <p:cNvSpPr/>
           <p:nvPr/>
         </p:nvSpPr>
@@ -14774,7 +14894,7 @@
           </a:solidFill>
           <a:ln w="3810">
             <a:solidFill>
-              <a:srgbClr val="D0D8DD"/>
+              <a:srgbClr val="D0D8D9"/>
             </a:solidFill>
           </a:ln>
         </p:spPr>
@@ -14802,7 +14922,7 @@
       </p:sp>
       <p:sp>
         <p:nvSpPr>
-          <p:cNvPr id="16" name="TextBox 15"/>
+          <p:cNvPr id="17" name="TextBox 16"/>
           <p:cNvSpPr txBox="1"/>
           <p:nvPr/>
         </p:nvSpPr>
@@ -14844,7 +14964,7 @@
       </p:sp>
       <p:sp>
         <p:nvSpPr>
-          <p:cNvPr id="17" name="TextBox 16"/>
+          <p:cNvPr id="18" name="TextBox 17"/>
           <p:cNvSpPr txBox="1"/>
           <p:nvPr/>
         </p:nvSpPr>
@@ -14886,7 +15006,7 @@
       </p:sp>
       <p:sp>
         <p:nvSpPr>
-          <p:cNvPr id="18" name="Rectangle 17"/>
+          <p:cNvPr id="19" name="Rectangle 18"/>
           <p:cNvSpPr/>
           <p:nvPr/>
         </p:nvSpPr>
@@ -14929,7 +15049,7 @@
       </p:sp>
       <p:sp>
         <p:nvSpPr>
-          <p:cNvPr id="19" name="TextBox 18"/>
+          <p:cNvPr id="20" name="TextBox 19"/>
           <p:cNvSpPr txBox="1"/>
           <p:nvPr/>
         </p:nvSpPr>
@@ -14971,7 +15091,7 @@
       </p:sp>
       <p:sp>
         <p:nvSpPr>
-          <p:cNvPr id="20" name="Rectangle 19"/>
+          <p:cNvPr id="21" name="Rectangle 20"/>
           <p:cNvSpPr/>
           <p:nvPr/>
         </p:nvSpPr>
@@ -14988,7 +15108,7 @@
           </a:solidFill>
           <a:ln w="5080">
             <a:solidFill>
-              <a:srgbClr val="D0D8DD"/>
+              <a:srgbClr val="D0D8D9"/>
             </a:solidFill>
           </a:ln>
         </p:spPr>
@@ -15016,7 +15136,7 @@
       </p:sp>
       <p:sp>
         <p:nvSpPr>
-          <p:cNvPr id="21" name="Rectangle 20"/>
+          <p:cNvPr id="22" name="Rectangle 21"/>
           <p:cNvSpPr/>
           <p:nvPr/>
         </p:nvSpPr>
@@ -15033,7 +15153,7 @@
           </a:solidFill>
           <a:ln w="3810">
             <a:solidFill>
-              <a:srgbClr val="D0D8DD"/>
+              <a:srgbClr val="D0D8D9"/>
             </a:solidFill>
           </a:ln>
         </p:spPr>
@@ -15061,7 +15181,7 @@
       </p:sp>
       <p:sp>
         <p:nvSpPr>
-          <p:cNvPr id="22" name="TextBox 21"/>
+          <p:cNvPr id="23" name="TextBox 22"/>
           <p:cNvSpPr txBox="1"/>
           <p:nvPr/>
         </p:nvSpPr>
@@ -15103,7 +15223,7 @@
       </p:sp>
       <p:sp>
         <p:nvSpPr>
-          <p:cNvPr id="23" name="TextBox 22"/>
+          <p:cNvPr id="24" name="TextBox 23"/>
           <p:cNvSpPr txBox="1"/>
           <p:nvPr/>
         </p:nvSpPr>
@@ -15145,7 +15265,7 @@
       </p:sp>
       <p:sp>
         <p:nvSpPr>
-          <p:cNvPr id="24" name="Rectangle 23"/>
+          <p:cNvPr id="25" name="Rectangle 24"/>
           <p:cNvSpPr/>
           <p:nvPr/>
         </p:nvSpPr>
@@ -15162,7 +15282,7 @@
           </a:solidFill>
           <a:ln w="3810">
             <a:solidFill>
-              <a:srgbClr val="D0D8DD"/>
+              <a:srgbClr val="D0D8D9"/>
             </a:solidFill>
           </a:ln>
         </p:spPr>
@@ -15190,7 +15310,7 @@
       </p:sp>
       <p:sp>
         <p:nvSpPr>
-          <p:cNvPr id="25" name="TextBox 24"/>
+          <p:cNvPr id="26" name="TextBox 25"/>
           <p:cNvSpPr txBox="1"/>
           <p:nvPr/>
         </p:nvSpPr>
@@ -15232,7 +15352,7 @@
       </p:sp>
       <p:sp>
         <p:nvSpPr>
-          <p:cNvPr id="26" name="TextBox 25"/>
+          <p:cNvPr id="27" name="TextBox 26"/>
           <p:cNvSpPr txBox="1"/>
           <p:nvPr/>
         </p:nvSpPr>
@@ -15274,7 +15394,7 @@
       </p:sp>
       <p:sp>
         <p:nvSpPr>
-          <p:cNvPr id="27" name="Rectangle 26"/>
+          <p:cNvPr id="28" name="Rectangle 27"/>
           <p:cNvSpPr/>
           <p:nvPr/>
         </p:nvSpPr>
@@ -15291,7 +15411,7 @@
           </a:solidFill>
           <a:ln w="3810">
             <a:solidFill>
-              <a:srgbClr val="D0D8DD"/>
+              <a:srgbClr val="D0D8D9"/>
             </a:solidFill>
           </a:ln>
         </p:spPr>
@@ -15319,7 +15439,7 @@
       </p:sp>
       <p:sp>
         <p:nvSpPr>
-          <p:cNvPr id="28" name="TextBox 27"/>
+          <p:cNvPr id="29" name="TextBox 28"/>
           <p:cNvSpPr txBox="1"/>
           <p:nvPr/>
         </p:nvSpPr>
@@ -15361,7 +15481,7 @@
       </p:sp>
       <p:sp>
         <p:nvSpPr>
-          <p:cNvPr id="29" name="TextBox 28"/>
+          <p:cNvPr id="30" name="TextBox 29"/>
           <p:cNvSpPr txBox="1"/>
           <p:nvPr/>
         </p:nvSpPr>
@@ -15403,7 +15523,7 @@
       </p:sp>
       <p:sp>
         <p:nvSpPr>
-          <p:cNvPr id="30" name="Rectangle 29"/>
+          <p:cNvPr id="31" name="Rectangle 30"/>
           <p:cNvSpPr/>
           <p:nvPr/>
         </p:nvSpPr>
@@ -15446,7 +15566,7 @@
       </p:sp>
       <p:sp>
         <p:nvSpPr>
-          <p:cNvPr id="31" name="TextBox 30"/>
+          <p:cNvPr id="32" name="TextBox 31"/>
           <p:cNvSpPr txBox="1"/>
           <p:nvPr/>
         </p:nvSpPr>
@@ -15488,7 +15608,7 @@
       </p:sp>
       <p:sp>
         <p:nvSpPr>
-          <p:cNvPr id="32" name="Rectangle 31"/>
+          <p:cNvPr id="33" name="Rectangle 32"/>
           <p:cNvSpPr/>
           <p:nvPr/>
         </p:nvSpPr>
@@ -15505,7 +15625,7 @@
           </a:solidFill>
           <a:ln w="5080">
             <a:solidFill>
-              <a:srgbClr val="D0D8DD"/>
+              <a:srgbClr val="D0D8D9"/>
             </a:solidFill>
           </a:ln>
         </p:spPr>
@@ -15533,7 +15653,7 @@
       </p:sp>
       <p:sp>
         <p:nvSpPr>
-          <p:cNvPr id="33" name="Rectangle 32"/>
+          <p:cNvPr id="34" name="Rectangle 33"/>
           <p:cNvSpPr/>
           <p:nvPr/>
         </p:nvSpPr>
@@ -15576,7 +15696,7 @@
       </p:sp>
       <p:sp>
         <p:nvSpPr>
-          <p:cNvPr id="34" name="TextBox 33"/>
+          <p:cNvPr id="35" name="TextBox 34"/>
           <p:cNvSpPr txBox="1"/>
           <p:nvPr/>
         </p:nvSpPr>
@@ -15618,7 +15738,7 @@
       </p:sp>
       <p:sp>
         <p:nvSpPr>
-          <p:cNvPr id="35" name="Rectangle 34"/>
+          <p:cNvPr id="36" name="Rectangle 35"/>
           <p:cNvSpPr/>
           <p:nvPr/>
         </p:nvSpPr>
@@ -15635,7 +15755,7 @@
           </a:solidFill>
           <a:ln w="3810">
             <a:solidFill>
-              <a:srgbClr val="D0D8DD"/>
+              <a:srgbClr val="D0D8D9"/>
             </a:solidFill>
           </a:ln>
         </p:spPr>
@@ -15663,7 +15783,7 @@
       </p:sp>
       <p:sp>
         <p:nvSpPr>
-          <p:cNvPr id="36" name="TextBox 35"/>
+          <p:cNvPr id="37" name="TextBox 36"/>
           <p:cNvSpPr txBox="1"/>
           <p:nvPr/>
         </p:nvSpPr>
@@ -15705,7 +15825,7 @@
       </p:sp>
       <p:sp>
         <p:nvSpPr>
-          <p:cNvPr id="37" name="TextBox 36"/>
+          <p:cNvPr id="38" name="TextBox 37"/>
           <p:cNvSpPr txBox="1"/>
           <p:nvPr/>
         </p:nvSpPr>
@@ -15747,7 +15867,7 @@
       </p:sp>
       <p:sp>
         <p:nvSpPr>
-          <p:cNvPr id="38" name="Rectangle 37"/>
+          <p:cNvPr id="39" name="Rectangle 38"/>
           <p:cNvSpPr/>
           <p:nvPr/>
         </p:nvSpPr>
@@ -15764,7 +15884,7 @@
           </a:solidFill>
           <a:ln w="3810">
             <a:solidFill>
-              <a:srgbClr val="D0D8DD"/>
+              <a:srgbClr val="D0D8D9"/>
             </a:solidFill>
           </a:ln>
         </p:spPr>
@@ -15792,7 +15912,7 @@
       </p:sp>
       <p:sp>
         <p:nvSpPr>
-          <p:cNvPr id="39" name="TextBox 38"/>
+          <p:cNvPr id="40" name="TextBox 39"/>
           <p:cNvSpPr txBox="1"/>
           <p:nvPr/>
         </p:nvSpPr>
@@ -15834,7 +15954,7 @@
       </p:sp>
       <p:sp>
         <p:nvSpPr>
-          <p:cNvPr id="40" name="TextBox 39"/>
+          <p:cNvPr id="41" name="TextBox 40"/>
           <p:cNvSpPr txBox="1"/>
           <p:nvPr/>
         </p:nvSpPr>
@@ -15876,7 +15996,7 @@
       </p:sp>
       <p:sp>
         <p:nvSpPr>
-          <p:cNvPr id="41" name="Rectangle 40"/>
+          <p:cNvPr id="42" name="Rectangle 41"/>
           <p:cNvSpPr/>
           <p:nvPr/>
         </p:nvSpPr>
@@ -15893,7 +16013,7 @@
           </a:solidFill>
           <a:ln w="3810">
             <a:solidFill>
-              <a:srgbClr val="D0D8DD"/>
+              <a:srgbClr val="D0D8D9"/>
             </a:solidFill>
           </a:ln>
         </p:spPr>
@@ -15921,7 +16041,7 @@
       </p:sp>
       <p:sp>
         <p:nvSpPr>
-          <p:cNvPr id="42" name="TextBox 41"/>
+          <p:cNvPr id="43" name="TextBox 42"/>
           <p:cNvSpPr txBox="1"/>
           <p:nvPr/>
         </p:nvSpPr>
@@ -15963,7 +16083,7 @@
       </p:sp>
       <p:sp>
         <p:nvSpPr>
-          <p:cNvPr id="43" name="TextBox 42"/>
+          <p:cNvPr id="44" name="TextBox 43"/>
           <p:cNvSpPr txBox="1"/>
           <p:nvPr/>
         </p:nvSpPr>
@@ -16005,7 +16125,7 @@
       </p:sp>
       <p:sp>
         <p:nvSpPr>
-          <p:cNvPr id="44" name="Rectangle 43"/>
+          <p:cNvPr id="45" name="Rectangle 44"/>
           <p:cNvSpPr/>
           <p:nvPr/>
         </p:nvSpPr>
@@ -16022,7 +16142,7 @@
           </a:solidFill>
           <a:ln w="5080">
             <a:solidFill>
-              <a:srgbClr val="D0D8DD"/>
+              <a:srgbClr val="D0D8D9"/>
             </a:solidFill>
           </a:ln>
         </p:spPr>
@@ -16050,7 +16170,7 @@
       </p:sp>
       <p:sp>
         <p:nvSpPr>
-          <p:cNvPr id="45" name="Rectangle 44"/>
+          <p:cNvPr id="46" name="Rectangle 45"/>
           <p:cNvSpPr/>
           <p:nvPr/>
         </p:nvSpPr>
@@ -16093,7 +16213,7 @@
       </p:sp>
       <p:sp>
         <p:nvSpPr>
-          <p:cNvPr id="46" name="TextBox 45"/>
+          <p:cNvPr id="47" name="TextBox 46"/>
           <p:cNvSpPr txBox="1"/>
           <p:nvPr/>
         </p:nvSpPr>
@@ -16135,7 +16255,7 @@
       </p:sp>
       <p:sp>
         <p:nvSpPr>
-          <p:cNvPr id="47" name="Rectangle 46"/>
+          <p:cNvPr id="48" name="Rectangle 47"/>
           <p:cNvSpPr/>
           <p:nvPr/>
         </p:nvSpPr>
@@ -16152,7 +16272,7 @@
           </a:solidFill>
           <a:ln w="3810">
             <a:solidFill>
-              <a:srgbClr val="D0D8DD"/>
+              <a:srgbClr val="D0D8D9"/>
             </a:solidFill>
           </a:ln>
         </p:spPr>
@@ -16180,7 +16300,7 @@
       </p:sp>
       <p:sp>
         <p:nvSpPr>
-          <p:cNvPr id="48" name="TextBox 47"/>
+          <p:cNvPr id="49" name="TextBox 48"/>
           <p:cNvSpPr txBox="1"/>
           <p:nvPr/>
         </p:nvSpPr>
@@ -16222,7 +16342,7 @@
       </p:sp>
       <p:sp>
         <p:nvSpPr>
-          <p:cNvPr id="49" name="TextBox 48"/>
+          <p:cNvPr id="50" name="TextBox 49"/>
           <p:cNvSpPr txBox="1"/>
           <p:nvPr/>
         </p:nvSpPr>
@@ -16264,7 +16384,7 @@
       </p:sp>
       <p:sp>
         <p:nvSpPr>
-          <p:cNvPr id="50" name="Rectangle 49"/>
+          <p:cNvPr id="51" name="Rectangle 50"/>
           <p:cNvSpPr/>
           <p:nvPr/>
         </p:nvSpPr>
@@ -16281,7 +16401,7 @@
           </a:solidFill>
           <a:ln w="3810">
             <a:solidFill>
-              <a:srgbClr val="D0D8DD"/>
+              <a:srgbClr val="D0D8D9"/>
             </a:solidFill>
           </a:ln>
         </p:spPr>
@@ -16309,7 +16429,7 @@
       </p:sp>
       <p:sp>
         <p:nvSpPr>
-          <p:cNvPr id="51" name="TextBox 50"/>
+          <p:cNvPr id="52" name="TextBox 51"/>
           <p:cNvSpPr txBox="1"/>
           <p:nvPr/>
         </p:nvSpPr>
@@ -16351,7 +16471,7 @@
       </p:sp>
       <p:sp>
         <p:nvSpPr>
-          <p:cNvPr id="52" name="TextBox 51"/>
+          <p:cNvPr id="53" name="TextBox 52"/>
           <p:cNvSpPr txBox="1"/>
           <p:nvPr/>
         </p:nvSpPr>
@@ -16393,7 +16513,7 @@
       </p:sp>
       <p:sp>
         <p:nvSpPr>
-          <p:cNvPr id="53" name="Rectangle 52"/>
+          <p:cNvPr id="54" name="Rectangle 53"/>
           <p:cNvSpPr/>
           <p:nvPr/>
         </p:nvSpPr>
@@ -16410,7 +16530,7 @@
           </a:solidFill>
           <a:ln w="3810">
             <a:solidFill>
-              <a:srgbClr val="D0D8DD"/>
+              <a:srgbClr val="D0D8D9"/>
             </a:solidFill>
           </a:ln>
         </p:spPr>
@@ -16438,7 +16558,7 @@
       </p:sp>
       <p:sp>
         <p:nvSpPr>
-          <p:cNvPr id="54" name="TextBox 53"/>
+          <p:cNvPr id="55" name="TextBox 54"/>
           <p:cNvSpPr txBox="1"/>
           <p:nvPr/>
         </p:nvSpPr>
@@ -16480,7 +16600,7 @@
       </p:sp>
       <p:sp>
         <p:nvSpPr>
-          <p:cNvPr id="55" name="TextBox 54"/>
+          <p:cNvPr id="56" name="TextBox 55"/>
           <p:cNvSpPr txBox="1"/>
           <p:nvPr/>
         </p:nvSpPr>
@@ -16522,7 +16642,7 @@
       </p:sp>
       <p:sp>
         <p:nvSpPr>
-          <p:cNvPr id="56" name="Rectangle 55"/>
+          <p:cNvPr id="57" name="Rectangle 56"/>
           <p:cNvSpPr/>
           <p:nvPr/>
         </p:nvSpPr>
@@ -16539,7 +16659,7 @@
           </a:solidFill>
           <a:ln w="5080">
             <a:solidFill>
-              <a:srgbClr val="D0D8DD"/>
+              <a:srgbClr val="D0D8D9"/>
             </a:solidFill>
           </a:ln>
         </p:spPr>
@@ -16567,7 +16687,7 @@
       </p:sp>
       <p:sp>
         <p:nvSpPr>
-          <p:cNvPr id="57" name="Rectangle 56"/>
+          <p:cNvPr id="58" name="Rectangle 57"/>
           <p:cNvSpPr/>
           <p:nvPr/>
         </p:nvSpPr>
@@ -16610,7 +16730,7 @@
       </p:sp>
       <p:sp>
         <p:nvSpPr>
-          <p:cNvPr id="58" name="TextBox 57"/>
+          <p:cNvPr id="59" name="TextBox 58"/>
           <p:cNvSpPr txBox="1"/>
           <p:nvPr/>
         </p:nvSpPr>
@@ -16652,7 +16772,7 @@
       </p:sp>
       <p:sp>
         <p:nvSpPr>
-          <p:cNvPr id="59" name="Rectangle 58"/>
+          <p:cNvPr id="60" name="Rectangle 59"/>
           <p:cNvSpPr/>
           <p:nvPr/>
         </p:nvSpPr>
@@ -16669,7 +16789,7 @@
           </a:solidFill>
           <a:ln w="3810">
             <a:solidFill>
-              <a:srgbClr val="D0D8DD"/>
+              <a:srgbClr val="D0D8D9"/>
             </a:solidFill>
           </a:ln>
         </p:spPr>
@@ -16697,7 +16817,7 @@
       </p:sp>
       <p:sp>
         <p:nvSpPr>
-          <p:cNvPr id="60" name="TextBox 59"/>
+          <p:cNvPr id="61" name="TextBox 60"/>
           <p:cNvSpPr txBox="1"/>
           <p:nvPr/>
         </p:nvSpPr>
@@ -16739,7 +16859,7 @@
       </p:sp>
       <p:sp>
         <p:nvSpPr>
-          <p:cNvPr id="61" name="TextBox 60"/>
+          <p:cNvPr id="62" name="TextBox 61"/>
           <p:cNvSpPr txBox="1"/>
           <p:nvPr/>
         </p:nvSpPr>
@@ -16781,7 +16901,7 @@
       </p:sp>
       <p:sp>
         <p:nvSpPr>
-          <p:cNvPr id="62" name="Rectangle 61"/>
+          <p:cNvPr id="63" name="Rectangle 62"/>
           <p:cNvSpPr/>
           <p:nvPr/>
         </p:nvSpPr>
@@ -16798,7 +16918,7 @@
           </a:solidFill>
           <a:ln w="3810">
             <a:solidFill>
-              <a:srgbClr val="D0D8DD"/>
+              <a:srgbClr val="D0D8D9"/>
             </a:solidFill>
           </a:ln>
         </p:spPr>
@@ -16826,7 +16946,7 @@
       </p:sp>
       <p:sp>
         <p:nvSpPr>
-          <p:cNvPr id="63" name="TextBox 62"/>
+          <p:cNvPr id="64" name="TextBox 63"/>
           <p:cNvSpPr txBox="1"/>
           <p:nvPr/>
         </p:nvSpPr>
@@ -16868,7 +16988,7 @@
       </p:sp>
       <p:sp>
         <p:nvSpPr>
-          <p:cNvPr id="64" name="TextBox 63"/>
+          <p:cNvPr id="65" name="TextBox 64"/>
           <p:cNvSpPr txBox="1"/>
           <p:nvPr/>
         </p:nvSpPr>
@@ -16910,7 +17030,7 @@
       </p:sp>
       <p:sp>
         <p:nvSpPr>
-          <p:cNvPr id="65" name="Rectangle 64"/>
+          <p:cNvPr id="66" name="Rectangle 65"/>
           <p:cNvSpPr/>
           <p:nvPr/>
         </p:nvSpPr>
@@ -16927,7 +17047,7 @@
           </a:solidFill>
           <a:ln w="3810">
             <a:solidFill>
-              <a:srgbClr val="D0D8DD"/>
+              <a:srgbClr val="D0D8D9"/>
             </a:solidFill>
           </a:ln>
         </p:spPr>
@@ -16955,7 +17075,7 @@
       </p:sp>
       <p:sp>
         <p:nvSpPr>
-          <p:cNvPr id="66" name="TextBox 65"/>
+          <p:cNvPr id="67" name="TextBox 66"/>
           <p:cNvSpPr txBox="1"/>
           <p:nvPr/>
         </p:nvSpPr>
@@ -16997,7 +17117,7 @@
       </p:sp>
       <p:sp>
         <p:nvSpPr>
-          <p:cNvPr id="67" name="TextBox 66"/>
+          <p:cNvPr id="68" name="TextBox 67"/>
           <p:cNvSpPr txBox="1"/>
           <p:nvPr/>
         </p:nvSpPr>
@@ -17039,7 +17159,7 @@
       </p:sp>
       <p:sp>
         <p:nvSpPr>
-          <p:cNvPr id="68" name="Rectangle 67"/>
+          <p:cNvPr id="69" name="Rectangle 68"/>
           <p:cNvSpPr/>
           <p:nvPr/>
         </p:nvSpPr>
@@ -17056,7 +17176,7 @@
           </a:solidFill>
           <a:ln w="5080">
             <a:solidFill>
-              <a:srgbClr val="D0D8DD"/>
+              <a:srgbClr val="D0D8D9"/>
             </a:solidFill>
           </a:ln>
         </p:spPr>
@@ -17084,7 +17204,7 @@
       </p:sp>
       <p:sp>
         <p:nvSpPr>
-          <p:cNvPr id="69" name="Rectangle 68"/>
+          <p:cNvPr id="70" name="Rectangle 69"/>
           <p:cNvSpPr/>
           <p:nvPr/>
         </p:nvSpPr>
@@ -17127,7 +17247,7 @@
       </p:sp>
       <p:sp>
         <p:nvSpPr>
-          <p:cNvPr id="70" name="TextBox 69"/>
+          <p:cNvPr id="71" name="TextBox 70"/>
           <p:cNvSpPr txBox="1"/>
           <p:nvPr/>
         </p:nvSpPr>
@@ -17169,7 +17289,7 @@
       </p:sp>
       <p:sp>
         <p:nvSpPr>
-          <p:cNvPr id="71" name="Rectangle 70"/>
+          <p:cNvPr id="72" name="Rectangle 71"/>
           <p:cNvSpPr/>
           <p:nvPr/>
         </p:nvSpPr>
@@ -17186,7 +17306,7 @@
           </a:solidFill>
           <a:ln w="3810">
             <a:solidFill>
-              <a:srgbClr val="D0D8DD"/>
+              <a:srgbClr val="D0D8D9"/>
             </a:solidFill>
           </a:ln>
         </p:spPr>
@@ -17214,7 +17334,7 @@
       </p:sp>
       <p:sp>
         <p:nvSpPr>
-          <p:cNvPr id="72" name="TextBox 71"/>
+          <p:cNvPr id="73" name="TextBox 72"/>
           <p:cNvSpPr txBox="1"/>
           <p:nvPr/>
         </p:nvSpPr>
@@ -17256,7 +17376,7 @@
       </p:sp>
       <p:sp>
         <p:nvSpPr>
-          <p:cNvPr id="73" name="TextBox 72"/>
+          <p:cNvPr id="74" name="TextBox 73"/>
           <p:cNvSpPr txBox="1"/>
           <p:nvPr/>
         </p:nvSpPr>
@@ -17298,7 +17418,7 @@
       </p:sp>
       <p:sp>
         <p:nvSpPr>
-          <p:cNvPr id="74" name="Rectangle 73"/>
+          <p:cNvPr id="75" name="Rectangle 74"/>
           <p:cNvSpPr/>
           <p:nvPr/>
         </p:nvSpPr>
@@ -17315,7 +17435,7 @@
           </a:solidFill>
           <a:ln w="3810">
             <a:solidFill>
-              <a:srgbClr val="D0D8DD"/>
+              <a:srgbClr val="D0D8D9"/>
             </a:solidFill>
           </a:ln>
         </p:spPr>
@@ -17343,7 +17463,7 @@
       </p:sp>
       <p:sp>
         <p:nvSpPr>
-          <p:cNvPr id="75" name="TextBox 74"/>
+          <p:cNvPr id="76" name="TextBox 75"/>
           <p:cNvSpPr txBox="1"/>
           <p:nvPr/>
         </p:nvSpPr>
@@ -17385,7 +17505,7 @@
       </p:sp>
       <p:sp>
         <p:nvSpPr>
-          <p:cNvPr id="76" name="TextBox 75"/>
+          <p:cNvPr id="77" name="TextBox 76"/>
           <p:cNvSpPr txBox="1"/>
           <p:nvPr/>
         </p:nvSpPr>
@@ -17427,7 +17547,7 @@
       </p:sp>
       <p:sp>
         <p:nvSpPr>
-          <p:cNvPr id="77" name="Rectangle 76"/>
+          <p:cNvPr id="78" name="Rectangle 77"/>
           <p:cNvSpPr/>
           <p:nvPr/>
         </p:nvSpPr>
@@ -17444,7 +17564,7 @@
           </a:solidFill>
           <a:ln w="3810">
             <a:solidFill>
-              <a:srgbClr val="D0D8DD"/>
+              <a:srgbClr val="D0D8D9"/>
             </a:solidFill>
           </a:ln>
         </p:spPr>
@@ -17472,7 +17592,7 @@
       </p:sp>
       <p:sp>
         <p:nvSpPr>
-          <p:cNvPr id="78" name="TextBox 77"/>
+          <p:cNvPr id="79" name="TextBox 78"/>
           <p:cNvSpPr txBox="1"/>
           <p:nvPr/>
         </p:nvSpPr>
@@ -17514,7 +17634,7 @@
       </p:sp>
       <p:sp>
         <p:nvSpPr>
-          <p:cNvPr id="79" name="TextBox 78"/>
+          <p:cNvPr id="80" name="TextBox 79"/>
           <p:cNvSpPr txBox="1"/>
           <p:nvPr/>
         </p:nvSpPr>
@@ -17556,7 +17676,7 @@
       </p:sp>
       <p:sp>
         <p:nvSpPr>
-          <p:cNvPr id="80" name="Rectangle 79"/>
+          <p:cNvPr id="81" name="Rectangle 80"/>
           <p:cNvSpPr/>
           <p:nvPr/>
         </p:nvSpPr>
@@ -17569,7 +17689,7 @@
             <a:avLst/>
           </a:prstGeom>
           <a:solidFill>
-            <a:srgbClr val="D0D8DD"/>
+            <a:srgbClr val="D0D8D9"/>
           </a:solidFill>
           <a:ln>
             <a:noFill/>
@@ -17599,7 +17719,7 @@
       </p:sp>
       <p:sp>
         <p:nvSpPr>
-          <p:cNvPr id="81" name="TextBox 80"/>
+          <p:cNvPr id="82" name="TextBox 81"/>
           <p:cNvSpPr txBox="1"/>
           <p:nvPr/>
         </p:nvSpPr>
@@ -17759,7 +17879,7 @@
         <p:spPr>
           <a:xfrm>
             <a:off x="457200" y="402336"/>
-            <a:ext cx="10972800" cy="164592"/>
+            <a:ext cx="10058400" cy="164592"/>
           </a:xfrm>
           <a:prstGeom prst="rect">
             <a:avLst/>
@@ -17792,9 +17912,33 @@
           </a:p>
         </p:txBody>
       </p:sp>
-      <p:sp>
-        <p:nvSpPr>
-          <p:cNvPr id="5" name="Rectangle 4"/>
+      <p:pic>
+        <p:nvPicPr>
+          <p:cNvPr id="5" name="Picture 4" descr="sih_logo.png"/>
+          <p:cNvPicPr>
+            <a:picLocks noChangeAspect="1"/>
+          </p:cNvPicPr>
+          <p:nvPr/>
+        </p:nvPicPr>
+        <p:blipFill>
+          <a:blip r:embed="rId2"/>
+          <a:stretch>
+            <a:fillRect/>
+          </a:stretch>
+        </p:blipFill>
+        <p:spPr>
+          <a:xfrm>
+            <a:off x="10698480" y="36576"/>
+            <a:ext cx="1216152" cy="566928"/>
+          </a:xfrm>
+          <a:prstGeom prst="rect">
+            <a:avLst/>
+          </a:prstGeom>
+        </p:spPr>
+      </p:pic>
+      <p:sp>
+        <p:nvSpPr>
+          <p:cNvPr id="6" name="Rectangle 5"/>
           <p:cNvSpPr/>
           <p:nvPr/>
         </p:nvSpPr>
@@ -17807,7 +17951,7 @@
             <a:avLst/>
           </a:prstGeom>
           <a:solidFill>
-            <a:srgbClr val="D0D8DD"/>
+            <a:srgbClr val="D0D8D9"/>
           </a:solidFill>
           <a:ln>
             <a:noFill/>
@@ -17837,7 +17981,7 @@
       </p:sp>
       <p:sp>
         <p:nvSpPr>
-          <p:cNvPr id="6" name="Rectangle 5"/>
+          <p:cNvPr id="7" name="Rectangle 6"/>
           <p:cNvSpPr/>
           <p:nvPr/>
         </p:nvSpPr>
@@ -17880,7 +18024,7 @@
       </p:sp>
       <p:sp>
         <p:nvSpPr>
-          <p:cNvPr id="7" name="TextBox 6"/>
+          <p:cNvPr id="8" name="TextBox 7"/>
           <p:cNvSpPr txBox="1"/>
           <p:nvPr/>
         </p:nvSpPr>
@@ -17922,7 +18066,7 @@
       </p:sp>
       <p:sp>
         <p:nvSpPr>
-          <p:cNvPr id="8" name="Rectangle 7"/>
+          <p:cNvPr id="9" name="Rectangle 8"/>
           <p:cNvSpPr/>
           <p:nvPr/>
         </p:nvSpPr>
@@ -17939,7 +18083,7 @@
           </a:solidFill>
           <a:ln w="5080">
             <a:solidFill>
-              <a:srgbClr val="D0D8DD"/>
+              <a:srgbClr val="D0D8D9"/>
             </a:solidFill>
           </a:ln>
         </p:spPr>
@@ -17967,7 +18111,7 @@
       </p:sp>
       <p:sp>
         <p:nvSpPr>
-          <p:cNvPr id="9" name="Rectangle 8"/>
+          <p:cNvPr id="10" name="Rectangle 9"/>
           <p:cNvSpPr/>
           <p:nvPr/>
         </p:nvSpPr>
@@ -17984,7 +18128,7 @@
           </a:solidFill>
           <a:ln w="3810">
             <a:solidFill>
-              <a:srgbClr val="D0D8DD"/>
+              <a:srgbClr val="D0D8D9"/>
             </a:solidFill>
           </a:ln>
         </p:spPr>
@@ -18012,7 +18156,7 @@
       </p:sp>
       <p:sp>
         <p:nvSpPr>
-          <p:cNvPr id="10" name="TextBox 9"/>
+          <p:cNvPr id="11" name="TextBox 10"/>
           <p:cNvSpPr txBox="1"/>
           <p:nvPr/>
         </p:nvSpPr>
@@ -18054,7 +18198,7 @@
       </p:sp>
       <p:sp>
         <p:nvSpPr>
-          <p:cNvPr id="11" name="TextBox 10"/>
+          <p:cNvPr id="12" name="TextBox 11"/>
           <p:cNvSpPr txBox="1"/>
           <p:nvPr/>
         </p:nvSpPr>
@@ -18096,7 +18240,7 @@
       </p:sp>
       <p:sp>
         <p:nvSpPr>
-          <p:cNvPr id="12" name="Rectangle 11"/>
+          <p:cNvPr id="13" name="Rectangle 12"/>
           <p:cNvSpPr/>
           <p:nvPr/>
         </p:nvSpPr>
@@ -18113,7 +18257,7 @@
           </a:solidFill>
           <a:ln w="3810">
             <a:solidFill>
-              <a:srgbClr val="D0D8DD"/>
+              <a:srgbClr val="D0D8D9"/>
             </a:solidFill>
           </a:ln>
         </p:spPr>
@@ -18141,7 +18285,7 @@
       </p:sp>
       <p:sp>
         <p:nvSpPr>
-          <p:cNvPr id="13" name="TextBox 12"/>
+          <p:cNvPr id="14" name="TextBox 13"/>
           <p:cNvSpPr txBox="1"/>
           <p:nvPr/>
         </p:nvSpPr>
@@ -18183,7 +18327,7 @@
       </p:sp>
       <p:sp>
         <p:nvSpPr>
-          <p:cNvPr id="14" name="TextBox 13"/>
+          <p:cNvPr id="15" name="TextBox 14"/>
           <p:cNvSpPr txBox="1"/>
           <p:nvPr/>
         </p:nvSpPr>
@@ -18225,7 +18369,7 @@
       </p:sp>
       <p:sp>
         <p:nvSpPr>
-          <p:cNvPr id="15" name="Rectangle 14"/>
+          <p:cNvPr id="16" name="Rectangle 15"/>
           <p:cNvSpPr/>
           <p:nvPr/>
         </p:nvSpPr>
@@ -18242,7 +18386,7 @@
           </a:solidFill>
           <a:ln w="3810">
             <a:solidFill>
-              <a:srgbClr val="D0D8DD"/>
+              <a:srgbClr val="D0D8D9"/>
             </a:solidFill>
           </a:ln>
         </p:spPr>
@@ -18270,7 +18414,7 @@
       </p:sp>
       <p:sp>
         <p:nvSpPr>
-          <p:cNvPr id="16" name="TextBox 15"/>
+          <p:cNvPr id="17" name="TextBox 16"/>
           <p:cNvSpPr txBox="1"/>
           <p:nvPr/>
         </p:nvSpPr>
@@ -18312,7 +18456,7 @@
       </p:sp>
       <p:sp>
         <p:nvSpPr>
-          <p:cNvPr id="17" name="TextBox 16"/>
+          <p:cNvPr id="18" name="TextBox 17"/>
           <p:cNvSpPr txBox="1"/>
           <p:nvPr/>
         </p:nvSpPr>
@@ -18354,7 +18498,7 @@
       </p:sp>
       <p:sp>
         <p:nvSpPr>
-          <p:cNvPr id="18" name="Rectangle 17"/>
+          <p:cNvPr id="19" name="Rectangle 18"/>
           <p:cNvSpPr/>
           <p:nvPr/>
         </p:nvSpPr>
@@ -18371,7 +18515,7 @@
           </a:solidFill>
           <a:ln w="3810">
             <a:solidFill>
-              <a:srgbClr val="D0D8DD"/>
+              <a:srgbClr val="D0D8D9"/>
             </a:solidFill>
           </a:ln>
         </p:spPr>
@@ -18399,7 +18543,7 @@
       </p:sp>
       <p:sp>
         <p:nvSpPr>
-          <p:cNvPr id="19" name="TextBox 18"/>
+          <p:cNvPr id="20" name="TextBox 19"/>
           <p:cNvSpPr txBox="1"/>
           <p:nvPr/>
         </p:nvSpPr>
@@ -18441,7 +18585,7 @@
       </p:sp>
       <p:sp>
         <p:nvSpPr>
-          <p:cNvPr id="20" name="TextBox 19"/>
+          <p:cNvPr id="21" name="TextBox 20"/>
           <p:cNvSpPr txBox="1"/>
           <p:nvPr/>
         </p:nvSpPr>
@@ -18483,7 +18627,7 @@
       </p:sp>
       <p:sp>
         <p:nvSpPr>
-          <p:cNvPr id="21" name="Rectangle 20"/>
+          <p:cNvPr id="22" name="Rectangle 21"/>
           <p:cNvSpPr/>
           <p:nvPr/>
         </p:nvSpPr>
@@ -18526,7 +18670,7 @@
       </p:sp>
       <p:sp>
         <p:nvSpPr>
-          <p:cNvPr id="22" name="TextBox 21"/>
+          <p:cNvPr id="23" name="TextBox 22"/>
           <p:cNvSpPr txBox="1"/>
           <p:nvPr/>
         </p:nvSpPr>
@@ -18568,7 +18712,7 @@
       </p:sp>
       <p:sp>
         <p:nvSpPr>
-          <p:cNvPr id="23" name="Rectangle 22"/>
+          <p:cNvPr id="24" name="Rectangle 23"/>
           <p:cNvSpPr/>
           <p:nvPr/>
         </p:nvSpPr>
@@ -18585,7 +18729,7 @@
           </a:solidFill>
           <a:ln w="5080">
             <a:solidFill>
-              <a:srgbClr val="D0D8DD"/>
+              <a:srgbClr val="D0D8D9"/>
             </a:solidFill>
           </a:ln>
         </p:spPr>
@@ -18613,7 +18757,7 @@
       </p:sp>
       <p:sp>
         <p:nvSpPr>
-          <p:cNvPr id="24" name="Rectangle 23"/>
+          <p:cNvPr id="25" name="Rectangle 24"/>
           <p:cNvSpPr/>
           <p:nvPr/>
         </p:nvSpPr>
@@ -18630,7 +18774,7 @@
           </a:solidFill>
           <a:ln w="3810">
             <a:solidFill>
-              <a:srgbClr val="D0D8DD"/>
+              <a:srgbClr val="D0D8D9"/>
             </a:solidFill>
           </a:ln>
         </p:spPr>
@@ -18658,7 +18802,7 @@
       </p:sp>
       <p:sp>
         <p:nvSpPr>
-          <p:cNvPr id="25" name="TextBox 24"/>
+          <p:cNvPr id="26" name="TextBox 25"/>
           <p:cNvSpPr txBox="1"/>
           <p:nvPr/>
         </p:nvSpPr>
@@ -18700,7 +18844,7 @@
       </p:sp>
       <p:sp>
         <p:nvSpPr>
-          <p:cNvPr id="26" name="TextBox 25"/>
+          <p:cNvPr id="27" name="TextBox 26"/>
           <p:cNvSpPr txBox="1"/>
           <p:nvPr/>
         </p:nvSpPr>
@@ -18727,7 +18871,7 @@
                   <a:srgbClr val="147D77"/>
                 </a:solidFill>
                 <a:latin typeface="Calibri"/>
-                <a:hlinkClick r:id="rId2"/>
+                <a:hlinkClick r:id="rId3"/>
               </a:rPr>
               <a:t>https://github.com/TanukuSai/luna-corr</a:t>
             </a:r>
@@ -18736,7 +18880,7 @@
       </p:sp>
       <p:sp>
         <p:nvSpPr>
-          <p:cNvPr id="27" name="TextBox 26"/>
+          <p:cNvPr id="28" name="TextBox 27"/>
           <p:cNvSpPr txBox="1"/>
           <p:nvPr/>
         </p:nvSpPr>
@@ -18778,7 +18922,7 @@
       </p:sp>
       <p:sp>
         <p:nvSpPr>
-          <p:cNvPr id="28" name="Rectangle 27"/>
+          <p:cNvPr id="29" name="Rectangle 28"/>
           <p:cNvSpPr/>
           <p:nvPr/>
         </p:nvSpPr>
@@ -18795,7 +18939,7 @@
           </a:solidFill>
           <a:ln w="3810">
             <a:solidFill>
-              <a:srgbClr val="D0D8DD"/>
+              <a:srgbClr val="D0D8D9"/>
             </a:solidFill>
           </a:ln>
         </p:spPr>
@@ -18823,7 +18967,7 @@
       </p:sp>
       <p:sp>
         <p:nvSpPr>
-          <p:cNvPr id="29" name="TextBox 28"/>
+          <p:cNvPr id="30" name="TextBox 29"/>
           <p:cNvSpPr txBox="1"/>
           <p:nvPr/>
         </p:nvSpPr>
@@ -18865,7 +19009,7 @@
       </p:sp>
       <p:sp>
         <p:nvSpPr>
-          <p:cNvPr id="30" name="TextBox 29"/>
+          <p:cNvPr id="31" name="TextBox 30"/>
           <p:cNvSpPr txBox="1"/>
           <p:nvPr/>
         </p:nvSpPr>
@@ -18892,7 +19036,7 @@
                   <a:srgbClr val="147D77"/>
                 </a:solidFill>
                 <a:latin typeface="Calibri"/>
-                <a:hlinkClick r:id="rId3"/>
+                <a:hlinkClick r:id="rId4"/>
               </a:rPr>
               <a:t>https://pradan.issdc.gov.in</a:t>
             </a:r>
@@ -18901,7 +19045,7 @@
       </p:sp>
       <p:sp>
         <p:nvSpPr>
-          <p:cNvPr id="31" name="TextBox 30"/>
+          <p:cNvPr id="32" name="TextBox 31"/>
           <p:cNvSpPr txBox="1"/>
           <p:nvPr/>
         </p:nvSpPr>
@@ -18943,7 +19087,7 @@
       </p:sp>
       <p:sp>
         <p:nvSpPr>
-          <p:cNvPr id="32" name="Rectangle 31"/>
+          <p:cNvPr id="33" name="Rectangle 32"/>
           <p:cNvSpPr/>
           <p:nvPr/>
         </p:nvSpPr>
@@ -18960,7 +19104,7 @@
           </a:solidFill>
           <a:ln w="3810">
             <a:solidFill>
-              <a:srgbClr val="D0D8DD"/>
+              <a:srgbClr val="D0D8D9"/>
             </a:solidFill>
           </a:ln>
         </p:spPr>
@@ -18988,7 +19132,7 @@
       </p:sp>
       <p:sp>
         <p:nvSpPr>
-          <p:cNvPr id="33" name="TextBox 32"/>
+          <p:cNvPr id="34" name="TextBox 33"/>
           <p:cNvSpPr txBox="1"/>
           <p:nvPr/>
         </p:nvSpPr>
@@ -19030,7 +19174,7 @@
       </p:sp>
       <p:sp>
         <p:nvSpPr>
-          <p:cNvPr id="34" name="TextBox 33"/>
+          <p:cNvPr id="35" name="TextBox 34"/>
           <p:cNvSpPr txBox="1"/>
           <p:nvPr/>
         </p:nvSpPr>
@@ -19057,7 +19201,7 @@
                   <a:srgbClr val="147D77"/>
                 </a:solidFill>
                 <a:latin typeface="Calibri"/>
-                <a:hlinkClick r:id="rId4"/>
+                <a:hlinkClick r:id="rId5"/>
               </a:rPr>
               <a:t>https://astrogeology.usgs.gov</a:t>
             </a:r>
@@ -19066,7 +19210,7 @@
       </p:sp>
       <p:sp>
         <p:nvSpPr>
-          <p:cNvPr id="35" name="TextBox 34"/>
+          <p:cNvPr id="36" name="TextBox 35"/>
           <p:cNvSpPr txBox="1"/>
           <p:nvPr/>
         </p:nvSpPr>
@@ -19108,7 +19252,7 @@
       </p:sp>
       <p:sp>
         <p:nvSpPr>
-          <p:cNvPr id="36" name="Rectangle 35"/>
+          <p:cNvPr id="37" name="Rectangle 36"/>
           <p:cNvSpPr/>
           <p:nvPr/>
         </p:nvSpPr>
@@ -19125,7 +19269,7 @@
           </a:solidFill>
           <a:ln w="3810">
             <a:solidFill>
-              <a:srgbClr val="D0D8DD"/>
+              <a:srgbClr val="D0D8D9"/>
             </a:solidFill>
           </a:ln>
         </p:spPr>
@@ -19153,7 +19297,7 @@
       </p:sp>
       <p:sp>
         <p:nvSpPr>
-          <p:cNvPr id="37" name="TextBox 36"/>
+          <p:cNvPr id="38" name="TextBox 37"/>
           <p:cNvSpPr txBox="1"/>
           <p:nvPr/>
         </p:nvSpPr>
@@ -19195,7 +19339,7 @@
       </p:sp>
       <p:sp>
         <p:nvSpPr>
-          <p:cNvPr id="38" name="TextBox 37"/>
+          <p:cNvPr id="39" name="TextBox 38"/>
           <p:cNvSpPr txBox="1"/>
           <p:nvPr/>
         </p:nvSpPr>
@@ -19237,7 +19381,7 @@
       </p:sp>
       <p:sp>
         <p:nvSpPr>
-          <p:cNvPr id="39" name="Rectangle 38"/>
+          <p:cNvPr id="40" name="Rectangle 39"/>
           <p:cNvSpPr/>
           <p:nvPr/>
         </p:nvSpPr>
@@ -19280,7 +19424,7 @@
       </p:sp>
       <p:sp>
         <p:nvSpPr>
-          <p:cNvPr id="40" name="TextBox 39"/>
+          <p:cNvPr id="41" name="TextBox 40"/>
           <p:cNvSpPr txBox="1"/>
           <p:nvPr/>
         </p:nvSpPr>
@@ -19322,7 +19466,7 @@
       </p:sp>
       <p:sp>
         <p:nvSpPr>
-          <p:cNvPr id="41" name="Rectangle 40"/>
+          <p:cNvPr id="42" name="Rectangle 41"/>
           <p:cNvSpPr/>
           <p:nvPr/>
         </p:nvSpPr>
@@ -19367,7 +19511,7 @@
       </p:sp>
       <p:sp>
         <p:nvSpPr>
-          <p:cNvPr id="42" name="Rectangle 41"/>
+          <p:cNvPr id="43" name="Rectangle 42"/>
           <p:cNvSpPr/>
           <p:nvPr/>
         </p:nvSpPr>
@@ -19410,7 +19554,7 @@
       </p:sp>
       <p:sp>
         <p:nvSpPr>
-          <p:cNvPr id="43" name="TextBox 42"/>
+          <p:cNvPr id="44" name="TextBox 43"/>
           <p:cNvSpPr txBox="1"/>
           <p:nvPr/>
         </p:nvSpPr>
@@ -19452,7 +19596,7 @@
       </p:sp>
       <p:sp>
         <p:nvSpPr>
-          <p:cNvPr id="44" name="Rectangle 43"/>
+          <p:cNvPr id="45" name="Rectangle 44"/>
           <p:cNvSpPr/>
           <p:nvPr/>
         </p:nvSpPr>
@@ -19469,7 +19613,7 @@
           </a:solidFill>
           <a:ln w="3810">
             <a:solidFill>
-              <a:srgbClr val="D0D8DD"/>
+              <a:srgbClr val="D0D8D9"/>
             </a:solidFill>
           </a:ln>
         </p:spPr>
@@ -19497,7 +19641,7 @@
       </p:sp>
       <p:sp>
         <p:nvSpPr>
-          <p:cNvPr id="45" name="TextBox 44"/>
+          <p:cNvPr id="46" name="TextBox 45"/>
           <p:cNvSpPr txBox="1"/>
           <p:nvPr/>
         </p:nvSpPr>
@@ -19539,7 +19683,7 @@
       </p:sp>
       <p:sp>
         <p:nvSpPr>
-          <p:cNvPr id="46" name="TextBox 45"/>
+          <p:cNvPr id="47" name="TextBox 46"/>
           <p:cNvSpPr txBox="1"/>
           <p:nvPr/>
         </p:nvSpPr>
@@ -19581,7 +19725,7 @@
       </p:sp>
       <p:sp>
         <p:nvSpPr>
-          <p:cNvPr id="47" name="Rectangle 46"/>
+          <p:cNvPr id="48" name="Rectangle 47"/>
           <p:cNvSpPr/>
           <p:nvPr/>
         </p:nvSpPr>
@@ -19598,7 +19742,7 @@
           </a:solidFill>
           <a:ln w="3810">
             <a:solidFill>
-              <a:srgbClr val="D0D8DD"/>
+              <a:srgbClr val="D0D8D9"/>
             </a:solidFill>
           </a:ln>
         </p:spPr>
@@ -19626,7 +19770,7 @@
       </p:sp>
       <p:sp>
         <p:nvSpPr>
-          <p:cNvPr id="48" name="TextBox 47"/>
+          <p:cNvPr id="49" name="TextBox 48"/>
           <p:cNvSpPr txBox="1"/>
           <p:nvPr/>
         </p:nvSpPr>
@@ -19668,7 +19812,7 @@
       </p:sp>
       <p:sp>
         <p:nvSpPr>
-          <p:cNvPr id="49" name="TextBox 48"/>
+          <p:cNvPr id="50" name="TextBox 49"/>
           <p:cNvSpPr txBox="1"/>
           <p:nvPr/>
         </p:nvSpPr>
@@ -19710,7 +19854,7 @@
       </p:sp>
       <p:sp>
         <p:nvSpPr>
-          <p:cNvPr id="50" name="Rectangle 49"/>
+          <p:cNvPr id="51" name="Rectangle 50"/>
           <p:cNvSpPr/>
           <p:nvPr/>
         </p:nvSpPr>
@@ -19727,7 +19871,7 @@
           </a:solidFill>
           <a:ln w="3810">
             <a:solidFill>
-              <a:srgbClr val="D0D8DD"/>
+              <a:srgbClr val="D0D8D9"/>
             </a:solidFill>
           </a:ln>
         </p:spPr>
@@ -19755,7 +19899,7 @@
       </p:sp>
       <p:sp>
         <p:nvSpPr>
-          <p:cNvPr id="51" name="TextBox 50"/>
+          <p:cNvPr id="52" name="TextBox 51"/>
           <p:cNvSpPr txBox="1"/>
           <p:nvPr/>
         </p:nvSpPr>
@@ -19797,7 +19941,7 @@
       </p:sp>
       <p:sp>
         <p:nvSpPr>
-          <p:cNvPr id="52" name="TextBox 51"/>
+          <p:cNvPr id="53" name="TextBox 52"/>
           <p:cNvSpPr txBox="1"/>
           <p:nvPr/>
         </p:nvSpPr>
@@ -19839,7 +19983,7 @@
       </p:sp>
       <p:sp>
         <p:nvSpPr>
-          <p:cNvPr id="53" name="Rectangle 52"/>
+          <p:cNvPr id="54" name="Rectangle 53"/>
           <p:cNvSpPr/>
           <p:nvPr/>
         </p:nvSpPr>
@@ -19884,7 +20028,7 @@
       </p:sp>
       <p:sp>
         <p:nvSpPr>
-          <p:cNvPr id="54" name="Rectangle 53"/>
+          <p:cNvPr id="55" name="Rectangle 54"/>
           <p:cNvSpPr/>
           <p:nvPr/>
         </p:nvSpPr>
@@ -19927,7 +20071,7 @@
       </p:sp>
       <p:sp>
         <p:nvSpPr>
-          <p:cNvPr id="55" name="TextBox 54"/>
+          <p:cNvPr id="56" name="TextBox 55"/>
           <p:cNvSpPr txBox="1"/>
           <p:nvPr/>
         </p:nvSpPr>
@@ -19969,7 +20113,7 @@
       </p:sp>
       <p:sp>
         <p:nvSpPr>
-          <p:cNvPr id="56" name="Rectangle 55"/>
+          <p:cNvPr id="57" name="Rectangle 56"/>
           <p:cNvSpPr/>
           <p:nvPr/>
         </p:nvSpPr>
@@ -19986,7 +20130,7 @@
           </a:solidFill>
           <a:ln w="3810">
             <a:solidFill>
-              <a:srgbClr val="D0D8DD"/>
+              <a:srgbClr val="D0D8D9"/>
             </a:solidFill>
           </a:ln>
         </p:spPr>
@@ -20014,7 +20158,7 @@
       </p:sp>
       <p:sp>
         <p:nvSpPr>
-          <p:cNvPr id="57" name="TextBox 56"/>
+          <p:cNvPr id="58" name="TextBox 57"/>
           <p:cNvSpPr txBox="1"/>
           <p:nvPr/>
         </p:nvSpPr>
@@ -20056,7 +20200,7 @@
       </p:sp>
       <p:sp>
         <p:nvSpPr>
-          <p:cNvPr id="58" name="TextBox 57"/>
+          <p:cNvPr id="59" name="TextBox 58"/>
           <p:cNvSpPr txBox="1"/>
           <p:nvPr/>
         </p:nvSpPr>
@@ -20098,7 +20242,7 @@
       </p:sp>
       <p:sp>
         <p:nvSpPr>
-          <p:cNvPr id="59" name="Rectangle 58"/>
+          <p:cNvPr id="60" name="Rectangle 59"/>
           <p:cNvSpPr/>
           <p:nvPr/>
         </p:nvSpPr>
@@ -20115,7 +20259,7 @@
           </a:solidFill>
           <a:ln w="3810">
             <a:solidFill>
-              <a:srgbClr val="D0D8DD"/>
+              <a:srgbClr val="D0D8D9"/>
             </a:solidFill>
           </a:ln>
         </p:spPr>
@@ -20143,7 +20287,7 @@
       </p:sp>
       <p:sp>
         <p:nvSpPr>
-          <p:cNvPr id="60" name="TextBox 59"/>
+          <p:cNvPr id="61" name="TextBox 60"/>
           <p:cNvSpPr txBox="1"/>
           <p:nvPr/>
         </p:nvSpPr>
@@ -20185,7 +20329,7 @@
       </p:sp>
       <p:sp>
         <p:nvSpPr>
-          <p:cNvPr id="61" name="TextBox 60"/>
+          <p:cNvPr id="62" name="TextBox 61"/>
           <p:cNvSpPr txBox="1"/>
           <p:nvPr/>
         </p:nvSpPr>
@@ -20227,7 +20371,7 @@
       </p:sp>
       <p:sp>
         <p:nvSpPr>
-          <p:cNvPr id="62" name="Rectangle 61"/>
+          <p:cNvPr id="63" name="Rectangle 62"/>
           <p:cNvSpPr/>
           <p:nvPr/>
         </p:nvSpPr>
@@ -20244,7 +20388,7 @@
           </a:solidFill>
           <a:ln w="3810">
             <a:solidFill>
-              <a:srgbClr val="D0D8DD"/>
+              <a:srgbClr val="D0D8D9"/>
             </a:solidFill>
           </a:ln>
         </p:spPr>
@@ -20272,7 +20416,7 @@
       </p:sp>
       <p:sp>
         <p:nvSpPr>
-          <p:cNvPr id="63" name="TextBox 62"/>
+          <p:cNvPr id="64" name="TextBox 63"/>
           <p:cNvSpPr txBox="1"/>
           <p:nvPr/>
         </p:nvSpPr>
@@ -20314,7 +20458,7 @@
       </p:sp>
       <p:sp>
         <p:nvSpPr>
-          <p:cNvPr id="64" name="TextBox 63"/>
+          <p:cNvPr id="65" name="TextBox 64"/>
           <p:cNvSpPr txBox="1"/>
           <p:nvPr/>
         </p:nvSpPr>
@@ -20356,7 +20500,7 @@
       </p:sp>
       <p:sp>
         <p:nvSpPr>
-          <p:cNvPr id="65" name="Rectangle 64"/>
+          <p:cNvPr id="66" name="Rectangle 65"/>
           <p:cNvSpPr/>
           <p:nvPr/>
         </p:nvSpPr>
@@ -20401,7 +20545,7 @@
       </p:sp>
       <p:sp>
         <p:nvSpPr>
-          <p:cNvPr id="66" name="Rectangle 65"/>
+          <p:cNvPr id="67" name="Rectangle 66"/>
           <p:cNvSpPr/>
           <p:nvPr/>
         </p:nvSpPr>
@@ -20444,7 +20588,7 @@
       </p:sp>
       <p:sp>
         <p:nvSpPr>
-          <p:cNvPr id="67" name="TextBox 66"/>
+          <p:cNvPr id="68" name="TextBox 67"/>
           <p:cNvSpPr txBox="1"/>
           <p:nvPr/>
         </p:nvSpPr>
@@ -20486,7 +20630,7 @@
       </p:sp>
       <p:sp>
         <p:nvSpPr>
-          <p:cNvPr id="68" name="Rectangle 67"/>
+          <p:cNvPr id="69" name="Rectangle 68"/>
           <p:cNvSpPr/>
           <p:nvPr/>
         </p:nvSpPr>
@@ -20503,7 +20647,7 @@
           </a:solidFill>
           <a:ln w="3810">
             <a:solidFill>
-              <a:srgbClr val="D0D8DD"/>
+              <a:srgbClr val="D0D8D9"/>
             </a:solidFill>
           </a:ln>
         </p:spPr>
@@ -20531,7 +20675,7 @@
       </p:sp>
       <p:sp>
         <p:nvSpPr>
-          <p:cNvPr id="69" name="TextBox 68"/>
+          <p:cNvPr id="70" name="TextBox 69"/>
           <p:cNvSpPr txBox="1"/>
           <p:nvPr/>
         </p:nvSpPr>
@@ -20573,7 +20717,7 @@
       </p:sp>
       <p:sp>
         <p:nvSpPr>
-          <p:cNvPr id="70" name="TextBox 69"/>
+          <p:cNvPr id="71" name="TextBox 70"/>
           <p:cNvSpPr txBox="1"/>
           <p:nvPr/>
         </p:nvSpPr>
@@ -20615,7 +20759,7 @@
       </p:sp>
       <p:sp>
         <p:nvSpPr>
-          <p:cNvPr id="71" name="Rectangle 70"/>
+          <p:cNvPr id="72" name="Rectangle 71"/>
           <p:cNvSpPr/>
           <p:nvPr/>
         </p:nvSpPr>
@@ -20632,7 +20776,7 @@
           </a:solidFill>
           <a:ln w="3810">
             <a:solidFill>
-              <a:srgbClr val="D0D8DD"/>
+              <a:srgbClr val="D0D8D9"/>
             </a:solidFill>
           </a:ln>
         </p:spPr>
@@ -20660,7 +20804,7 @@
       </p:sp>
       <p:sp>
         <p:nvSpPr>
-          <p:cNvPr id="72" name="TextBox 71"/>
+          <p:cNvPr id="73" name="TextBox 72"/>
           <p:cNvSpPr txBox="1"/>
           <p:nvPr/>
         </p:nvSpPr>
@@ -20702,7 +20846,7 @@
       </p:sp>
       <p:sp>
         <p:nvSpPr>
-          <p:cNvPr id="73" name="TextBox 72"/>
+          <p:cNvPr id="74" name="TextBox 73"/>
           <p:cNvSpPr txBox="1"/>
           <p:nvPr/>
         </p:nvSpPr>
@@ -20744,7 +20888,7 @@
       </p:sp>
       <p:sp>
         <p:nvSpPr>
-          <p:cNvPr id="74" name="Rectangle 73"/>
+          <p:cNvPr id="75" name="Rectangle 74"/>
           <p:cNvSpPr/>
           <p:nvPr/>
         </p:nvSpPr>
@@ -20761,7 +20905,7 @@
           </a:solidFill>
           <a:ln w="3810">
             <a:solidFill>
-              <a:srgbClr val="D0D8DD"/>
+              <a:srgbClr val="D0D8D9"/>
             </a:solidFill>
           </a:ln>
         </p:spPr>
@@ -20789,7 +20933,7 @@
       </p:sp>
       <p:sp>
         <p:nvSpPr>
-          <p:cNvPr id="75" name="TextBox 74"/>
+          <p:cNvPr id="76" name="TextBox 75"/>
           <p:cNvSpPr txBox="1"/>
           <p:nvPr/>
         </p:nvSpPr>
@@ -20831,7 +20975,7 @@
       </p:sp>
       <p:sp>
         <p:nvSpPr>
-          <p:cNvPr id="76" name="TextBox 75"/>
+          <p:cNvPr id="77" name="TextBox 76"/>
           <p:cNvSpPr txBox="1"/>
           <p:nvPr/>
         </p:nvSpPr>
@@ -20873,7 +21017,7 @@
       </p:sp>
       <p:sp>
         <p:nvSpPr>
-          <p:cNvPr id="77" name="Rectangle 76"/>
+          <p:cNvPr id="78" name="Rectangle 77"/>
           <p:cNvSpPr/>
           <p:nvPr/>
         </p:nvSpPr>
@@ -20886,7 +21030,7 @@
             <a:avLst/>
           </a:prstGeom>
           <a:solidFill>
-            <a:srgbClr val="D0D8DD"/>
+            <a:srgbClr val="D0D8D9"/>
           </a:solidFill>
           <a:ln>
             <a:noFill/>
@@ -20916,7 +21060,7 @@
       </p:sp>
       <p:sp>
         <p:nvSpPr>
-          <p:cNvPr id="78" name="TextBox 77"/>
+          <p:cNvPr id="79" name="TextBox 78"/>
           <p:cNvSpPr txBox="1"/>
           <p:nvPr/>
         </p:nvSpPr>

</xml_diff>

<commit_message>
fix(ppt): eliminate clipping of SIH logo on Slide 1 header
</commit_message>
<xml_diff>
--- a/LUNA-CORR_SIH2026_Presentation.pptx
+++ b/LUNA-CORR_SIH2026_Presentation.pptx
@@ -4042,7 +4042,7 @@
         </p:nvSpPr>
         <p:spPr>
           <a:xfrm>
-            <a:off x="4023360" y="201168"/>
+            <a:off x="4023360" y="182880"/>
             <a:ext cx="6537960" cy="201168"/>
           </a:xfrm>
           <a:prstGeom prst="rect">
@@ -4085,7 +4085,7 @@
         </p:nvSpPr>
         <p:spPr>
           <a:xfrm>
-            <a:off x="4096512" y="219456"/>
+            <a:off x="4096512" y="201168"/>
             <a:ext cx="6428232" cy="201168"/>
           </a:xfrm>
           <a:prstGeom prst="rect">
@@ -4135,8 +4135,8 @@
         </p:blipFill>
         <p:spPr>
           <a:xfrm>
-            <a:off x="10698480" y="36576"/>
-            <a:ext cx="1216152" cy="566928"/>
+            <a:off x="10744200" y="73152"/>
+            <a:ext cx="1143000" cy="475488"/>
           </a:xfrm>
           <a:prstGeom prst="rect">
             <a:avLst/>
@@ -4159,8 +4159,8 @@
         </p:blipFill>
         <p:spPr>
           <a:xfrm>
-            <a:off x="4023360" y="457200"/>
-            <a:ext cx="8092440" cy="2606040"/>
+            <a:off x="4023360" y="594360"/>
+            <a:ext cx="8092440" cy="2468880"/>
           </a:xfrm>
           <a:prstGeom prst="rect">
             <a:avLst/>

</xml_diff>